<commit_message>
docs: close on takeaways instead of a thank-you slide
Slide 15 returns to the four measured takeaways. Per-slide timings on
slides 2, 3, 5, 6, 8 and 13 are trimmed by five seconds each to pay for
the longer closer.
</commit_message>
<xml_diff>
--- a/presentation/VERIFACT-Lite-TTU.pptx
+++ b/presentation/VERIFACT-Lite-TTU.pptx
@@ -125,7 +125,7 @@
   <p:extLst>
     <p:ext uri="{521415D9-36F7-43E2-AB2F-B90AF26B5E84}">
       <p14:sectionLst xmlns:p14="http://schemas.microsoft.com/office/powerpoint/2010/main">
-        <p14:section name="Talk" id="{4e5fb88f-4677-3b0a-7740-59439003136b}">
+        <p14:section name="Talk" id="{a71b4084-bc1c-c36a-676d-1ab0264dad6c}">
           <p14:sldIdLst>
             <p14:sldId id="256"/>
             <p14:sldId id="257"/>
@@ -144,7 +144,7 @@
             <p14:sldId id="270"/>
           </p14:sldIdLst>
         </p14:section>
-        <p14:section name="Appendix" id="{991f364b-0046-4d05-777f-c73915b41d9a}">
+        <p14:section name="Appendix" id="{e3824fcf-c566-2718-5d4d-63e6a1177ef3}">
           <p14:sldIdLst>
             <p14:sldId id="271"/>
             <p14:sldId id="272"/>
@@ -1253,7 +1253,7 @@
           <a:p>
             <a:r>
               <a:rPr lang="en-US" dirty="0"/>
-              <a:t>[1:00] Point at the Agreement column, not the numbers. The claim is that the mechanism behaves as described; the claim is explicitly not that the numbers match.</a:t>
+              <a:t>[0:55] Point at the Agreement column, not the numbers. The claim is that the mechanism behaves as described; the claim is explicitly not that the numbers match.</a:t>
             </a:r>
             <a:endParaRPr lang="en-US" dirty="0"/>
           </a:p>
@@ -1429,7 +1429,7 @@
           <a:p>
             <a:r>
               <a:rPr lang="en-US" dirty="0"/>
-              <a:t>[0:05] Leave this up for the questions. If asked to summarise, read point 3 — it is the finding that generalises beyond this paper.</a:t>
+              <a:t>[0:40] Close on points 3 and 4. Point 3 is the finding that generalises beyond this paper. Point 4 is where we corrected ourselves between versions of this talk, which is the honest thing to show. Leave the slide up for the questions.</a:t>
             </a:r>
             <a:endParaRPr lang="en-US" dirty="0"/>
           </a:p>
@@ -1869,7 +1869,7 @@
           <a:p>
             <a:r>
               <a:rPr lang="en-US" dirty="0"/>
-              <a:t>[1:20] This example is the whole paper. Verifying the stripped claim gives a meaningless verdict, because it is not what the answer said. Read the two fact lists side by side, then point at the three numbers: measured on human annotation, not anecdote.</a:t>
+              <a:t>[1:15] This example is the whole paper. Verifying the stripped claim gives a meaningless verdict, because it is not what the answer said. Read the two fact lists side by side, then point at the three numbers: measured on human annotation, not anecdote.</a:t>
             </a:r>
             <a:endParaRPr lang="en-US" dirty="0"/>
           </a:p>
@@ -1957,7 +1957,7 @@
           <a:p>
             <a:r>
               <a:rPr lang="en-US" dirty="0"/>
-              <a:t>[0:50] Three sentences on what the framework is, then the bottom strip: this is what the paper claims. Say explicitly that the bottom row is the paper's, not ours — the rest of the talk is about which of these behaviours survive on free hardware.</a:t>
+              <a:t>[0:45] Three sentences on what the framework is, then the bottom strip: this is what the paper claims. Say explicitly that the bottom row is the paper's, not ours — the rest of the talk is about which of these behaviours survive on free hardware.</a:t>
             </a:r>
             <a:endParaRPr lang="en-US" dirty="0"/>
           </a:p>
@@ -2133,7 +2133,7 @@
           <a:p>
             <a:r>
               <a:rPr lang="en-US" dirty="0"/>
-              <a:t>[1:00] Do not read the table. Say: every paid or large component has a free local stand-in, and the detection logic itself is unchanged. Then the bottom strip — twelve questions written to contain conditions, comparisons and event order, and an answer key written by hand before any run.</a:t>
+              <a:t>[0:55] Do not read the table. Say: every paid or large component has a free local stand-in, and the detection logic itself is unchanged. Then the bottom strip — twelve questions written to contain conditions, comparisons and event order, and an answer key written by hand before any run.</a:t>
             </a:r>
             <a:endParaRPr lang="en-US" dirty="0"/>
           </a:p>
@@ -2221,7 +2221,7 @@
           <a:p>
             <a:r>
               <a:rPr lang="en-US" dirty="0"/>
-              <a:t>[0:55] The key methodological point: the answer is generated once, so baseline and VERIFACT-Lite differ only in whether refinement runs. Read the recall definition out loud — it explains why recall never moves between variants.</a:t>
+              <a:t>[0:50] The key methodological point: the answer is generated once, so baseline and VERIFACT-Lite differ only in whether refinement runs. Read the recall definition out loud — it explains why recall never moves between variants.</a:t>
             </a:r>
             <a:endParaRPr lang="en-US" dirty="0"/>
           </a:p>
@@ -2397,7 +2397,7 @@
           <a:p>
             <a:r>
               <a:rPr lang="en-US" dirty="0"/>
-              <a:t>[0:50] Walk the table once, then read the three card headings only. Each half of the contribution moves its own metric, and the two compose.</a:t>
+              <a:t>[0:45] Walk the table once, then read the three card headings only. Each half of the contribution moves its own metric, and the two compose.</a:t>
             </a:r>
             <a:endParaRPr lang="en-US" dirty="0"/>
           </a:p>
@@ -16859,14 +16859,14 @@
       </p:grpSpPr>
       <p:sp>
         <p:nvSpPr>
-          <p:cNvPr id="2" name="ty"/>
+          <p:cNvPr id="2" name="eyebrow"/>
           <p:cNvSpPr txBox="1"/>
           <p:nvPr/>
         </p:nvSpPr>
         <p:spPr>
           <a:xfrm>
-            <a:off x="685800" y="1371600"/>
-            <a:ext cx="10789920" cy="1097280"/>
+            <a:off x="548640" y="128016"/>
+            <a:ext cx="11064240" cy="256032"/>
           </a:xfrm>
           <a:prstGeom prst="rect">
             <a:avLst/>
@@ -16882,29 +16882,134 @@
               <a:buNone/>
             </a:pPr>
             <a:r>
-              <a:rPr lang="en-US" sz="5400" b="1" dirty="0">
+              <a:rPr lang="en-US" sz="1100" b="1" spc="200" kern="0" dirty="0">
+                <a:solidFill>
+                  <a:srgbClr val="E90802"/>
+                </a:solidFill>
+                <a:latin typeface="Arial" pitchFamily="34" charset="0"/>
+                <a:ea typeface="Arial" pitchFamily="34" charset="-122"/>
+                <a:cs typeface="Arial" pitchFamily="34" charset="-120"/>
+              </a:rPr>
+              <a:t>TAKEAWAYS</a:t>
+            </a:r>
+            <a:endParaRPr lang="en-US" sz="1100" dirty="0"/>
+          </a:p>
+        </p:txBody>
+      </p:sp>
+      <p:sp>
+        <p:nvSpPr>
+          <p:cNvPr id="3" name="title"/>
+          <p:cNvSpPr txBox="1"/>
+          <p:nvPr/>
+        </p:nvSpPr>
+        <p:spPr>
+          <a:xfrm>
+            <a:off x="548640" y="420624"/>
+            <a:ext cx="11064240" cy="658368"/>
+          </a:xfrm>
+          <a:prstGeom prst="rect">
+            <a:avLst/>
+          </a:prstGeom>
+          <a:noFill/>
+          <a:ln/>
+        </p:spPr>
+        <p:txBody>
+          <a:bodyPr wrap="square" lIns="0" tIns="0" rIns="0" bIns="0" rtlCol="0" anchor="ctr"/>
+          <a:lstStyle/>
+          <a:p>
+            <a:pPr indent="0" marL="0">
+              <a:buNone/>
+            </a:pPr>
+            <a:r>
+              <a:rPr lang="en-US" sz="3000" b="1" dirty="0">
                 <a:solidFill>
                   <a:srgbClr val="FFFFFF"/>
                 </a:solidFill>
               </a:rPr>
-              <a:t>THANK YOU</a:t>
+              <a:t>Four things this reimplementation establishes</a:t>
             </a:r>
-            <a:endParaRPr lang="en-US" sz="5400" dirty="0"/>
+            <a:endParaRPr lang="en-US" sz="3000" dirty="0"/>
           </a:p>
         </p:txBody>
       </p:sp>
       <p:sp>
         <p:nvSpPr>
-          <p:cNvPr id="3" name="ty-rule"/>
+          <p:cNvPr id="4" name="subtitle"/>
+          <p:cNvSpPr txBox="1"/>
+          <p:nvPr/>
+        </p:nvSpPr>
+        <p:spPr>
+          <a:xfrm>
+            <a:off x="548640" y="1042416"/>
+            <a:ext cx="11064240" cy="292608"/>
+          </a:xfrm>
+          <a:prstGeom prst="rect">
+            <a:avLst/>
+          </a:prstGeom>
+          <a:noFill/>
+          <a:ln/>
+        </p:spPr>
+        <p:txBody>
+          <a:bodyPr wrap="square" lIns="0" tIns="0" rIns="0" bIns="0" rtlCol="0" anchor="ctr"/>
+          <a:lstStyle/>
+          <a:p>
+            <a:pPr indent="0" marL="0">
+              <a:buNone/>
+            </a:pPr>
+            <a:r>
+              <a:rPr lang="en-US" sz="1500" dirty="0">
+                <a:solidFill>
+                  <a:srgbClr val="EDEDED"/>
+                </a:solidFill>
+                <a:latin typeface="Arial" pitchFamily="34" charset="0"/>
+                <a:ea typeface="Arial" pitchFamily="34" charset="-122"/>
+                <a:cs typeface="Arial" pitchFamily="34" charset="-120"/>
+              </a:rPr>
+              <a:t>Measured by the repository, on 12 questions and three model configurations</a:t>
+            </a:r>
+            <a:endParaRPr lang="en-US" sz="1500" dirty="0"/>
+          </a:p>
+        </p:txBody>
+      </p:sp>
+      <p:sp>
+        <p:nvSpPr>
+          <p:cNvPr id="5" name="tk1"/>
           <p:cNvSpPr/>
           <p:nvPr/>
         </p:nvSpPr>
         <p:spPr>
           <a:xfrm>
-            <a:off x="713232" y="2560320"/>
-            <a:ext cx="2011680" cy="73152"/>
-          </a:xfrm>
-          <a:prstGeom prst="rect">
+            <a:off x="548640" y="1481328"/>
+            <a:ext cx="11064240" cy="969264"/>
+          </a:xfrm>
+          <a:prstGeom prst="roundRect">
+            <a:avLst>
+              <a:gd name="adj" fmla="val 5660"/>
+            </a:avLst>
+          </a:prstGeom>
+          <a:solidFill>
+            <a:srgbClr val="333333"/>
+          </a:solidFill>
+          <a:ln w="12700">
+            <a:solidFill>
+              <a:srgbClr val="333333"/>
+            </a:solidFill>
+            <a:prstDash val="solid"/>
+          </a:ln>
+        </p:spPr>
+      </p:sp>
+      <p:sp>
+        <p:nvSpPr>
+          <p:cNvPr id="6" name="tk-b1"/>
+          <p:cNvSpPr/>
+          <p:nvPr/>
+        </p:nvSpPr>
+        <p:spPr>
+          <a:xfrm>
+            <a:off x="777240" y="1737360"/>
+            <a:ext cx="457200" cy="457200"/>
+          </a:xfrm>
+          <a:prstGeom prst="ellipse">
             <a:avLst/>
           </a:prstGeom>
           <a:solidFill>
@@ -16920,14 +17025,119 @@
       </p:sp>
       <p:sp>
         <p:nvSpPr>
-          <p:cNvPr id="4" name="ty-b1"/>
+          <p:cNvPr id="7" name="tk-n1"/>
+          <p:cNvSpPr txBox="1"/>
+          <p:nvPr/>
+        </p:nvSpPr>
+        <p:spPr>
+          <a:xfrm>
+            <a:off x="777240" y="1737360"/>
+            <a:ext cx="457200" cy="457200"/>
+          </a:xfrm>
+          <a:prstGeom prst="rect">
+            <a:avLst/>
+          </a:prstGeom>
+          <a:noFill/>
+          <a:ln/>
+        </p:spPr>
+        <p:txBody>
+          <a:bodyPr wrap="square" lIns="0" tIns="0" rIns="0" bIns="0" rtlCol="0" anchor="ctr"/>
+          <a:lstStyle/>
+          <a:p>
+            <a:pPr algn="ctr" indent="0" marL="0">
+              <a:buNone/>
+            </a:pPr>
+            <a:r>
+              <a:rPr lang="en-US" sz="1600" b="1" dirty="0">
+                <a:solidFill>
+                  <a:srgbClr val="FFFFFF"/>
+                </a:solidFill>
+              </a:rPr>
+              <a:t>1</a:t>
+            </a:r>
+            <a:endParaRPr lang="en-US" sz="1600" dirty="0"/>
+          </a:p>
+        </p:txBody>
+      </p:sp>
+      <p:sp>
+        <p:nvSpPr>
+          <p:cNvPr id="8" name="tk-t1"/>
+          <p:cNvSpPr txBox="1"/>
+          <p:nvPr/>
+        </p:nvSpPr>
+        <p:spPr>
+          <a:xfrm>
+            <a:off x="1417320" y="1572768"/>
+            <a:ext cx="9966960" cy="786384"/>
+          </a:xfrm>
+          <a:prstGeom prst="rect">
+            <a:avLst/>
+          </a:prstGeom>
+          <a:noFill/>
+          <a:ln/>
+        </p:spPr>
+        <p:txBody>
+          <a:bodyPr wrap="square" lIns="0" tIns="0" rIns="0" bIns="0" rtlCol="0" anchor="ctr"/>
+          <a:lstStyle/>
+          <a:p>
+            <a:pPr indent="0" marL="0">
+              <a:lnSpc>
+                <a:spcPct val="115000"/>
+              </a:lnSpc>
+              <a:buNone/>
+            </a:pPr>
+            <a:r>
+              <a:rPr lang="en-US" sz="1300" dirty="0">
+                <a:solidFill>
+                  <a:srgbClr val="EDEDED"/>
+                </a:solidFill>
+                <a:latin typeface="Arial" pitchFamily="34" charset="0"/>
+                <a:ea typeface="Arial" pitchFamily="34" charset="-122"/>
+                <a:cs typeface="Arial" pitchFamily="34" charset="-120"/>
+              </a:rPr>
+              <a:t>The whole VeriFact pipeline runs on a 4 GB consumer GPU with quantized 3B models, free Wikipedia evidence and no API key — and scales to 7–8B on a free T4.</a:t>
+            </a:r>
+            <a:endParaRPr lang="en-US" sz="1300" dirty="0"/>
+          </a:p>
+        </p:txBody>
+      </p:sp>
+      <p:sp>
+        <p:nvSpPr>
+          <p:cNvPr id="9" name="tk2"/>
           <p:cNvSpPr/>
           <p:nvPr/>
         </p:nvSpPr>
         <p:spPr>
           <a:xfrm>
-            <a:off x="713232" y="3145536"/>
-            <a:ext cx="402336" cy="402336"/>
+            <a:off x="548640" y="2596896"/>
+            <a:ext cx="11064240" cy="969264"/>
+          </a:xfrm>
+          <a:prstGeom prst="roundRect">
+            <a:avLst>
+              <a:gd name="adj" fmla="val 5660"/>
+            </a:avLst>
+          </a:prstGeom>
+          <a:solidFill>
+            <a:srgbClr val="333333"/>
+          </a:solidFill>
+          <a:ln w="12700">
+            <a:solidFill>
+              <a:srgbClr val="333333"/>
+            </a:solidFill>
+            <a:prstDash val="solid"/>
+          </a:ln>
+        </p:spPr>
+      </p:sp>
+      <p:sp>
+        <p:nvSpPr>
+          <p:cNvPr id="10" name="tk-b2"/>
+          <p:cNvSpPr/>
+          <p:nvPr/>
+        </p:nvSpPr>
+        <p:spPr>
+          <a:xfrm>
+            <a:off x="777240" y="2852928"/>
+            <a:ext cx="457200" cy="457200"/>
           </a:xfrm>
           <a:prstGeom prst="ellipse">
             <a:avLst/>
@@ -16945,14 +17155,14 @@
       </p:sp>
       <p:sp>
         <p:nvSpPr>
-          <p:cNvPr id="5" name="ty-n1"/>
+          <p:cNvPr id="11" name="tk-n2"/>
           <p:cNvSpPr txBox="1"/>
           <p:nvPr/>
         </p:nvSpPr>
         <p:spPr>
           <a:xfrm>
-            <a:off x="713232" y="3145536"/>
-            <a:ext cx="402336" cy="402336"/>
+            <a:off x="777240" y="2852928"/>
+            <a:ext cx="457200" cy="457200"/>
           </a:xfrm>
           <a:prstGeom prst="rect">
             <a:avLst/>
@@ -16968,27 +17178,27 @@
               <a:buNone/>
             </a:pPr>
             <a:r>
-              <a:rPr lang="en-US" sz="1500" b="1" dirty="0">
+              <a:rPr lang="en-US" sz="1600" b="1" dirty="0">
                 <a:solidFill>
                   <a:srgbClr val="FFFFFF"/>
                 </a:solidFill>
               </a:rPr>
-              <a:t>1</a:t>
+              <a:t>2</a:t>
             </a:r>
-            <a:endParaRPr lang="en-US" sz="1500" dirty="0"/>
+            <a:endParaRPr lang="en-US" sz="1600" dirty="0"/>
           </a:p>
         </p:txBody>
       </p:sp>
       <p:sp>
         <p:nvSpPr>
-          <p:cNvPr id="6" name="ty-t1"/>
+          <p:cNvPr id="12" name="tk-t2"/>
           <p:cNvSpPr txBox="1"/>
           <p:nvPr/>
         </p:nvSpPr>
         <p:spPr>
           <a:xfrm>
-            <a:off x="1325880" y="3063240"/>
-            <a:ext cx="10149840" cy="566928"/>
+            <a:off x="1417320" y="2688336"/>
+            <a:ext cx="9966960" cy="786384"/>
           </a:xfrm>
           <a:prstGeom prst="rect">
             <a:avLst/>
@@ -17007,7 +17217,7 @@
               <a:buNone/>
             </a:pPr>
             <a:r>
-              <a:rPr lang="en-US" sz="1400" dirty="0">
+              <a:rPr lang="en-US" sz="1300" dirty="0">
                 <a:solidFill>
                   <a:srgbClr val="EDEDED"/>
                 </a:solidFill>
@@ -17015,22 +17225,49 @@
                 <a:ea typeface="Arial" pitchFamily="34" charset="-122"/>
                 <a:cs typeface="Arial" pitchFamily="34" charset="-120"/>
               </a:rPr>
-              <a:t>The whole pipeline runs on a 4 GB consumer GPU and a free T4 — no API key, $0 total cost.</a:t>
+              <a:t>Refinement changed the verdict on 39–46% of refined facts across three model configurations, against 24.9% in the paper. The phenomenon is robust to model size.</a:t>
             </a:r>
-            <a:endParaRPr lang="en-US" sz="1400" dirty="0"/>
+            <a:endParaRPr lang="en-US" sz="1300" dirty="0"/>
           </a:p>
         </p:txBody>
       </p:sp>
       <p:sp>
         <p:nvSpPr>
-          <p:cNvPr id="7" name="ty-b2"/>
+          <p:cNvPr id="13" name="tk3"/>
           <p:cNvSpPr/>
           <p:nvPr/>
         </p:nvSpPr>
         <p:spPr>
           <a:xfrm>
-            <a:off x="713232" y="3913632"/>
-            <a:ext cx="402336" cy="402336"/>
+            <a:off x="548640" y="3712464"/>
+            <a:ext cx="11064240" cy="969264"/>
+          </a:xfrm>
+          <a:prstGeom prst="roundRect">
+            <a:avLst>
+              <a:gd name="adj" fmla="val 5660"/>
+            </a:avLst>
+          </a:prstGeom>
+          <a:solidFill>
+            <a:srgbClr val="333333"/>
+          </a:solidFill>
+          <a:ln w="12700">
+            <a:solidFill>
+              <a:srgbClr val="333333"/>
+            </a:solidFill>
+            <a:prstDash val="solid"/>
+          </a:ln>
+        </p:spPr>
+      </p:sp>
+      <p:sp>
+        <p:nvSpPr>
+          <p:cNvPr id="14" name="tk-b3"/>
+          <p:cNvSpPr/>
+          <p:nvPr/>
+        </p:nvSpPr>
+        <p:spPr>
+          <a:xfrm>
+            <a:off x="777240" y="3968496"/>
+            <a:ext cx="457200" cy="457200"/>
           </a:xfrm>
           <a:prstGeom prst="ellipse">
             <a:avLst/>
@@ -17048,14 +17285,14 @@
       </p:sp>
       <p:sp>
         <p:nvSpPr>
-          <p:cNvPr id="8" name="ty-n2"/>
+          <p:cNvPr id="15" name="tk-n3"/>
           <p:cNvSpPr txBox="1"/>
           <p:nvPr/>
         </p:nvSpPr>
         <p:spPr>
           <a:xfrm>
-            <a:off x="713232" y="3913632"/>
-            <a:ext cx="402336" cy="402336"/>
+            <a:off x="777240" y="3968496"/>
+            <a:ext cx="457200" cy="457200"/>
           </a:xfrm>
           <a:prstGeom prst="rect">
             <a:avLst/>
@@ -17071,27 +17308,27 @@
               <a:buNone/>
             </a:pPr>
             <a:r>
-              <a:rPr lang="en-US" sz="1500" b="1" dirty="0">
+              <a:rPr lang="en-US" sz="1600" b="1" dirty="0">
                 <a:solidFill>
                   <a:srgbClr val="FFFFFF"/>
                 </a:solidFill>
               </a:rPr>
-              <a:t>2</a:t>
+              <a:t>3</a:t>
             </a:r>
-            <a:endParaRPr lang="en-US" sz="1500" dirty="0"/>
+            <a:endParaRPr lang="en-US" sz="1600" dirty="0"/>
           </a:p>
         </p:txBody>
       </p:sp>
       <p:sp>
         <p:nvSpPr>
-          <p:cNvPr id="9" name="ty-t2"/>
+          <p:cNvPr id="16" name="tk-t3"/>
           <p:cNvSpPr txBox="1"/>
           <p:nvPr/>
         </p:nvSpPr>
         <p:spPr>
           <a:xfrm>
-            <a:off x="1325880" y="3831336"/>
-            <a:ext cx="10149840" cy="566928"/>
+            <a:off x="1417320" y="3803904"/>
+            <a:ext cx="9966960" cy="786384"/>
           </a:xfrm>
           <a:prstGeom prst="rect">
             <a:avLst/>
@@ -17110,7 +17347,7 @@
               <a:buNone/>
             </a:pPr>
             <a:r>
-              <a:rPr lang="en-US" sz="1400" dirty="0">
+              <a:rPr lang="en-US" sz="1300" dirty="0">
                 <a:solidFill>
                   <a:srgbClr val="EDEDED"/>
                 </a:solidFill>
@@ -17118,22 +17355,49 @@
                 <a:ea typeface="Arial" pitchFamily="34" charset="-122"/>
                 <a:cs typeface="Arial" pitchFamily="34" charset="-120"/>
               </a:rPr>
-              <a:t>Refinement changed the verdict on 39–46% of refined facts in every configuration, against 24.9% in the paper.</a:t>
+              <a:t>These metrics measure the judge as much as the system: identical facts score 0.105 incomplete at 3B and 0.438 at 7B; identical answers score 0.41 recall at 3B and 0.28 at 7B.</a:t>
             </a:r>
-            <a:endParaRPr lang="en-US" sz="1400" dirty="0"/>
+            <a:endParaRPr lang="en-US" sz="1300" dirty="0"/>
           </a:p>
         </p:txBody>
       </p:sp>
       <p:sp>
         <p:nvSpPr>
-          <p:cNvPr id="10" name="ty-b3"/>
+          <p:cNvPr id="17" name="tk4"/>
           <p:cNvSpPr/>
           <p:nvPr/>
         </p:nvSpPr>
         <p:spPr>
           <a:xfrm>
-            <a:off x="713232" y="4681728"/>
-            <a:ext cx="402336" cy="402336"/>
+            <a:off x="548640" y="4828032"/>
+            <a:ext cx="11064240" cy="969264"/>
+          </a:xfrm>
+          <a:prstGeom prst="roundRect">
+            <a:avLst>
+              <a:gd name="adj" fmla="val 5660"/>
+            </a:avLst>
+          </a:prstGeom>
+          <a:solidFill>
+            <a:srgbClr val="333333"/>
+          </a:solidFill>
+          <a:ln w="19050">
+            <a:solidFill>
+              <a:srgbClr val="E90802"/>
+            </a:solidFill>
+            <a:prstDash val="solid"/>
+          </a:ln>
+        </p:spPr>
+      </p:sp>
+      <p:sp>
+        <p:nvSpPr>
+          <p:cNvPr id="18" name="tk-b4"/>
+          <p:cNvSpPr/>
+          <p:nvPr/>
+        </p:nvSpPr>
+        <p:spPr>
+          <a:xfrm>
+            <a:off x="777240" y="5084064"/>
+            <a:ext cx="457200" cy="457200"/>
           </a:xfrm>
           <a:prstGeom prst="ellipse">
             <a:avLst/>
@@ -17151,14 +17415,14 @@
       </p:sp>
       <p:sp>
         <p:nvSpPr>
-          <p:cNvPr id="11" name="ty-n3"/>
+          <p:cNvPr id="19" name="tk-n4"/>
           <p:cNvSpPr txBox="1"/>
           <p:nvPr/>
         </p:nvSpPr>
         <p:spPr>
           <a:xfrm>
-            <a:off x="713232" y="4681728"/>
-            <a:ext cx="402336" cy="402336"/>
+            <a:off x="777240" y="5084064"/>
+            <a:ext cx="457200" cy="457200"/>
           </a:xfrm>
           <a:prstGeom prst="rect">
             <a:avLst/>
@@ -17174,27 +17438,27 @@
               <a:buNone/>
             </a:pPr>
             <a:r>
-              <a:rPr lang="en-US" sz="1500" b="1" dirty="0">
+              <a:rPr lang="en-US" sz="1600" b="1" dirty="0">
                 <a:solidFill>
                   <a:srgbClr val="FFFFFF"/>
                 </a:solidFill>
               </a:rPr>
-              <a:t>3</a:t>
+              <a:t>4</a:t>
             </a:r>
-            <a:endParaRPr lang="en-US" sz="1500" dirty="0"/>
+            <a:endParaRPr lang="en-US" sz="1600" dirty="0"/>
           </a:p>
         </p:txBody>
       </p:sp>
       <p:sp>
         <p:nvSpPr>
-          <p:cNvPr id="12" name="ty-t3"/>
+          <p:cNvPr id="20" name="tk-t4"/>
           <p:cNvSpPr txBox="1"/>
           <p:nvPr/>
         </p:nvSpPr>
         <p:spPr>
           <a:xfrm>
-            <a:off x="1325880" y="4599432"/>
-            <a:ext cx="10149840" cy="566928"/>
+            <a:off x="1417320" y="4919472"/>
+            <a:ext cx="9966960" cy="786384"/>
           </a:xfrm>
           <a:prstGeom prst="rect">
             <a:avLst/>
@@ -17213,7 +17477,7 @@
               <a:buNone/>
             </a:pPr>
             <a:r>
-              <a:rPr lang="en-US" sz="1400" dirty="0">
+              <a:rPr lang="en-US" sz="1300" dirty="0">
                 <a:solidFill>
                   <a:srgbClr val="EDEDED"/>
                 </a:solidFill>
@@ -17221,15 +17485,15 @@
                 <a:ea typeface="Arial" pitchFamily="34" charset="-122"/>
                 <a:cs typeface="Arial" pitchFamily="34" charset="-120"/>
               </a:rPr>
-              <a:t>These metrics measure the judge as much as the system: the same facts score 0.105 incomplete at 3B and 0.438 at 7B.</a:t>
+              <a:t>Majority vote beat the paper's union rule on precision in every configuration — but the large incomplete-rate advantage we first reported was a 3B artifact, and we say so.</a:t>
             </a:r>
-            <a:endParaRPr lang="en-US" sz="1400" dirty="0"/>
+            <a:endParaRPr lang="en-US" sz="1300" dirty="0"/>
           </a:p>
         </p:txBody>
       </p:sp>
       <p:sp>
         <p:nvSpPr>
-          <p:cNvPr id="13" name="note"/>
+          <p:cNvPr id="21" name="note"/>
           <p:cNvSpPr txBox="1"/>
           <p:nvPr/>
         </p:nvSpPr>

</xml_diff>

<commit_message>
docs: 16 slides, team byline
Folds the four appendix slides into one backup slide covering word
mapping, run B, what the refiner writes, and the engineering hazards.
The deck is now 15 talk slides plus one backup, and nothing presented
changed.

Adds the five team members to the title slide.
</commit_message>
<xml_diff>
--- a/presentation/VERIFACT-Lite-TTU.pptx
+++ b/presentation/VERIFACT-Lite-TTU.pptx
@@ -21,12 +21,9 @@
     <p:sldId id="269" r:id="rId15"/>
     <p:sldId id="270" r:id="rId16"/>
     <p:sldId id="271" r:id="rId17"/>
-    <p:sldId id="272" r:id="rId18"/>
-    <p:sldId id="273" r:id="rId19"/>
-    <p:sldId id="274" r:id="rId20"/>
   </p:sldIdLst>
   <p:notesMasterIdLst>
-    <p:notesMasterId r:id="rId21"/>
+    <p:notesMasterId r:id="rId18"/>
   </p:notesMasterIdLst>
   <p:sldSz cx="12192000" cy="6858000"/>
   <p:notesSz cx="6858000" cy="12192000"/>
@@ -125,7 +122,7 @@
   <p:extLst>
     <p:ext uri="{521415D9-36F7-43E2-AB2F-B90AF26B5E84}">
       <p14:sectionLst xmlns:p14="http://schemas.microsoft.com/office/powerpoint/2010/main">
-        <p14:section name="Talk" id="{04b6b7c8-648c-08b8-e980-49519a0d1d51}">
+        <p14:section name="Talk" id="{812554c9-9b4e-7407-0140-df5e1e4590fc}">
           <p14:sldIdLst>
             <p14:sldId id="256"/>
             <p14:sldId id="257"/>
@@ -144,12 +141,9 @@
             <p14:sldId id="270"/>
           </p14:sldIdLst>
         </p14:section>
-        <p14:section name="Appendix" id="{e6a5150b-742e-ea1b-3814-6437140a1a06}">
+        <p14:section name="Backup" id="{638b93d3-0bd5-2e97-008c-7cf1980f3fd9}">
           <p14:sldIdLst>
             <p14:sldId id="271"/>
-            <p14:sldId id="272"/>
-            <p14:sldId id="273"/>
-            <p14:sldId id="274"/>
           </p14:sldIdLst>
         </p14:section>
       </p14:sectionLst>
@@ -1517,7 +1511,7 @@
           <a:p>
             <a:r>
               <a:rPr lang="en-US" dirty="0"/>
-              <a:t>Appendix. Use if asked how missing relations are found.</a:t>
+              <a:t>Backup. Not part of the 15 minutes.</a:t>
             </a:r>
             <a:endParaRPr lang="en-US" dirty="0"/>
           </a:p>
@@ -1541,270 +1535,6 @@
             <a:fld id="{F7021451-1387-4CA6-816F-3879F97B5CBC}" type="slidenum">
               <a:rPr lang="en-US"/>
               <a:t>16</a:t>
-            </a:fld>
-            <a:endParaRPr lang="en-US"/>
-          </a:p>
-        </p:txBody>
-      </p:sp>
-    </p:spTree>
-    <p:extLst>
-      <p:ext uri="{BB962C8B-B14F-4D97-AF65-F5344CB8AC3E}">
-        <p14:creationId xmlns:p14="http://schemas.microsoft.com/office/powerpoint/2010/main" val="1024086991"/>
-      </p:ext>
-    </p:extLst>
-  </p:cSld>
-  <p:clrMapOvr>
-    <a:masterClrMapping/>
-  </p:clrMapOvr>
-</p:notes>
-</file>
-
-<file path=ppt/notesSlides/notesSlide17.xml><?xml version="1.0" encoding="utf-8"?>
-<p:notes xmlns:a="http://schemas.openxmlformats.org/drawingml/2006/main" xmlns:r="http://schemas.openxmlformats.org/officeDocument/2006/relationships" xmlns:p="http://schemas.openxmlformats.org/presentationml/2006/main">
-  <p:cSld>
-    <p:spTree>
-      <p:nvGrpSpPr>
-        <p:cNvPr id="1" name=""/>
-        <p:cNvGrpSpPr/>
-        <p:nvPr/>
-      </p:nvGrpSpPr>
-      <p:grpSpPr>
-        <a:xfrm>
-          <a:off x="0" y="0"/>
-          <a:ext cx="0" cy="0"/>
-          <a:chOff x="0" y="0"/>
-          <a:chExt cx="0" cy="0"/>
-        </a:xfrm>
-      </p:grpSpPr>
-      <p:sp>
-        <p:nvSpPr>
-          <p:cNvPr id="2" name="Slide Image Placeholder 1"/>
-          <p:cNvSpPr>
-            <a:spLocks noGrp="1" noRot="1" noChangeAspect="1"/>
-          </p:cNvSpPr>
-          <p:nvPr>
-            <p:ph type="sldImg"/>
-          </p:nvPr>
-        </p:nvSpPr>
-        <p:spPr/>
-      </p:sp>
-      <p:sp>
-        <p:nvSpPr>
-          <p:cNvPr id="3" name="Notes Placeholder 2"/>
-          <p:cNvSpPr>
-            <a:spLocks noGrp="1"/>
-          </p:cNvSpPr>
-          <p:nvPr>
-            <p:ph type="body" idx="1"/>
-          </p:nvPr>
-        </p:nvSpPr>
-        <p:spPr/>
-        <p:txBody>
-          <a:bodyPr/>
-          <a:lstStyle/>
-          <a:p>
-            <a:r>
-              <a:rPr lang="en-US" dirty="0"/>
-              <a:t>Appendix. Use if asked what the refiner actually writes, or why a stronger model was the first thing tested.</a:t>
-            </a:r>
-            <a:endParaRPr lang="en-US" dirty="0"/>
-          </a:p>
-        </p:txBody>
-      </p:sp>
-      <p:sp>
-        <p:nvSpPr>
-          <p:cNvPr id="4" name="Slide Number Placeholder 3"/>
-          <p:cNvSpPr>
-            <a:spLocks noGrp="1"/>
-          </p:cNvSpPr>
-          <p:nvPr>
-            <p:ph type="sldNum" sz="quarter" idx="10"/>
-          </p:nvPr>
-        </p:nvSpPr>
-        <p:spPr/>
-        <p:txBody>
-          <a:bodyPr/>
-          <a:lstStyle/>
-          <a:p>
-            <a:fld id="{F7021451-1387-4CA6-816F-3879F97B5CBC}" type="slidenum">
-              <a:rPr lang="en-US"/>
-              <a:t>17</a:t>
-            </a:fld>
-            <a:endParaRPr lang="en-US"/>
-          </a:p>
-        </p:txBody>
-      </p:sp>
-    </p:spTree>
-    <p:extLst>
-      <p:ext uri="{BB962C8B-B14F-4D97-AF65-F5344CB8AC3E}">
-        <p14:creationId xmlns:p14="http://schemas.microsoft.com/office/powerpoint/2010/main" val="1024086991"/>
-      </p:ext>
-    </p:extLst>
-  </p:cSld>
-  <p:clrMapOvr>
-    <a:masterClrMapping/>
-  </p:clrMapOvr>
-</p:notes>
-</file>
-
-<file path=ppt/notesSlides/notesSlide18.xml><?xml version="1.0" encoding="utf-8"?>
-<p:notes xmlns:a="http://schemas.openxmlformats.org/drawingml/2006/main" xmlns:r="http://schemas.openxmlformats.org/officeDocument/2006/relationships" xmlns:p="http://schemas.openxmlformats.org/presentationml/2006/main">
-  <p:cSld>
-    <p:spTree>
-      <p:nvGrpSpPr>
-        <p:cNvPr id="1" name=""/>
-        <p:cNvGrpSpPr/>
-        <p:nvPr/>
-      </p:nvGrpSpPr>
-      <p:grpSpPr>
-        <a:xfrm>
-          <a:off x="0" y="0"/>
-          <a:ext cx="0" cy="0"/>
-          <a:chOff x="0" y="0"/>
-          <a:chExt cx="0" cy="0"/>
-        </a:xfrm>
-      </p:grpSpPr>
-      <p:sp>
-        <p:nvSpPr>
-          <p:cNvPr id="2" name="Slide Image Placeholder 1"/>
-          <p:cNvSpPr>
-            <a:spLocks noGrp="1" noRot="1" noChangeAspect="1"/>
-          </p:cNvSpPr>
-          <p:nvPr>
-            <p:ph type="sldImg"/>
-          </p:nvPr>
-        </p:nvSpPr>
-        <p:spPr/>
-      </p:sp>
-      <p:sp>
-        <p:nvSpPr>
-          <p:cNvPr id="3" name="Notes Placeholder 2"/>
-          <p:cNvSpPr>
-            <a:spLocks noGrp="1"/>
-          </p:cNvSpPr>
-          <p:nvPr>
-            <p:ph type="body" idx="1"/>
-          </p:nvPr>
-        </p:nvSpPr>
-        <p:spPr/>
-        <p:txBody>
-          <a:bodyPr/>
-          <a:lstStyle/>
-          <a:p>
-            <a:r>
-              <a:rPr lang="en-US" dirty="0"/>
-              <a:t>Appendix. Use if asked what else you would do.</a:t>
-            </a:r>
-            <a:endParaRPr lang="en-US" dirty="0"/>
-          </a:p>
-        </p:txBody>
-      </p:sp>
-      <p:sp>
-        <p:nvSpPr>
-          <p:cNvPr id="4" name="Slide Number Placeholder 3"/>
-          <p:cNvSpPr>
-            <a:spLocks noGrp="1"/>
-          </p:cNvSpPr>
-          <p:nvPr>
-            <p:ph type="sldNum" sz="quarter" idx="10"/>
-          </p:nvPr>
-        </p:nvSpPr>
-        <p:spPr/>
-        <p:txBody>
-          <a:bodyPr/>
-          <a:lstStyle/>
-          <a:p>
-            <a:fld id="{F7021451-1387-4CA6-816F-3879F97B5CBC}" type="slidenum">
-              <a:rPr lang="en-US"/>
-              <a:t>18</a:t>
-            </a:fld>
-            <a:endParaRPr lang="en-US"/>
-          </a:p>
-        </p:txBody>
-      </p:sp>
-    </p:spTree>
-    <p:extLst>
-      <p:ext uri="{BB962C8B-B14F-4D97-AF65-F5344CB8AC3E}">
-        <p14:creationId xmlns:p14="http://schemas.microsoft.com/office/powerpoint/2010/main" val="1024086991"/>
-      </p:ext>
-    </p:extLst>
-  </p:cSld>
-  <p:clrMapOvr>
-    <a:masterClrMapping/>
-  </p:clrMapOvr>
-</p:notes>
-</file>
-
-<file path=ppt/notesSlides/notesSlide19.xml><?xml version="1.0" encoding="utf-8"?>
-<p:notes xmlns:a="http://schemas.openxmlformats.org/drawingml/2006/main" xmlns:r="http://schemas.openxmlformats.org/officeDocument/2006/relationships" xmlns:p="http://schemas.openxmlformats.org/presentationml/2006/main">
-  <p:cSld>
-    <p:spTree>
-      <p:nvGrpSpPr>
-        <p:cNvPr id="1" name=""/>
-        <p:cNvGrpSpPr/>
-        <p:nvPr/>
-      </p:nvGrpSpPr>
-      <p:grpSpPr>
-        <a:xfrm>
-          <a:off x="0" y="0"/>
-          <a:ext cx="0" cy="0"/>
-          <a:chOff x="0" y="0"/>
-          <a:chExt cx="0" cy="0"/>
-        </a:xfrm>
-      </p:grpSpPr>
-      <p:sp>
-        <p:nvSpPr>
-          <p:cNvPr id="2" name="Slide Image Placeholder 1"/>
-          <p:cNvSpPr>
-            <a:spLocks noGrp="1" noRot="1" noChangeAspect="1"/>
-          </p:cNvSpPr>
-          <p:nvPr>
-            <p:ph type="sldImg"/>
-          </p:nvPr>
-        </p:nvSpPr>
-        <p:spPr/>
-      </p:sp>
-      <p:sp>
-        <p:nvSpPr>
-          <p:cNvPr id="3" name="Notes Placeholder 2"/>
-          <p:cNvSpPr>
-            <a:spLocks noGrp="1"/>
-          </p:cNvSpPr>
-          <p:nvPr>
-            <p:ph type="body" idx="1"/>
-          </p:nvPr>
-        </p:nvSpPr>
-        <p:spPr/>
-        <p:txBody>
-          <a:bodyPr/>
-          <a:lstStyle/>
-          <a:p>
-            <a:r>
-              <a:rPr lang="en-US" dirty="0"/>
-              <a:t>Appendix. Use if asked about run B or about engineering problems.</a:t>
-            </a:r>
-            <a:endParaRPr lang="en-US" dirty="0"/>
-          </a:p>
-        </p:txBody>
-      </p:sp>
-      <p:sp>
-        <p:nvSpPr>
-          <p:cNvPr id="4" name="Slide Number Placeholder 3"/>
-          <p:cNvSpPr>
-            <a:spLocks noGrp="1"/>
-          </p:cNvSpPr>
-          <p:nvPr>
-            <p:ph type="sldNum" sz="quarter" idx="10"/>
-          </p:nvPr>
-        </p:nvSpPr>
-        <p:spPr/>
-        <p:txBody>
-          <a:bodyPr/>
-          <a:lstStyle/>
-          <a:p>
-            <a:fld id="{F7021451-1387-4CA6-816F-3879F97B5CBC}" type="slidenum">
-              <a:rPr lang="en-US"/>
-              <a:t>19</a:t>
             </a:fld>
             <a:endParaRPr lang="en-US"/>
           </a:p>
@@ -3148,14 +2878,53 @@
       </p:sp>
       <p:sp>
         <p:nvSpPr>
-          <p:cNvPr id="6" name="cover-by"/>
+          <p:cNvPr id="6" name="cover-by-label"/>
           <p:cNvSpPr txBox="1"/>
           <p:nvPr/>
         </p:nvSpPr>
         <p:spPr>
           <a:xfrm>
-            <a:off x="548640" y="4023360"/>
-            <a:ext cx="10241280" cy="292608"/>
+            <a:off x="548640" y="4041648"/>
+            <a:ext cx="10241280" cy="237744"/>
+          </a:xfrm>
+          <a:prstGeom prst="rect">
+            <a:avLst/>
+          </a:prstGeom>
+          <a:noFill/>
+          <a:ln/>
+        </p:spPr>
+        <p:txBody>
+          <a:bodyPr wrap="square" lIns="0" tIns="0" rIns="0" bIns="0" rtlCol="0" anchor="ctr"/>
+          <a:lstStyle/>
+          <a:p>
+            <a:pPr indent="0" marL="0">
+              <a:buNone/>
+            </a:pPr>
+            <a:r>
+              <a:rPr lang="en-US" sz="1000" b="1" spc="200" kern="0" dirty="0">
+                <a:solidFill>
+                  <a:srgbClr val="767676"/>
+                </a:solidFill>
+                <a:latin typeface="Arial" pitchFamily="34" charset="0"/>
+                <a:ea typeface="Arial" pitchFamily="34" charset="-122"/>
+                <a:cs typeface="Arial" pitchFamily="34" charset="-120"/>
+              </a:rPr>
+              <a:t>By</a:t>
+            </a:r>
+            <a:endParaRPr lang="en-US" sz="1000" dirty="0"/>
+          </a:p>
+        </p:txBody>
+      </p:sp>
+      <p:sp>
+        <p:nvSpPr>
+          <p:cNvPr id="7" name="cover-by"/>
+          <p:cNvSpPr txBox="1"/>
+          <p:nvPr/>
+        </p:nvSpPr>
+        <p:spPr>
+          <a:xfrm>
+            <a:off x="548640" y="4297680"/>
+            <a:ext cx="10607040" cy="292608"/>
           </a:xfrm>
           <a:prstGeom prst="rect">
             <a:avLst/>
@@ -3179,7 +2948,7 @@
                 <a:ea typeface="Arial" pitchFamily="34" charset="-122"/>
                 <a:cs typeface="Arial" pitchFamily="34" charset="-120"/>
               </a:rPr>
-              <a:t>Madhav Krishna</a:t>
+              <a:t>Madhav Krishna Arumulla  ·  Sanskar Jadhav  ·  Sri Charan Komati Reddy  ·  Gourav Verma  ·  Trinath Reddy Vundela</a:t>
             </a:r>
             <a:endParaRPr lang="en-US" sz="1300" dirty="0"/>
           </a:p>
@@ -3187,13 +2956,13 @@
       </p:sp>
       <p:sp>
         <p:nvSpPr>
-          <p:cNvPr id="7" name="chip0"/>
+          <p:cNvPr id="8" name="chip0"/>
           <p:cNvSpPr/>
           <p:nvPr/>
         </p:nvSpPr>
         <p:spPr>
           <a:xfrm>
-            <a:off x="548640" y="4754880"/>
+            <a:off x="548640" y="4892040"/>
             <a:ext cx="2631643" cy="365760"/>
           </a:xfrm>
           <a:prstGeom prst="roundRect">
@@ -3214,13 +2983,13 @@
       </p:sp>
       <p:sp>
         <p:nvSpPr>
-          <p:cNvPr id="8" name="chip-t0"/>
+          <p:cNvPr id="9" name="chip-t0"/>
           <p:cNvSpPr txBox="1"/>
           <p:nvPr/>
         </p:nvSpPr>
         <p:spPr>
           <a:xfrm>
-            <a:off x="548640" y="4754880"/>
+            <a:off x="548640" y="4892040"/>
             <a:ext cx="2631643" cy="365760"/>
           </a:xfrm>
           <a:prstGeom prst="rect">
@@ -3253,13 +3022,13 @@
       </p:sp>
       <p:sp>
         <p:nvSpPr>
-          <p:cNvPr id="9" name="chip1"/>
+          <p:cNvPr id="10" name="chip1"/>
           <p:cNvSpPr/>
           <p:nvPr/>
         </p:nvSpPr>
         <p:spPr>
           <a:xfrm>
-            <a:off x="3381451" y="4754880"/>
+            <a:off x="3381451" y="4892040"/>
             <a:ext cx="2546604" cy="365760"/>
           </a:xfrm>
           <a:prstGeom prst="roundRect">
@@ -3280,13 +3049,13 @@
       </p:sp>
       <p:sp>
         <p:nvSpPr>
-          <p:cNvPr id="10" name="chip-t1"/>
+          <p:cNvPr id="11" name="chip-t1"/>
           <p:cNvSpPr txBox="1"/>
           <p:nvPr/>
         </p:nvSpPr>
         <p:spPr>
           <a:xfrm>
-            <a:off x="3381451" y="4754880"/>
+            <a:off x="3381451" y="4892040"/>
             <a:ext cx="2546604" cy="365760"/>
           </a:xfrm>
           <a:prstGeom prst="rect">
@@ -3319,13 +3088,13 @@
       </p:sp>
       <p:sp>
         <p:nvSpPr>
-          <p:cNvPr id="11" name="chip2"/>
+          <p:cNvPr id="12" name="chip2"/>
           <p:cNvSpPr/>
           <p:nvPr/>
         </p:nvSpPr>
         <p:spPr>
           <a:xfrm>
-            <a:off x="6129223" y="4754880"/>
+            <a:off x="6129223" y="4892040"/>
             <a:ext cx="1951330" cy="365760"/>
           </a:xfrm>
           <a:prstGeom prst="roundRect">
@@ -3346,13 +3115,13 @@
       </p:sp>
       <p:sp>
         <p:nvSpPr>
-          <p:cNvPr id="12" name="chip-t2"/>
+          <p:cNvPr id="13" name="chip-t2"/>
           <p:cNvSpPr txBox="1"/>
           <p:nvPr/>
         </p:nvSpPr>
         <p:spPr>
           <a:xfrm>
-            <a:off x="6129223" y="4754880"/>
+            <a:off x="6129223" y="4892040"/>
             <a:ext cx="1951330" cy="365760"/>
           </a:xfrm>
           <a:prstGeom prst="rect">
@@ -3385,13 +3154,13 @@
       </p:sp>
       <p:sp>
         <p:nvSpPr>
-          <p:cNvPr id="13" name="chip3"/>
+          <p:cNvPr id="14" name="chip3"/>
           <p:cNvSpPr/>
           <p:nvPr/>
         </p:nvSpPr>
         <p:spPr>
           <a:xfrm>
-            <a:off x="8281721" y="4754880"/>
+            <a:off x="8281721" y="4892040"/>
             <a:ext cx="3141878" cy="365760"/>
           </a:xfrm>
           <a:prstGeom prst="roundRect">
@@ -3412,13 +3181,13 @@
       </p:sp>
       <p:sp>
         <p:nvSpPr>
-          <p:cNvPr id="14" name="chip-t3"/>
+          <p:cNvPr id="15" name="chip-t3"/>
           <p:cNvSpPr txBox="1"/>
           <p:nvPr/>
         </p:nvSpPr>
         <p:spPr>
           <a:xfrm>
-            <a:off x="8281721" y="4754880"/>
+            <a:off x="8281721" y="4892040"/>
             <a:ext cx="3141878" cy="365760"/>
           </a:xfrm>
           <a:prstGeom prst="rect">
@@ -3451,7 +3220,7 @@
       </p:sp>
       <p:sp>
         <p:nvSpPr>
-          <p:cNvPr id="15" name="cover-foot"/>
+          <p:cNvPr id="16" name="cover-foot"/>
           <p:cNvSpPr txBox="1"/>
           <p:nvPr/>
         </p:nvSpPr>
@@ -17664,7 +17433,7 @@
                 <a:ea typeface="Arial" pitchFamily="34" charset="-122"/>
                 <a:cs typeface="Arial" pitchFamily="34" charset="-120"/>
               </a:rPr>
-              <a:t>APPENDIX — NOT PRESENTED</a:t>
+              <a:t>BACKUP — NOT PRESENTED</a:t>
             </a:r>
             <a:endParaRPr lang="en-US" sz="1000" dirty="0"/>
           </a:p>
@@ -17700,7 +17469,7 @@
                   <a:srgbClr val="1A1A1A"/>
                 </a:solidFill>
               </a:rPr>
-              <a:t>Step 2B: word mapping, the paper's Algorithm 1</a:t>
+              <a:t>Detail behind the four most likely questions</a:t>
             </a:r>
             <a:endParaRPr lang="en-US" sz="2700" dirty="0"/>
           </a:p>
@@ -17739,7 +17508,7 @@
                 <a:ea typeface="Arial" pitchFamily="34" charset="-122"/>
                 <a:cs typeface="Arial" pitchFamily="34" charset="-120"/>
               </a:rPr>
-              <a:t>How an uncovered span becomes a missing-relation candidate</a:t>
+              <a:t>Word mapping, the uncontrolled run, what the refiner writes, and the engineering hazards</a:t>
             </a:r>
             <a:endParaRPr lang="en-US" sz="1350" dirty="0"/>
           </a:p>
@@ -17772,134 +17541,24 @@
       </p:sp>
       <p:sp>
         <p:nvSpPr>
-          <p:cNvPr id="6" name="algo"/>
-          <p:cNvSpPr txBox="1"/>
-          <p:nvPr/>
-        </p:nvSpPr>
-        <p:spPr>
-          <a:xfrm>
-            <a:off x="548640" y="1600200"/>
-            <a:ext cx="5394960" cy="1463040"/>
-          </a:xfrm>
-          <a:prstGeom prst="rect">
-            <a:avLst/>
-          </a:prstGeom>
-          <a:noFill/>
-          <a:ln/>
-        </p:spPr>
-        <p:txBody>
-          <a:bodyPr wrap="square" lIns="0" tIns="0" rIns="0" bIns="0" rtlCol="0" anchor="ctr"/>
-          <a:lstStyle/>
-          <a:p>
-            <a:pPr marL="342900" indent="-342900">
-              <a:spcAft>
-                <a:spcPts val="600"/>
-              </a:spcAft>
-              <a:buSzPct val="100000"/>
-              <a:buFont typeface="+mj-lt"/>
-              <a:buAutoNum type="arabicPeriod" startAt="1"/>
-            </a:pPr>
-            <a:r>
-              <a:rPr lang="en-US" sz="1350" dirty="0">
-                <a:solidFill>
-                  <a:srgbClr val="444444"/>
-                </a:solidFill>
-                <a:latin typeface="Arial" pitchFamily="34" charset="0"/>
-                <a:ea typeface="Arial" pitchFamily="34" charset="-122"/>
-                <a:cs typeface="Arial" pitchFamily="34" charset="-120"/>
-              </a:rPr>
-              <a:t>For each fact, take its longest common substring with the response.</a:t>
-            </a:r>
-            <a:endParaRPr lang="en-US" sz="1350" dirty="0"/>
-          </a:p>
-          <a:p>
-            <a:pPr marL="342900" indent="-342900">
-              <a:spcAft>
-                <a:spcPts val="600"/>
-              </a:spcAft>
-              <a:buSzPct val="100000"/>
-              <a:buFont typeface="+mj-lt"/>
-              <a:buAutoNum type="arabicPeriod" startAt="1"/>
-            </a:pPr>
-            <a:r>
-              <a:rPr lang="en-US" sz="1350" dirty="0">
-                <a:solidFill>
-                  <a:srgbClr val="444444"/>
-                </a:solidFill>
-                <a:latin typeface="Arial" pitchFamily="34" charset="0"/>
-                <a:ea typeface="Arial" pitchFamily="34" charset="-122"/>
-                <a:cs typeface="Arial" pitchFamily="34" charset="-120"/>
-              </a:rPr>
-              <a:t>Mark those response characters as covered.</a:t>
-            </a:r>
-            <a:endParaRPr lang="en-US" sz="1350" dirty="0"/>
-          </a:p>
-          <a:p>
-            <a:pPr marL="342900" indent="-342900">
-              <a:spcAft>
-                <a:spcPts val="600"/>
-              </a:spcAft>
-              <a:buSzPct val="100000"/>
-              <a:buFont typeface="+mj-lt"/>
-              <a:buAutoNum type="arabicPeriod" startAt="1"/>
-            </a:pPr>
-            <a:r>
-              <a:rPr lang="en-US" sz="1350" dirty="0">
-                <a:solidFill>
-                  <a:srgbClr val="444444"/>
-                </a:solidFill>
-                <a:latin typeface="Arial" pitchFamily="34" charset="0"/>
-                <a:ea typeface="Arial" pitchFamily="34" charset="-122"/>
-                <a:cs typeface="Arial" pitchFamily="34" charset="-120"/>
-              </a:rPr>
-              <a:t>Collect the contiguous runs that stayed uncovered.</a:t>
-            </a:r>
-            <a:endParaRPr lang="en-US" sz="1350" dirty="0"/>
-          </a:p>
-          <a:p>
-            <a:pPr marL="342900" indent="-342900">
-              <a:spcAft>
-                <a:spcPts val="600"/>
-              </a:spcAft>
-              <a:buSzPct val="100000"/>
-              <a:buFont typeface="+mj-lt"/>
-              <a:buAutoNum type="arabicPeriod" startAt="1"/>
-            </a:pPr>
-            <a:r>
-              <a:rPr lang="en-US" sz="1350" dirty="0">
-                <a:solidFill>
-                  <a:srgbClr val="444444"/>
-                </a:solidFill>
-                <a:latin typeface="Arial" pitchFamily="34" charset="0"/>
-                <a:ea typeface="Arial" pitchFamily="34" charset="-122"/>
-                <a:cs typeface="Arial" pitchFamily="34" charset="-120"/>
-              </a:rPr>
-              <a:t>Send those spans to the judges as missing-relation candidates.</a:t>
-            </a:r>
-            <a:endParaRPr lang="en-US" sz="1350" dirty="0"/>
-          </a:p>
-        </p:txBody>
-      </p:sp>
-      <p:sp>
-        <p:nvSpPr>
-          <p:cNvPr id="7" name="impl"/>
+          <p:cNvPr id="6" name="bk-wm"/>
           <p:cNvSpPr/>
           <p:nvPr/>
         </p:nvSpPr>
         <p:spPr>
           <a:xfrm>
-            <a:off x="548640" y="3200400"/>
-            <a:ext cx="5394960" cy="1554480"/>
+            <a:off x="548640" y="1600200"/>
+            <a:ext cx="5394960" cy="2103120"/>
           </a:xfrm>
           <a:prstGeom prst="rect">
             <a:avLst/>
           </a:prstGeom>
           <a:solidFill>
-            <a:srgbClr val="F4F4F4"/>
+            <a:srgbClr val="FFFFFF"/>
           </a:solidFill>
           <a:ln w="9525">
             <a:solidFill>
-              <a:srgbClr val="F4F4F4"/>
+              <a:srgbClr val="DCDCDC"/>
             </a:solidFill>
             <a:prstDash val="solid"/>
           </a:ln>
@@ -17907,13 +17566,13 @@
       </p:sp>
       <p:sp>
         <p:nvSpPr>
-          <p:cNvPr id="8" name="impl-h"/>
+          <p:cNvPr id="7" name="bk-wm-h"/>
           <p:cNvSpPr txBox="1"/>
           <p:nvPr/>
         </p:nvSpPr>
         <p:spPr>
           <a:xfrm>
-            <a:off x="804672" y="3401568"/>
+            <a:off x="804672" y="1801368"/>
             <a:ext cx="4882896" cy="292608"/>
           </a:xfrm>
           <a:prstGeom prst="rect">
@@ -17930,27 +17589,27 @@
               <a:buNone/>
             </a:pPr>
             <a:r>
-              <a:rPr lang="en-US" sz="1450" b="1" dirty="0">
+              <a:rPr lang="en-US" sz="1350" b="1" dirty="0">
                 <a:solidFill>
                   <a:srgbClr val="1A1A1A"/>
                 </a:solidFill>
               </a:rPr>
-              <a:t>Implementation</a:t>
+              <a:t>How missing relations are found — Algorithm 1</a:t>
             </a:r>
-            <a:endParaRPr lang="en-US" sz="1450" dirty="0"/>
+            <a:endParaRPr lang="en-US" sz="1350" dirty="0"/>
           </a:p>
         </p:txBody>
       </p:sp>
       <p:sp>
         <p:nvSpPr>
-          <p:cNvPr id="9" name="impl-b"/>
+          <p:cNvPr id="8" name="bk-wm-b"/>
           <p:cNvSpPr txBox="1"/>
           <p:nvPr/>
         </p:nvSpPr>
         <p:spPr>
           <a:xfrm>
-            <a:off x="804672" y="3803904"/>
-            <a:ext cx="4882896" cy="786384"/>
+            <a:off x="804672" y="2203704"/>
+            <a:ext cx="4882896" cy="1335024"/>
           </a:xfrm>
           <a:prstGeom prst="rect">
             <a:avLst/>
@@ -17969,7 +17628,7 @@
               <a:buNone/>
             </a:pPr>
             <a:r>
-              <a:rPr lang="en-US" sz="1200" dirty="0">
+              <a:rPr lang="en-US" sz="1050" dirty="0">
                 <a:solidFill>
                   <a:srgbClr val="444444"/>
                 </a:solidFill>
@@ -17977,22 +17636,42 @@
                 <a:ea typeface="Arial" pitchFamily="34" charset="-122"/>
                 <a:cs typeface="Arial" pitchFamily="34" charset="-120"/>
               </a:rPr>
-              <a:t>Normalization for case, whitespace and line breaks is index-preserving — one character in, one character out — so span offsets still point into the original answer.</a:t>
+              <a:t>Take each fact's longest common substring with the response, mark those characters covered, collect the runs that stayed uncovered, and send them to the judges. Normalization is index-preserving, so offsets still point into the original answer.</a:t>
             </a:r>
-            <a:endParaRPr lang="en-US" sz="1200" dirty="0"/>
+            <a:endParaRPr lang="en-US" sz="1050" dirty="0"/>
+          </a:p>
+          <a:p>
+            <a:pPr indent="0" marL="0">
+              <a:lnSpc>
+                <a:spcPct val="125000"/>
+              </a:lnSpc>
+              <a:buNone/>
+            </a:pPr>
+            <a:r>
+              <a:rPr lang="en-US" sz="1050" dirty="0">
+                <a:solidFill>
+                  <a:srgbClr val="444444"/>
+                </a:solidFill>
+                <a:latin typeface="Arial" pitchFamily="34" charset="0"/>
+                <a:ea typeface="Arial" pitchFamily="34" charset="-122"/>
+                <a:cs typeface="Arial" pitchFamily="34" charset="-120"/>
+              </a:rPr>
+              <a:t>Coverage 0.55–0.59.  73 candidate spans.  A fact is added only when the span expresses a temporal or contingency relation AND no single existing fact already captures it.</a:t>
+            </a:r>
+            <a:endParaRPr lang="en-US" sz="1050" dirty="0"/>
           </a:p>
         </p:txBody>
       </p:sp>
       <p:sp>
         <p:nvSpPr>
-          <p:cNvPr id="10" name="cov-box"/>
+          <p:cNvPr id="9" name="bk-b"/>
           <p:cNvSpPr/>
           <p:nvPr/>
         </p:nvSpPr>
         <p:spPr>
           <a:xfrm>
             <a:off x="6217920" y="1600200"/>
-            <a:ext cx="5394960" cy="1463040"/>
+            <a:ext cx="5394960" cy="2103120"/>
           </a:xfrm>
           <a:prstGeom prst="rect">
             <a:avLst/>
@@ -18010,90 +17689,14 @@
       </p:sp>
       <p:sp>
         <p:nvSpPr>
-          <p:cNvPr id="11" name="cov-text"/>
+          <p:cNvPr id="10" name="bk-b-h"/>
           <p:cNvSpPr txBox="1"/>
           <p:nvPr/>
         </p:nvSpPr>
         <p:spPr>
           <a:xfrm>
-            <a:off x="6473952" y="1783080"/>
-            <a:ext cx="4882896" cy="822960"/>
-          </a:xfrm>
-          <a:prstGeom prst="rect">
-            <a:avLst/>
-          </a:prstGeom>
-          <a:noFill/>
-          <a:ln/>
-        </p:spPr>
-        <p:txBody>
-          <a:bodyPr wrap="square" lIns="0" tIns="0" rIns="0" bIns="0" rtlCol="0" anchor="ctr"/>
-          <a:lstStyle/>
-          <a:p>
-            <a:pPr indent="0" marL="0">
-              <a:lnSpc>
-                <a:spcPct val="120000"/>
-              </a:lnSpc>
-              <a:buNone/>
-            </a:pPr>
-            <a:r>
-              <a:rPr lang="en-US" sz="1250" dirty="0">
-                <a:solidFill>
-                  <a:srgbClr val="767676"/>
-                </a:solidFill>
-                <a:latin typeface="Arial" pitchFamily="34" charset="0"/>
-                <a:ea typeface="Arial" pitchFamily="34" charset="-122"/>
-                <a:cs typeface="Arial" pitchFamily="34" charset="-120"/>
-              </a:rPr>
-              <a:t>If the demand for gold as jewelry were to disappear, </a:t>
-            </a:r>
-            <a:pPr indent="0" marL="0">
-              <a:lnSpc>
-                <a:spcPct val="120000"/>
-              </a:lnSpc>
-              <a:buNone/>
-            </a:pPr>
-            <a:r>
-              <a:rPr lang="en-US" sz="1250" b="1" dirty="0">
-                <a:solidFill>
-                  <a:srgbClr val="E90802"/>
-                </a:solidFill>
-                <a:latin typeface="Arial" pitchFamily="34" charset="0"/>
-                <a:ea typeface="Arial" pitchFamily="34" charset="-122"/>
-                <a:cs typeface="Arial" pitchFamily="34" charset="-120"/>
-              </a:rPr>
-              <a:t>making it more competitive with other materials like </a:t>
-            </a:r>
-            <a:pPr indent="0" marL="0">
-              <a:lnSpc>
-                <a:spcPct val="120000"/>
-              </a:lnSpc>
-              <a:buNone/>
-            </a:pPr>
-            <a:r>
-              <a:rPr lang="en-US" sz="1250" dirty="0">
-                <a:solidFill>
-                  <a:srgbClr val="767676"/>
-                </a:solidFill>
-                <a:latin typeface="Arial" pitchFamily="34" charset="0"/>
-                <a:ea typeface="Arial" pitchFamily="34" charset="-122"/>
-                <a:cs typeface="Arial" pitchFamily="34" charset="-120"/>
-              </a:rPr>
-              <a:t>copper and silver.</a:t>
-            </a:r>
-            <a:endParaRPr lang="en-US" sz="1250" dirty="0"/>
-          </a:p>
-        </p:txBody>
-      </p:sp>
-      <p:sp>
-        <p:nvSpPr>
-          <p:cNvPr id="12" name="cov-key"/>
-          <p:cNvSpPr txBox="1"/>
-          <p:nvPr/>
-        </p:nvSpPr>
-        <p:spPr>
-          <a:xfrm>
-            <a:off x="6473952" y="2642616"/>
-            <a:ext cx="4882896" cy="237744"/>
+            <a:off x="6473952" y="1801368"/>
+            <a:ext cx="4882896" cy="292608"/>
           </a:xfrm>
           <a:prstGeom prst="rect">
             <a:avLst/>
@@ -18109,91 +17712,27 @@
               <a:buNone/>
             </a:pPr>
             <a:r>
-              <a:rPr lang="en-US" sz="1000" dirty="0">
-                <a:solidFill>
-                  <a:srgbClr val="767676"/>
-                </a:solidFill>
-                <a:latin typeface="Arial" pitchFamily="34" charset="0"/>
-                <a:ea typeface="Arial" pitchFamily="34" charset="-122"/>
-                <a:cs typeface="Arial" pitchFamily="34" charset="-120"/>
-              </a:rPr>
-              <a:t>grey = matched by some fact   ·   scarlet = uncovered span</a:t>
-            </a:r>
-            <a:endParaRPr lang="en-US" sz="1000" dirty="0"/>
-          </a:p>
-        </p:txBody>
-      </p:sp>
-      <p:sp>
-        <p:nvSpPr>
-          <p:cNvPr id="13" name="twoq"/>
-          <p:cNvSpPr/>
-          <p:nvPr/>
-        </p:nvSpPr>
-        <p:spPr>
-          <a:xfrm>
-            <a:off x="6217920" y="3200400"/>
-            <a:ext cx="5394960" cy="1554480"/>
-          </a:xfrm>
-          <a:prstGeom prst="rect">
-            <a:avLst/>
-          </a:prstGeom>
-          <a:solidFill>
-            <a:srgbClr val="FFFFFF"/>
-          </a:solidFill>
-          <a:ln w="9525">
-            <a:solidFill>
-              <a:srgbClr val="DCDCDC"/>
-            </a:solidFill>
-            <a:prstDash val="solid"/>
-          </a:ln>
-        </p:spPr>
-      </p:sp>
-      <p:sp>
-        <p:nvSpPr>
-          <p:cNvPr id="14" name="twoq-h"/>
-          <p:cNvSpPr txBox="1"/>
-          <p:nvPr/>
-        </p:nvSpPr>
-        <p:spPr>
-          <a:xfrm>
-            <a:off x="6473952" y="3401568"/>
-            <a:ext cx="4882896" cy="292608"/>
-          </a:xfrm>
-          <a:prstGeom prst="rect">
-            <a:avLst/>
-          </a:prstGeom>
-          <a:noFill/>
-          <a:ln/>
-        </p:spPr>
-        <p:txBody>
-          <a:bodyPr wrap="square" lIns="0" tIns="0" rIns="0" bIns="0" rtlCol="0" anchor="ctr"/>
-          <a:lstStyle/>
-          <a:p>
-            <a:pPr indent="0" marL="0">
-              <a:buNone/>
-            </a:pPr>
-            <a:r>
-              <a:rPr lang="en-US" sz="1450" b="1" dirty="0">
+              <a:rPr lang="en-US" sz="1350" b="1" dirty="0">
                 <a:solidFill>
                   <a:srgbClr val="1A1A1A"/>
                 </a:solidFill>
               </a:rPr>
-              <a:t>Then two judge questions</a:t>
+              <a:t>Run B — the whole pipeline at 7B, extractor included</a:t>
             </a:r>
-            <a:endParaRPr lang="en-US" sz="1450" dirty="0"/>
+            <a:endParaRPr lang="en-US" sz="1350" dirty="0"/>
           </a:p>
         </p:txBody>
       </p:sp>
       <p:sp>
         <p:nvSpPr>
-          <p:cNvPr id="15" name="twoq-b"/>
+          <p:cNvPr id="11" name="bk-b-b"/>
           <p:cNvSpPr txBox="1"/>
           <p:nvPr/>
         </p:nvSpPr>
         <p:spPr>
           <a:xfrm>
-            <a:off x="6473952" y="3803904"/>
-            <a:ext cx="4882896" cy="786384"/>
+            <a:off x="6473952" y="2203704"/>
+            <a:ext cx="4882896" cy="1335024"/>
           </a:xfrm>
           <a:prstGeom prst="rect">
             <a:avLst/>
@@ -18212,7 +17751,7 @@
               <a:buNone/>
             </a:pPr>
             <a:r>
-              <a:rPr lang="en-US" sz="1200" dirty="0">
+              <a:rPr lang="en-US" sz="1050" dirty="0">
                 <a:solidFill>
                   <a:srgbClr val="444444"/>
                 </a:solidFill>
@@ -18220,9 +17759,9 @@
                 <a:ea typeface="Arial" pitchFamily="34" charset="-122"/>
                 <a:cs typeface="Arial" pitchFamily="34" charset="-120"/>
               </a:rPr>
-              <a:t>1. Does the span express a temporal or contingency relation?</a:t>
+              <a:t>Baseline 15.92 facts per answer against 21.50, incomplete rate 0.319, precision 0.5050. Refinement then costs −0.025 precision, against −0.118 in run A.</a:t>
             </a:r>
-            <a:endParaRPr lang="en-US" sz="1200" dirty="0"/>
+            <a:endParaRPr lang="en-US" sz="1050" dirty="0"/>
           </a:p>
           <a:p>
             <a:pPr indent="0" marL="0">
@@ -18232,7 +17771,7 @@
               <a:buNone/>
             </a:pPr>
             <a:r>
-              <a:rPr lang="en-US" sz="1200" dirty="0">
+              <a:rPr lang="en-US" sz="1050" dirty="0">
                 <a:solidFill>
                   <a:srgbClr val="444444"/>
                 </a:solidFill>
@@ -18240,149 +17779,27 @@
                 <a:ea typeface="Arial" pitchFamily="34" charset="-122"/>
                 <a:cs typeface="Arial" pitchFamily="34" charset="-120"/>
               </a:rPr>
-              <a:t>2. Does any single existing fact already capture it?</a:t>
+              <a:t>A stronger extractor writes fewer, coarser, self-contained facts, so there is less to repair — the trade the paper notes for VERIFY (18.5 facts per response against VeriFact's 32.3).</a:t>
             </a:r>
-            <a:endParaRPr lang="en-US" sz="1200" dirty="0"/>
+            <a:endParaRPr lang="en-US" sz="1050" dirty="0"/>
           </a:p>
-        </p:txBody>
-      </p:sp>
-      <p:sp>
-        <p:nvSpPr>
-          <p:cNvPr id="16" name="wm0-rule"/>
-          <p:cNvSpPr/>
-          <p:nvPr/>
-        </p:nvSpPr>
-        <p:spPr>
-          <a:xfrm>
-            <a:off x="548640" y="4937760"/>
-            <a:ext cx="3505200" cy="25603"/>
-          </a:xfrm>
-          <a:prstGeom prst="rect">
-            <a:avLst/>
-          </a:prstGeom>
-          <a:solidFill>
-            <a:srgbClr val="DCDCDC"/>
-          </a:solidFill>
-          <a:ln w="3175">
-            <a:solidFill>
-              <a:srgbClr val="DCDCDC"/>
-            </a:solidFill>
-            <a:prstDash val="solid"/>
-          </a:ln>
-        </p:spPr>
-      </p:sp>
-      <p:sp>
-        <p:nvSpPr>
-          <p:cNvPr id="17" name="wm0-l"/>
-          <p:cNvSpPr txBox="1"/>
-          <p:nvPr/>
-        </p:nvSpPr>
-        <p:spPr>
-          <a:xfrm>
-            <a:off x="548640" y="5084064"/>
-            <a:ext cx="3505200" cy="219456"/>
-          </a:xfrm>
-          <a:prstGeom prst="rect">
-            <a:avLst/>
-          </a:prstGeom>
-          <a:noFill/>
-          <a:ln/>
-        </p:spPr>
-        <p:txBody>
-          <a:bodyPr wrap="square" lIns="0" tIns="0" rIns="0" bIns="0" rtlCol="0" anchor="ctr"/>
-          <a:lstStyle/>
-          <a:p>
-            <a:pPr indent="0" marL="0">
-              <a:buNone/>
-            </a:pPr>
-            <a:r>
-              <a:rPr lang="en-US" sz="950" b="1" spc="100" kern="0" dirty="0">
-                <a:solidFill>
-                  <a:srgbClr val="767676"/>
-                </a:solidFill>
-                <a:latin typeface="Arial" pitchFamily="34" charset="0"/>
-                <a:ea typeface="Arial" pitchFamily="34" charset="-122"/>
-                <a:cs typeface="Arial" pitchFamily="34" charset="-120"/>
-              </a:rPr>
-              <a:t>CHARACTER COVERAGE</a:t>
-            </a:r>
-            <a:endParaRPr lang="en-US" sz="950" dirty="0"/>
-          </a:p>
-        </p:txBody>
-      </p:sp>
-      <p:sp>
-        <p:nvSpPr>
-          <p:cNvPr id="18" name="wm0-v"/>
-          <p:cNvSpPr txBox="1"/>
-          <p:nvPr/>
-        </p:nvSpPr>
-        <p:spPr>
-          <a:xfrm>
-            <a:off x="548640" y="5321808"/>
-            <a:ext cx="3505200" cy="457200"/>
-          </a:xfrm>
-          <a:prstGeom prst="rect">
-            <a:avLst/>
-          </a:prstGeom>
-          <a:noFill/>
-          <a:ln/>
-        </p:spPr>
-        <p:txBody>
-          <a:bodyPr wrap="square" lIns="0" tIns="0" rIns="0" bIns="0" rtlCol="0" anchor="ctr"/>
-          <a:lstStyle/>
-          <a:p>
-            <a:pPr indent="0" marL="0">
-              <a:buNone/>
-            </a:pPr>
-            <a:r>
-              <a:rPr lang="en-US" sz="2200" b="1" dirty="0">
-                <a:solidFill>
-                  <a:srgbClr val="1A1A1A"/>
-                </a:solidFill>
-              </a:rPr>
-              <a:t>0.55–0.59</a:t>
-            </a:r>
-            <a:endParaRPr lang="en-US" sz="2200" dirty="0"/>
-          </a:p>
-        </p:txBody>
-      </p:sp>
-      <p:sp>
-        <p:nvSpPr>
-          <p:cNvPr id="19" name="wm0-f"/>
-          <p:cNvSpPr txBox="1"/>
-          <p:nvPr/>
-        </p:nvSpPr>
-        <p:spPr>
-          <a:xfrm>
-            <a:off x="548640" y="5806440"/>
-            <a:ext cx="3505200" cy="420624"/>
-          </a:xfrm>
-          <a:prstGeom prst="rect">
-            <a:avLst/>
-          </a:prstGeom>
-          <a:noFill/>
-          <a:ln/>
-        </p:spPr>
-        <p:txBody>
-          <a:bodyPr wrap="square" lIns="0" tIns="0" rIns="0" bIns="0" rtlCol="0" anchor="ctr"/>
-          <a:lstStyle/>
           <a:p>
             <a:pPr indent="0" marL="0">
               <a:lnSpc>
-                <a:spcPct val="110000"/>
+                <a:spcPct val="125000"/>
               </a:lnSpc>
               <a:buNone/>
             </a:pPr>
             <a:r>
               <a:rPr lang="en-US" sz="1050" dirty="0">
                 <a:solidFill>
-                  <a:srgbClr val="767676"/>
+                  <a:srgbClr val="444444"/>
                 </a:solidFill>
                 <a:latin typeface="Arial" pitchFamily="34" charset="0"/>
                 <a:ea typeface="Arial" pitchFamily="34" charset="-122"/>
                 <a:cs typeface="Arial" pitchFamily="34" charset="-120"/>
               </a:rPr>
-              <a:t>of the response matched</a:t>
+              <a:t>B changed four things at once, so it reads only against its own baseline.</a:t>
             </a:r>
             <a:endParaRPr lang="en-US" sz="1050" dirty="0"/>
           </a:p>
@@ -18390,24 +17807,24 @@
       </p:sp>
       <p:sp>
         <p:nvSpPr>
-          <p:cNvPr id="20" name="wm1-rule"/>
+          <p:cNvPr id="12" name="bk-q"/>
           <p:cNvSpPr/>
           <p:nvPr/>
         </p:nvSpPr>
         <p:spPr>
           <a:xfrm>
-            <a:off x="4328160" y="4937760"/>
-            <a:ext cx="3505200" cy="25603"/>
+            <a:off x="548640" y="3886200"/>
+            <a:ext cx="5394960" cy="2103120"/>
           </a:xfrm>
           <a:prstGeom prst="rect">
             <a:avLst/>
           </a:prstGeom>
           <a:solidFill>
-            <a:srgbClr val="DCDCDC"/>
+            <a:srgbClr val="F4F4F4"/>
           </a:solidFill>
-          <a:ln w="3175">
+          <a:ln w="9525">
             <a:solidFill>
-              <a:srgbClr val="DCDCDC"/>
+              <a:srgbClr val="F4F4F4"/>
             </a:solidFill>
             <a:prstDash val="solid"/>
           </a:ln>
@@ -18415,131 +17832,14 @@
       </p:sp>
       <p:sp>
         <p:nvSpPr>
-          <p:cNvPr id="21" name="wm1-l"/>
-          <p:cNvSpPr txBox="1"/>
-          <p:nvPr/>
-        </p:nvSpPr>
-        <p:spPr>
-          <a:xfrm>
-            <a:off x="4328160" y="5084064"/>
-            <a:ext cx="3505200" cy="219456"/>
-          </a:xfrm>
-          <a:prstGeom prst="rect">
-            <a:avLst/>
-          </a:prstGeom>
-          <a:noFill/>
-          <a:ln/>
-        </p:spPr>
-        <p:txBody>
-          <a:bodyPr wrap="square" lIns="0" tIns="0" rIns="0" bIns="0" rtlCol="0" anchor="ctr"/>
-          <a:lstStyle/>
-          <a:p>
-            <a:pPr indent="0" marL="0">
-              <a:buNone/>
-            </a:pPr>
-            <a:r>
-              <a:rPr lang="en-US" sz="950" b="1" spc="100" kern="0" dirty="0">
-                <a:solidFill>
-                  <a:srgbClr val="767676"/>
-                </a:solidFill>
-                <a:latin typeface="Arial" pitchFamily="34" charset="0"/>
-                <a:ea typeface="Arial" pitchFamily="34" charset="-122"/>
-                <a:cs typeface="Arial" pitchFamily="34" charset="-120"/>
-              </a:rPr>
-              <a:t>CANDIDATE SPANS FOUND</a:t>
-            </a:r>
-            <a:endParaRPr lang="en-US" sz="950" dirty="0"/>
-          </a:p>
-        </p:txBody>
-      </p:sp>
-      <p:sp>
-        <p:nvSpPr>
-          <p:cNvPr id="22" name="wm1-v"/>
-          <p:cNvSpPr txBox="1"/>
-          <p:nvPr/>
-        </p:nvSpPr>
-        <p:spPr>
-          <a:xfrm>
-            <a:off x="4328160" y="5321808"/>
-            <a:ext cx="3505200" cy="457200"/>
-          </a:xfrm>
-          <a:prstGeom prst="rect">
-            <a:avLst/>
-          </a:prstGeom>
-          <a:noFill/>
-          <a:ln/>
-        </p:spPr>
-        <p:txBody>
-          <a:bodyPr wrap="square" lIns="0" tIns="0" rIns="0" bIns="0" rtlCol="0" anchor="ctr"/>
-          <a:lstStyle/>
-          <a:p>
-            <a:pPr indent="0" marL="0">
-              <a:buNone/>
-            </a:pPr>
-            <a:r>
-              <a:rPr lang="en-US" sz="2200" b="1" dirty="0">
-                <a:solidFill>
-                  <a:srgbClr val="1A1A1A"/>
-                </a:solidFill>
-              </a:rPr>
-              <a:t>73</a:t>
-            </a:r>
-            <a:endParaRPr lang="en-US" sz="2200" dirty="0"/>
-          </a:p>
-        </p:txBody>
-      </p:sp>
-      <p:sp>
-        <p:nvSpPr>
-          <p:cNvPr id="23" name="wm1-f"/>
-          <p:cNvSpPr txBox="1"/>
-          <p:nvPr/>
-        </p:nvSpPr>
-        <p:spPr>
-          <a:xfrm>
-            <a:off x="4328160" y="5806440"/>
-            <a:ext cx="3505200" cy="420624"/>
-          </a:xfrm>
-          <a:prstGeom prst="rect">
-            <a:avLst/>
-          </a:prstGeom>
-          <a:noFill/>
-          <a:ln/>
-        </p:spPr>
-        <p:txBody>
-          <a:bodyPr wrap="square" lIns="0" tIns="0" rIns="0" bIns="0" rtlCol="0" anchor="ctr"/>
-          <a:lstStyle/>
-          <a:p>
-            <a:pPr indent="0" marL="0">
-              <a:lnSpc>
-                <a:spcPct val="110000"/>
-              </a:lnSpc>
-              <a:buNone/>
-            </a:pPr>
-            <a:r>
-              <a:rPr lang="en-US" sz="1050" dirty="0">
-                <a:solidFill>
-                  <a:srgbClr val="767676"/>
-                </a:solidFill>
-                <a:latin typeface="Arial" pitchFamily="34" charset="0"/>
-                <a:ea typeface="Arial" pitchFamily="34" charset="-122"/>
-                <a:cs typeface="Arial" pitchFamily="34" charset="-120"/>
-              </a:rPr>
-              <a:t>across 12 answers</a:t>
-            </a:r>
-            <a:endParaRPr lang="en-US" sz="1050" dirty="0"/>
-          </a:p>
-        </p:txBody>
-      </p:sp>
-      <p:sp>
-        <p:nvSpPr>
-          <p:cNvPr id="24" name="wm2-rule"/>
+          <p:cNvPr id="13" name="bk-q-edge"/>
           <p:cNvSpPr/>
           <p:nvPr/>
         </p:nvSpPr>
         <p:spPr>
           <a:xfrm>
-            <a:off x="8107680" y="4937760"/>
-            <a:ext cx="3505200" cy="25603"/>
+            <a:off x="548640" y="3886200"/>
+            <a:ext cx="29261" cy="2103120"/>
           </a:xfrm>
           <a:prstGeom prst="rect">
             <a:avLst/>
@@ -18557,14 +17857,14 @@
       </p:sp>
       <p:sp>
         <p:nvSpPr>
-          <p:cNvPr id="25" name="wm2-l"/>
+          <p:cNvPr id="14" name="bk-q-h"/>
           <p:cNvSpPr txBox="1"/>
           <p:nvPr/>
         </p:nvSpPr>
         <p:spPr>
           <a:xfrm>
-            <a:off x="8107680" y="5084064"/>
-            <a:ext cx="3505200" cy="219456"/>
+            <a:off x="804672" y="4087368"/>
+            <a:ext cx="4882896" cy="292608"/>
           </a:xfrm>
           <a:prstGeom prst="rect">
             <a:avLst/>
@@ -18580,30 +17880,134 @@
               <a:buNone/>
             </a:pPr>
             <a:r>
-              <a:rPr lang="en-US" sz="950" b="1" spc="100" kern="0" dirty="0">
+              <a:rPr lang="en-US" sz="1350" b="1" dirty="0">
                 <a:solidFill>
-                  <a:srgbClr val="767676"/>
+                  <a:srgbClr val="E90802"/>
+                </a:solidFill>
+              </a:rPr>
+              <a:t>What the 3B refiner actually writes</a:t>
+            </a:r>
+            <a:endParaRPr lang="en-US" sz="1350" dirty="0"/>
+          </a:p>
+        </p:txBody>
+      </p:sp>
+      <p:sp>
+        <p:nvSpPr>
+          <p:cNvPr id="15" name="bk-q-b"/>
+          <p:cNvSpPr txBox="1"/>
+          <p:nvPr/>
+        </p:nvSpPr>
+        <p:spPr>
+          <a:xfrm>
+            <a:off x="804672" y="4489704"/>
+            <a:ext cx="4882896" cy="1335024"/>
+          </a:xfrm>
+          <a:prstGeom prst="rect">
+            <a:avLst/>
+          </a:prstGeom>
+          <a:noFill/>
+          <a:ln/>
+        </p:spPr>
+        <p:txBody>
+          <a:bodyPr wrap="square" lIns="0" tIns="0" rIns="0" bIns="0" rtlCol="0" anchor="t"/>
+          <a:lstStyle/>
+          <a:p>
+            <a:pPr indent="0" marL="0">
+              <a:lnSpc>
+                <a:spcPct val="125000"/>
+              </a:lnSpc>
+              <a:buNone/>
+            </a:pPr>
+            <a:r>
+              <a:rPr lang="en-US" sz="1050" dirty="0">
+                <a:solidFill>
+                  <a:srgbClr val="444444"/>
                 </a:solidFill>
                 <a:latin typeface="Arial" pitchFamily="34" charset="0"/>
                 <a:ea typeface="Arial" pitchFamily="34" charset="-122"/>
                 <a:cs typeface="Arial" pitchFamily="34" charset="-120"/>
               </a:rPr>
-              <a:t>FACT ADDED ONLY WHEN</a:t>
+              <a:t>Works — Q10:  “These substances are in the atmosphere.” becomes “… since the Montreal Protocol was signed.”   UNDECIDED → SUPPORTED.</a:t>
             </a:r>
-            <a:endParaRPr lang="en-US" sz="950" dirty="0"/>
+            <a:endParaRPr lang="en-US" sz="1050" dirty="0"/>
+          </a:p>
+          <a:p>
+            <a:pPr indent="0" marL="0">
+              <a:lnSpc>
+                <a:spcPct val="125000"/>
+              </a:lnSpc>
+              <a:buNone/>
+            </a:pPr>
+            <a:r>
+              <a:rPr lang="en-US" sz="1050" dirty="0">
+                <a:solidFill>
+                  <a:srgbClr val="444444"/>
+                </a:solidFill>
+                <a:latin typeface="Arial" pitchFamily="34" charset="0"/>
+                <a:ea typeface="Arial" pitchFamily="34" charset="-122"/>
+                <a:cs typeface="Arial" pitchFamily="34" charset="-120"/>
+              </a:rPr>
+              <a:t>Fails — Q01:  “There was demand for gold as jewelry.” becomes “There was NO demand …”. The hypothetical from the question was pasted into a fact stating the opposite.</a:t>
+            </a:r>
+            <a:endParaRPr lang="en-US" sz="1050" dirty="0"/>
+          </a:p>
+          <a:p>
+            <a:pPr indent="0" marL="0">
+              <a:lnSpc>
+                <a:spcPct val="125000"/>
+              </a:lnSpc>
+              <a:buNone/>
+            </a:pPr>
+            <a:r>
+              <a:rPr lang="en-US" sz="1050" dirty="0">
+                <a:solidFill>
+                  <a:srgbClr val="444444"/>
+                </a:solidFill>
+                <a:latin typeface="Arial" pitchFamily="34" charset="0"/>
+                <a:ea typeface="Arial" pitchFamily="34" charset="-122"/>
+                <a:cs typeface="Arial" pitchFamily="34" charset="-120"/>
+              </a:rPr>
+              <a:t>Added relation — Q04:  “The experiment just before the explosion caused the reactor to exceed its design limits …”</a:t>
+            </a:r>
+            <a:endParaRPr lang="en-US" sz="1050" dirty="0"/>
           </a:p>
         </p:txBody>
       </p:sp>
       <p:sp>
         <p:nvSpPr>
-          <p:cNvPr id="26" name="wm2-v"/>
+          <p:cNvPr id="16" name="bk-haz"/>
+          <p:cNvSpPr/>
+          <p:nvPr/>
+        </p:nvSpPr>
+        <p:spPr>
+          <a:xfrm>
+            <a:off x="6217920" y="3886200"/>
+            <a:ext cx="5394960" cy="2103120"/>
+          </a:xfrm>
+          <a:prstGeom prst="rect">
+            <a:avLst/>
+          </a:prstGeom>
+          <a:solidFill>
+            <a:srgbClr val="FFFFFF"/>
+          </a:solidFill>
+          <a:ln w="9525">
+            <a:solidFill>
+              <a:srgbClr val="DCDCDC"/>
+            </a:solidFill>
+            <a:prstDash val="solid"/>
+          </a:ln>
+        </p:spPr>
+      </p:sp>
+      <p:sp>
+        <p:nvSpPr>
+          <p:cNvPr id="17" name="bk-haz-h"/>
           <p:cNvSpPr txBox="1"/>
           <p:nvPr/>
         </p:nvSpPr>
         <p:spPr>
           <a:xfrm>
-            <a:off x="8107680" y="5321808"/>
-            <a:ext cx="3505200" cy="457200"/>
+            <a:off x="6473952" y="4087368"/>
+            <a:ext cx="4882896" cy="292608"/>
           </a:xfrm>
           <a:prstGeom prst="rect">
             <a:avLst/>
@@ -18619,27 +18023,27 @@
               <a:buNone/>
             </a:pPr>
             <a:r>
-              <a:rPr lang="en-US" sz="1600" b="1" dirty="0">
+              <a:rPr lang="en-US" sz="1350" b="1" dirty="0">
                 <a:solidFill>
-                  <a:srgbClr val="E90802"/>
+                  <a:srgbClr val="1A1A1A"/>
                 </a:solidFill>
               </a:rPr>
-              <a:t>relation ∧ ¬covered</a:t>
+              <a:t>Engineering hazards behind these numbers</a:t>
             </a:r>
-            <a:endParaRPr lang="en-US" sz="1600" dirty="0"/>
+            <a:endParaRPr lang="en-US" sz="1350" dirty="0"/>
           </a:p>
         </p:txBody>
       </p:sp>
       <p:sp>
         <p:nvSpPr>
-          <p:cNvPr id="27" name="wm2-f"/>
+          <p:cNvPr id="18" name="bk-haz-b"/>
           <p:cNvSpPr txBox="1"/>
           <p:nvPr/>
         </p:nvSpPr>
         <p:spPr>
           <a:xfrm>
-            <a:off x="8107680" y="5806440"/>
-            <a:ext cx="3505200" cy="420624"/>
+            <a:off x="6473952" y="4489704"/>
+            <a:ext cx="4882896" cy="1335024"/>
           </a:xfrm>
           <a:prstGeom prst="rect">
             <a:avLst/>
@@ -18648,25 +18052,65 @@
           <a:ln/>
         </p:spPr>
         <p:txBody>
-          <a:bodyPr wrap="square" lIns="0" tIns="0" rIns="0" bIns="0" rtlCol="0" anchor="ctr"/>
+          <a:bodyPr wrap="square" lIns="0" tIns="0" rIns="0" bIns="0" rtlCol="0" anchor="t"/>
           <a:lstStyle/>
           <a:p>
             <a:pPr indent="0" marL="0">
               <a:lnSpc>
-                <a:spcPct val="110000"/>
+                <a:spcPct val="125000"/>
               </a:lnSpc>
               <a:buNone/>
             </a:pPr>
             <a:r>
               <a:rPr lang="en-US" sz="1050" dirty="0">
                 <a:solidFill>
-                  <a:srgbClr val="767676"/>
+                  <a:srgbClr val="444444"/>
                 </a:solidFill>
                 <a:latin typeface="Arial" pitchFamily="34" charset="0"/>
                 <a:ea typeface="Arial" pitchFamily="34" charset="-122"/>
                 <a:cs typeface="Arial" pitchFamily="34" charset="-120"/>
               </a:rPr>
-              <a:t>both judge questions pass</a:t>
+              <a:t>GPU:  two 3B Q4_K_M judges do not fit in 4 GB, so the pipeline drives one judge over the whole fact list, then releases its weights — otherwise every call pays a ~20 s model load.</a:t>
+            </a:r>
+            <a:endParaRPr lang="en-US" sz="1050" dirty="0"/>
+          </a:p>
+          <a:p>
+            <a:pPr indent="0" marL="0">
+              <a:lnSpc>
+                <a:spcPct val="125000"/>
+              </a:lnSpc>
+              <a:buNone/>
+            </a:pPr>
+            <a:r>
+              <a:rPr lang="en-US" sz="1050" dirty="0">
+                <a:solidFill>
+                  <a:srgbClr val="444444"/>
+                </a:solidFill>
+                <a:latin typeface="Arial" pitchFamily="34" charset="0"/>
+                <a:ea typeface="Arial" pitchFamily="34" charset="-122"/>
+                <a:cs typeface="Arial" pitchFamily="34" charset="-120"/>
+              </a:rPr>
+              <a:t>Retrieval:  Wikipedia rate-limits unauthenticated clients and failures are not cached, so without retries a 429 silently becomes “no evidence”. Fixed with retries and backoff.</a:t>
+            </a:r>
+            <a:endParaRPr lang="en-US" sz="1050" dirty="0"/>
+          </a:p>
+          <a:p>
+            <a:pPr indent="0" marL="0">
+              <a:lnSpc>
+                <a:spcPct val="125000"/>
+              </a:lnSpc>
+              <a:buNone/>
+            </a:pPr>
+            <a:r>
+              <a:rPr lang="en-US" sz="1050" dirty="0">
+                <a:solidFill>
+                  <a:srgbClr val="444444"/>
+                </a:solidFill>
+                <a:latin typeface="Arial" pitchFamily="34" charset="0"/>
+                <a:ea typeface="Arial" pitchFamily="34" charset="-122"/>
+                <a:cs typeface="Arial" pitchFamily="34" charset="-120"/>
+              </a:rPr>
+              <a:t>Replay:  every LLM call is cached under hash(model + prompt + parameters).</a:t>
             </a:r>
             <a:endParaRPr lang="en-US" sz="1050" dirty="0"/>
           </a:p>
@@ -18674,7 +18118,7 @@
       </p:sp>
       <p:sp>
         <p:nvSpPr>
-          <p:cNvPr id="28" name="note"/>
+          <p:cNvPr id="19" name="note"/>
           <p:cNvSpPr txBox="1"/>
           <p:nvPr/>
         </p:nvSpPr>
@@ -18705,7 +18149,7 @@
                 <a:ea typeface="Arial" pitchFamily="34" charset="-122"/>
                 <a:cs typeface="Arial" pitchFamily="34" charset="-120"/>
               </a:rPr>
-              <a:t>Kept lexical, as in the paper. A semantic variant is listed as future work rather than silently substituted.</a:t>
+              <a:t>Full write-up in README.md and colab/RESULTS.md. All three runs reproduce from one command with no GPU.</a:t>
             </a:r>
             <a:endParaRPr lang="en-US" sz="950" dirty="0"/>
           </a:p>
@@ -18751,2388 +18195,6 @@
             <a:fld id="{F7021451-1387-4CA6-816F-3879F97B5CBC}" type="slidenum">
               <a:rPr b="0" lang="en-US"/>
               <a:t>16</a:t>
-            </a:fld>
-            <a:endParaRPr lang="en-US"/>
-          </a:p>
-        </p:txBody>
-      </p:sp>
-    </p:spTree>
-  </p:cSld>
-  <p:clrMapOvr>
-    <a:masterClrMapping/>
-  </p:clrMapOvr>
-</p:sld>
-</file>
-
-<file path=ppt/slides/slide17.xml><?xml version="1.0" encoding="utf-8"?>
-<p:sld xmlns:a="http://schemas.openxmlformats.org/drawingml/2006/main" xmlns:r="http://schemas.openxmlformats.org/officeDocument/2006/relationships" xmlns:p="http://schemas.openxmlformats.org/presentationml/2006/main">
-  <p:cSld name="Slide 17">
-    <p:spTree>
-      <p:nvGrpSpPr>
-        <p:cNvPr id="1" name=""/>
-        <p:cNvGrpSpPr/>
-        <p:nvPr/>
-      </p:nvGrpSpPr>
-      <p:grpSpPr>
-        <a:xfrm>
-          <a:off x="0" y="0"/>
-          <a:ext cx="0" cy="0"/>
-          <a:chOff x="0" y="0"/>
-          <a:chExt cx="0" cy="0"/>
-        </a:xfrm>
-      </p:grpSpPr>
-      <p:sp>
-        <p:nvSpPr>
-          <p:cNvPr id="2" name="eyebrow"/>
-          <p:cNvSpPr txBox="1"/>
-          <p:nvPr/>
-        </p:nvSpPr>
-        <p:spPr>
-          <a:xfrm>
-            <a:off x="548640" y="347472"/>
-            <a:ext cx="11064240" cy="237744"/>
-          </a:xfrm>
-          <a:prstGeom prst="rect">
-            <a:avLst/>
-          </a:prstGeom>
-          <a:noFill/>
-          <a:ln/>
-        </p:spPr>
-        <p:txBody>
-          <a:bodyPr wrap="square" lIns="0" tIns="0" rIns="0" bIns="0" rtlCol="0" anchor="ctr"/>
-          <a:lstStyle/>
-          <a:p>
-            <a:pPr indent="0" marL="0">
-              <a:buNone/>
-            </a:pPr>
-            <a:r>
-              <a:rPr lang="en-US" sz="1000" b="1" spc="200" kern="0" dirty="0">
-                <a:solidFill>
-                  <a:srgbClr val="E90802"/>
-                </a:solidFill>
-                <a:latin typeface="Arial" pitchFamily="34" charset="0"/>
-                <a:ea typeface="Arial" pitchFamily="34" charset="-122"/>
-                <a:cs typeface="Arial" pitchFamily="34" charset="-120"/>
-              </a:rPr>
-              <a:t>APPENDIX — NOT PRESENTED</a:t>
-            </a:r>
-            <a:endParaRPr lang="en-US" sz="1000" dirty="0"/>
-          </a:p>
-        </p:txBody>
-      </p:sp>
-      <p:sp>
-        <p:nvSpPr>
-          <p:cNvPr id="3" name="title"/>
-          <p:cNvSpPr txBox="1"/>
-          <p:nvPr/>
-        </p:nvSpPr>
-        <p:spPr>
-          <a:xfrm>
-            <a:off x="548640" y="621792"/>
-            <a:ext cx="11064240" cy="548640"/>
-          </a:xfrm>
-          <a:prstGeom prst="rect">
-            <a:avLst/>
-          </a:prstGeom>
-          <a:noFill/>
-          <a:ln/>
-        </p:spPr>
-        <p:txBody>
-          <a:bodyPr wrap="square" lIns="0" tIns="0" rIns="0" bIns="0" rtlCol="0" anchor="ctr"/>
-          <a:lstStyle/>
-          <a:p>
-            <a:pPr indent="0" marL="0">
-              <a:buNone/>
-            </a:pPr>
-            <a:r>
-              <a:rPr lang="en-US" sz="2700" b="1" dirty="0">
-                <a:solidFill>
-                  <a:srgbClr val="1A1A1A"/>
-                </a:solidFill>
-              </a:rPr>
-              <a:t>What a 3B refiner actually produces</a:t>
-            </a:r>
-            <a:endParaRPr lang="en-US" sz="2700" dirty="0"/>
-          </a:p>
-        </p:txBody>
-      </p:sp>
-      <p:sp>
-        <p:nvSpPr>
-          <p:cNvPr id="4" name="subtitle"/>
-          <p:cNvSpPr txBox="1"/>
-          <p:nvPr/>
-        </p:nvSpPr>
-        <p:spPr>
-          <a:xfrm>
-            <a:off x="548640" y="1188720"/>
-            <a:ext cx="11064240" cy="256032"/>
-          </a:xfrm>
-          <a:prstGeom prst="rect">
-            <a:avLst/>
-          </a:prstGeom>
-          <a:noFill/>
-          <a:ln/>
-        </p:spPr>
-        <p:txBody>
-          <a:bodyPr wrap="square" lIns="0" tIns="0" rIns="0" bIns="0" rtlCol="0" anchor="ctr"/>
-          <a:lstStyle/>
-          <a:p>
-            <a:pPr indent="0" marL="0">
-              <a:buNone/>
-            </a:pPr>
-            <a:r>
-              <a:rPr lang="en-US" sz="1350" dirty="0">
-                <a:solidFill>
-                  <a:srgbClr val="767676"/>
-                </a:solidFill>
-                <a:latin typeface="Arial" pitchFamily="34" charset="0"/>
-                <a:ea typeface="Arial" pitchFamily="34" charset="-122"/>
-                <a:cs typeface="Arial" pitchFamily="34" charset="-120"/>
-              </a:rPr>
-              <a:t>One case that works, one that does not, and one added relation</a:t>
-            </a:r>
-            <a:endParaRPr lang="en-US" sz="1350" dirty="0"/>
-          </a:p>
-        </p:txBody>
-      </p:sp>
-      <p:sp>
-        <p:nvSpPr>
-          <p:cNvPr id="5" name="head-rule"/>
-          <p:cNvSpPr/>
-          <p:nvPr/>
-        </p:nvSpPr>
-        <p:spPr>
-          <a:xfrm>
-            <a:off x="548640" y="1499616"/>
-            <a:ext cx="11064240" cy="10973"/>
-          </a:xfrm>
-          <a:prstGeom prst="rect">
-            <a:avLst/>
-          </a:prstGeom>
-          <a:solidFill>
-            <a:srgbClr val="DCDCDC"/>
-          </a:solidFill>
-          <a:ln w="3175">
-            <a:solidFill>
-              <a:srgbClr val="DCDCDC"/>
-            </a:solidFill>
-            <a:prstDash val="solid"/>
-          </a:ln>
-        </p:spPr>
-      </p:sp>
-      <p:sp>
-        <p:nvSpPr>
-          <p:cNvPr id="6" name="good"/>
-          <p:cNvSpPr/>
-          <p:nvPr/>
-        </p:nvSpPr>
-        <p:spPr>
-          <a:xfrm>
-            <a:off x="548640" y="1600200"/>
-            <a:ext cx="5394960" cy="2834640"/>
-          </a:xfrm>
-          <a:prstGeom prst="rect">
-            <a:avLst/>
-          </a:prstGeom>
-          <a:solidFill>
-            <a:srgbClr val="FFFFFF"/>
-          </a:solidFill>
-          <a:ln w="9525">
-            <a:solidFill>
-              <a:srgbClr val="DCDCDC"/>
-            </a:solidFill>
-            <a:prstDash val="solid"/>
-          </a:ln>
-        </p:spPr>
-      </p:sp>
-      <p:sp>
-        <p:nvSpPr>
-          <p:cNvPr id="7" name="good-edge"/>
-          <p:cNvSpPr/>
-          <p:nvPr/>
-        </p:nvSpPr>
-        <p:spPr>
-          <a:xfrm>
-            <a:off x="548640" y="1600200"/>
-            <a:ext cx="29261" cy="2834640"/>
-          </a:xfrm>
-          <a:prstGeom prst="rect">
-            <a:avLst/>
-          </a:prstGeom>
-          <a:solidFill>
-            <a:srgbClr val="E90802"/>
-          </a:solidFill>
-          <a:ln w="3175">
-            <a:solidFill>
-              <a:srgbClr val="E90802"/>
-            </a:solidFill>
-            <a:prstDash val="solid"/>
-          </a:ln>
-        </p:spPr>
-      </p:sp>
-      <p:sp>
-        <p:nvSpPr>
-          <p:cNvPr id="8" name="good-h"/>
-          <p:cNvSpPr txBox="1"/>
-          <p:nvPr/>
-        </p:nvSpPr>
-        <p:spPr>
-          <a:xfrm>
-            <a:off x="804672" y="1801368"/>
-            <a:ext cx="4882896" cy="292608"/>
-          </a:xfrm>
-          <a:prstGeom prst="rect">
-            <a:avLst/>
-          </a:prstGeom>
-          <a:noFill/>
-          <a:ln/>
-        </p:spPr>
-        <p:txBody>
-          <a:bodyPr wrap="square" lIns="0" tIns="0" rIns="0" bIns="0" rtlCol="0" anchor="ctr"/>
-          <a:lstStyle/>
-          <a:p>
-            <a:pPr indent="0" marL="0">
-              <a:buNone/>
-            </a:pPr>
-            <a:r>
-              <a:rPr lang="en-US" sz="1450" b="1" dirty="0">
-                <a:solidFill>
-                  <a:srgbClr val="E90802"/>
-                </a:solidFill>
-              </a:rPr>
-              <a:t>Works — Q10, ozone layer</a:t>
-            </a:r>
-            <a:endParaRPr lang="en-US" sz="1450" dirty="0"/>
-          </a:p>
-        </p:txBody>
-      </p:sp>
-      <p:sp>
-        <p:nvSpPr>
-          <p:cNvPr id="9" name="good-t"/>
-          <p:cNvSpPr txBox="1"/>
-          <p:nvPr/>
-        </p:nvSpPr>
-        <p:spPr>
-          <a:xfrm>
-            <a:off x="804672" y="2103120"/>
-            <a:ext cx="4882896" cy="2240280"/>
-          </a:xfrm>
-          <a:prstGeom prst="rect">
-            <a:avLst/>
-          </a:prstGeom>
-          <a:noFill/>
-          <a:ln/>
-        </p:spPr>
-        <p:txBody>
-          <a:bodyPr wrap="square" lIns="0" tIns="0" rIns="0" bIns="0" rtlCol="0" anchor="ctr"/>
-          <a:lstStyle/>
-          <a:p>
-            <a:pPr indent="0" marL="0">
-              <a:lnSpc>
-                <a:spcPct val="115000"/>
-              </a:lnSpc>
-              <a:buNone/>
-            </a:pPr>
-            <a:r>
-              <a:rPr lang="en-US" sz="1050" dirty="0">
-                <a:solidFill>
-                  <a:srgbClr val="767676"/>
-                </a:solidFill>
-                <a:latin typeface="Arial" pitchFamily="34" charset="0"/>
-                <a:ea typeface="Arial" pitchFamily="34" charset="-122"/>
-                <a:cs typeface="Arial" pitchFamily="34" charset="-120"/>
-              </a:rPr>
-              <a:t>omitted_condition_or_source</a:t>
-            </a:r>
-            <a:endParaRPr lang="en-US" sz="1150" dirty="0"/>
-          </a:p>
-          <a:p>
-            <a:pPr indent="0" marL="0">
-              <a:lnSpc>
-                <a:spcPct val="115000"/>
-              </a:lnSpc>
-              <a:buNone/>
-            </a:pPr>
-            <a:r>
-              <a:rPr lang="en-US" sz="1150" dirty="0">
-                <a:solidFill>
-                  <a:srgbClr val="444444"/>
-                </a:solidFill>
-                <a:latin typeface="Arial" pitchFamily="34" charset="0"/>
-                <a:ea typeface="Arial" pitchFamily="34" charset="-122"/>
-                <a:cs typeface="Arial" pitchFamily="34" charset="-120"/>
-              </a:rPr>
-              <a:t>before   “These substances are in the atmosphere.”</a:t>
-            </a:r>
-            <a:endParaRPr lang="en-US" sz="1150" dirty="0"/>
-          </a:p>
-          <a:p>
-            <a:pPr indent="0" marL="0">
-              <a:lnSpc>
-                <a:spcPct val="115000"/>
-              </a:lnSpc>
-              <a:buNone/>
-            </a:pPr>
-            <a:r>
-              <a:rPr lang="en-US" sz="1150" dirty="0">
-                <a:solidFill>
-                  <a:srgbClr val="444444"/>
-                </a:solidFill>
-                <a:latin typeface="Arial" pitchFamily="34" charset="0"/>
-                <a:ea typeface="Arial" pitchFamily="34" charset="-122"/>
-                <a:cs typeface="Arial" pitchFamily="34" charset="-120"/>
-              </a:rPr>
-              <a:t>after     “The substances are in the atmosphere since the Montreal Protocol was signed.”</a:t>
-            </a:r>
-            <a:endParaRPr lang="en-US" sz="1150" dirty="0"/>
-          </a:p>
-          <a:p>
-            <a:pPr indent="0" marL="0">
-              <a:lnSpc>
-                <a:spcPct val="115000"/>
-              </a:lnSpc>
-              <a:buNone/>
-            </a:pPr>
-            <a:r>
-              <a:rPr lang="en-US" sz="1150" b="1" dirty="0">
-                <a:solidFill>
-                  <a:srgbClr val="E90802"/>
-                </a:solidFill>
-                <a:latin typeface="Arial" pitchFamily="34" charset="0"/>
-                <a:ea typeface="Arial" pitchFamily="34" charset="-122"/>
-                <a:cs typeface="Arial" pitchFamily="34" charset="-120"/>
-              </a:rPr>
-              <a:t>UNDECIDED → SUPPORTED</a:t>
-            </a:r>
-            <a:endParaRPr lang="en-US" sz="1150" dirty="0"/>
-          </a:p>
-          <a:p>
-            <a:pPr indent="0" marL="0">
-              <a:lnSpc>
-                <a:spcPct val="115000"/>
-              </a:lnSpc>
-              <a:buNone/>
-            </a:pPr>
-            <a:r>
-              <a:rPr lang="en-US" sz="600" dirty="0">
-                <a:solidFill>
-                  <a:srgbClr val="444444"/>
-                </a:solidFill>
-                <a:latin typeface="Arial" pitchFamily="34" charset="0"/>
-                <a:ea typeface="Arial" pitchFamily="34" charset="-122"/>
-                <a:cs typeface="Arial" pitchFamily="34" charset="-120"/>
-              </a:rPr>
-              <a:t> </a:t>
-            </a:r>
-            <a:endParaRPr lang="en-US" sz="1150" dirty="0"/>
-          </a:p>
-          <a:p>
-            <a:pPr indent="0" marL="0">
-              <a:lnSpc>
-                <a:spcPct val="115000"/>
-              </a:lnSpc>
-              <a:buNone/>
-            </a:pPr>
-            <a:r>
-              <a:rPr lang="en-US" sz="1050" dirty="0">
-                <a:solidFill>
-                  <a:srgbClr val="767676"/>
-                </a:solidFill>
-                <a:latin typeface="Arial" pitchFamily="34" charset="0"/>
-                <a:ea typeface="Arial" pitchFamily="34" charset="-122"/>
-                <a:cs typeface="Arial" pitchFamily="34" charset="-120"/>
-              </a:rPr>
-              <a:t>missing_comparison</a:t>
-            </a:r>
-            <a:endParaRPr lang="en-US" sz="1150" dirty="0"/>
-          </a:p>
-          <a:p>
-            <a:pPr indent="0" marL="0">
-              <a:lnSpc>
-                <a:spcPct val="115000"/>
-              </a:lnSpc>
-              <a:buNone/>
-            </a:pPr>
-            <a:r>
-              <a:rPr lang="en-US" sz="1150" dirty="0">
-                <a:solidFill>
-                  <a:srgbClr val="444444"/>
-                </a:solidFill>
-                <a:latin typeface="Arial" pitchFamily="34" charset="0"/>
-                <a:ea typeface="Arial" pitchFamily="34" charset="-122"/>
-                <a:cs typeface="Arial" pitchFamily="34" charset="-120"/>
-              </a:rPr>
-              <a:t>before   “The decrease is in the concentration of substances.”</a:t>
-            </a:r>
-            <a:endParaRPr lang="en-US" sz="1150" dirty="0"/>
-          </a:p>
-          <a:p>
-            <a:pPr indent="0" marL="0">
-              <a:lnSpc>
-                <a:spcPct val="115000"/>
-              </a:lnSpc>
-              <a:buNone/>
-            </a:pPr>
-            <a:r>
-              <a:rPr lang="en-US" sz="1150" dirty="0">
-                <a:solidFill>
-                  <a:srgbClr val="444444"/>
-                </a:solidFill>
-                <a:latin typeface="Arial" pitchFamily="34" charset="0"/>
-                <a:ea typeface="Arial" pitchFamily="34" charset="-122"/>
-                <a:cs typeface="Arial" pitchFamily="34" charset="-120"/>
-              </a:rPr>
-              <a:t>after     “… compared to before the Montreal Protocol.”</a:t>
-            </a:r>
-            <a:endParaRPr lang="en-US" sz="1150" dirty="0"/>
-          </a:p>
-          <a:p>
-            <a:pPr indent="0" marL="0">
-              <a:lnSpc>
-                <a:spcPct val="115000"/>
-              </a:lnSpc>
-              <a:buNone/>
-            </a:pPr>
-            <a:r>
-              <a:rPr lang="en-US" sz="1150" b="1" dirty="0">
-                <a:solidFill>
-                  <a:srgbClr val="E90802"/>
-                </a:solidFill>
-                <a:latin typeface="Arial" pitchFamily="34" charset="0"/>
-                <a:ea typeface="Arial" pitchFamily="34" charset="-122"/>
-                <a:cs typeface="Arial" pitchFamily="34" charset="-120"/>
-              </a:rPr>
-              <a:t>UNDECIDED → SUPPORTED</a:t>
-            </a:r>
-            <a:endParaRPr lang="en-US" sz="1150" dirty="0"/>
-          </a:p>
-        </p:txBody>
-      </p:sp>
-      <p:sp>
-        <p:nvSpPr>
-          <p:cNvPr id="10" name="bad"/>
-          <p:cNvSpPr/>
-          <p:nvPr/>
-        </p:nvSpPr>
-        <p:spPr>
-          <a:xfrm>
-            <a:off x="6217920" y="1600200"/>
-            <a:ext cx="5394960" cy="2834640"/>
-          </a:xfrm>
-          <a:prstGeom prst="rect">
-            <a:avLst/>
-          </a:prstGeom>
-          <a:solidFill>
-            <a:srgbClr val="FFFFFF"/>
-          </a:solidFill>
-          <a:ln w="9525">
-            <a:solidFill>
-              <a:srgbClr val="DCDCDC"/>
-            </a:solidFill>
-            <a:prstDash val="solid"/>
-          </a:ln>
-        </p:spPr>
-      </p:sp>
-      <p:sp>
-        <p:nvSpPr>
-          <p:cNvPr id="11" name="bad-h"/>
-          <p:cNvSpPr txBox="1"/>
-          <p:nvPr/>
-        </p:nvSpPr>
-        <p:spPr>
-          <a:xfrm>
-            <a:off x="6473952" y="1801368"/>
-            <a:ext cx="4882896" cy="292608"/>
-          </a:xfrm>
-          <a:prstGeom prst="rect">
-            <a:avLst/>
-          </a:prstGeom>
-          <a:noFill/>
-          <a:ln/>
-        </p:spPr>
-        <p:txBody>
-          <a:bodyPr wrap="square" lIns="0" tIns="0" rIns="0" bIns="0" rtlCol="0" anchor="ctr"/>
-          <a:lstStyle/>
-          <a:p>
-            <a:pPr indent="0" marL="0">
-              <a:buNone/>
-            </a:pPr>
-            <a:r>
-              <a:rPr lang="en-US" sz="1450" b="1" dirty="0">
-                <a:solidFill>
-                  <a:srgbClr val="1A1A1A"/>
-                </a:solidFill>
-              </a:rPr>
-              <a:t>Fails — Q01, the paper's own example</a:t>
-            </a:r>
-            <a:endParaRPr lang="en-US" sz="1450" dirty="0"/>
-          </a:p>
-        </p:txBody>
-      </p:sp>
-      <p:sp>
-        <p:nvSpPr>
-          <p:cNvPr id="12" name="bad-t"/>
-          <p:cNvSpPr txBox="1"/>
-          <p:nvPr/>
-        </p:nvSpPr>
-        <p:spPr>
-          <a:xfrm>
-            <a:off x="6473952" y="2103120"/>
-            <a:ext cx="4882896" cy="2240280"/>
-          </a:xfrm>
-          <a:prstGeom prst="rect">
-            <a:avLst/>
-          </a:prstGeom>
-          <a:noFill/>
-          <a:ln/>
-        </p:spPr>
-        <p:txBody>
-          <a:bodyPr wrap="square" lIns="0" tIns="0" rIns="0" bIns="0" rtlCol="0" anchor="ctr"/>
-          <a:lstStyle/>
-          <a:p>
-            <a:pPr indent="0" marL="0">
-              <a:lnSpc>
-                <a:spcPct val="115000"/>
-              </a:lnSpc>
-              <a:buNone/>
-            </a:pPr>
-            <a:r>
-              <a:rPr lang="en-US" sz="1050" dirty="0">
-                <a:solidFill>
-                  <a:srgbClr val="767676"/>
-                </a:solidFill>
-                <a:latin typeface="Arial" pitchFamily="34" charset="0"/>
-                <a:ea typeface="Arial" pitchFamily="34" charset="-122"/>
-                <a:cs typeface="Arial" pitchFamily="34" charset="-120"/>
-              </a:rPr>
-              <a:t>the refiner flipped the meaning</a:t>
-            </a:r>
-            <a:endParaRPr lang="en-US" sz="1150" dirty="0"/>
-          </a:p>
-          <a:p>
-            <a:pPr indent="0" marL="0">
-              <a:lnSpc>
-                <a:spcPct val="115000"/>
-              </a:lnSpc>
-              <a:buNone/>
-            </a:pPr>
-            <a:r>
-              <a:rPr lang="en-US" sz="1150" dirty="0">
-                <a:solidFill>
-                  <a:srgbClr val="444444"/>
-                </a:solidFill>
-                <a:latin typeface="Arial" pitchFamily="34" charset="0"/>
-                <a:ea typeface="Arial" pitchFamily="34" charset="-122"/>
-                <a:cs typeface="Arial" pitchFamily="34" charset="-120"/>
-              </a:rPr>
-              <a:t>before   “There was demand for gold as jewelry.”</a:t>
-            </a:r>
-            <a:endParaRPr lang="en-US" sz="1150" dirty="0"/>
-          </a:p>
-          <a:p>
-            <a:pPr indent="0" marL="0">
-              <a:lnSpc>
-                <a:spcPct val="115000"/>
-              </a:lnSpc>
-              <a:buNone/>
-            </a:pPr>
-            <a:r>
-              <a:rPr lang="en-US" sz="1150" dirty="0">
-                <a:solidFill>
-                  <a:srgbClr val="444444"/>
-                </a:solidFill>
-                <a:latin typeface="Arial" pitchFamily="34" charset="0"/>
-                <a:ea typeface="Arial" pitchFamily="34" charset="-122"/>
-                <a:cs typeface="Arial" pitchFamily="34" charset="-120"/>
-              </a:rPr>
-              <a:t>after     “There was no demand for gold as jewelry.”</a:t>
-            </a:r>
-            <a:endParaRPr lang="en-US" sz="1150" dirty="0"/>
-          </a:p>
-          <a:p>
-            <a:pPr indent="0" marL="0">
-              <a:lnSpc>
-                <a:spcPct val="115000"/>
-              </a:lnSpc>
-              <a:buNone/>
-            </a:pPr>
-            <a:r>
-              <a:rPr lang="en-US" sz="1150" dirty="0">
-                <a:solidFill>
-                  <a:srgbClr val="E90802"/>
-                </a:solidFill>
-                <a:latin typeface="Arial" pitchFamily="34" charset="0"/>
-                <a:ea typeface="Arial" pitchFamily="34" charset="-122"/>
-                <a:cs typeface="Arial" pitchFamily="34" charset="-120"/>
-              </a:rPr>
-              <a:t>The hypothetical from the question was pasted into a fact stating the opposite.</a:t>
-            </a:r>
-            <a:endParaRPr lang="en-US" sz="1150" dirty="0"/>
-          </a:p>
-          <a:p>
-            <a:pPr indent="0" marL="0">
-              <a:lnSpc>
-                <a:spcPct val="115000"/>
-              </a:lnSpc>
-              <a:buNone/>
-            </a:pPr>
-            <a:r>
-              <a:rPr lang="en-US" sz="600" dirty="0">
-                <a:solidFill>
-                  <a:srgbClr val="444444"/>
-                </a:solidFill>
-                <a:latin typeface="Arial" pitchFamily="34" charset="0"/>
-                <a:ea typeface="Arial" pitchFamily="34" charset="-122"/>
-                <a:cs typeface="Arial" pitchFamily="34" charset="-120"/>
-              </a:rPr>
-              <a:t> </a:t>
-            </a:r>
-            <a:endParaRPr lang="en-US" sz="1150" dirty="0"/>
-          </a:p>
-          <a:p>
-            <a:pPr indent="0" marL="0">
-              <a:lnSpc>
-                <a:spcPct val="115000"/>
-              </a:lnSpc>
-              <a:buNone/>
-            </a:pPr>
-            <a:r>
-              <a:rPr lang="en-US" sz="1050" dirty="0">
-                <a:solidFill>
-                  <a:srgbClr val="767676"/>
-                </a:solidFill>
-                <a:latin typeface="Arial" pitchFamily="34" charset="0"/>
-                <a:ea typeface="Arial" pitchFamily="34" charset="-122"/>
-                <a:cs typeface="Arial" pitchFamily="34" charset="-120"/>
-              </a:rPr>
-              <a:t>condition attached to the wrong claim</a:t>
-            </a:r>
-            <a:endParaRPr lang="en-US" sz="1150" dirty="0"/>
-          </a:p>
-          <a:p>
-            <a:pPr indent="0" marL="0">
-              <a:lnSpc>
-                <a:spcPct val="115000"/>
-              </a:lnSpc>
-              <a:buNone/>
-            </a:pPr>
-            <a:r>
-              <a:rPr lang="en-US" sz="1150" dirty="0">
-                <a:solidFill>
-                  <a:srgbClr val="444444"/>
-                </a:solidFill>
-                <a:latin typeface="Arial" pitchFamily="34" charset="0"/>
-                <a:ea typeface="Arial" pitchFamily="34" charset="-122"/>
-                <a:cs typeface="Arial" pitchFamily="34" charset="-120"/>
-              </a:rPr>
-              <a:t>“Gold has unique properties of malleability if there was no demand for gold as jewelry.”</a:t>
-            </a:r>
-            <a:endParaRPr lang="en-US" sz="1150" dirty="0"/>
-          </a:p>
-          <a:p>
-            <a:pPr indent="0" marL="0">
-              <a:lnSpc>
-                <a:spcPct val="115000"/>
-              </a:lnSpc>
-              <a:buNone/>
-            </a:pPr>
-            <a:r>
-              <a:rPr lang="en-US" sz="1150" b="1" dirty="0">
-                <a:solidFill>
-                  <a:srgbClr val="E90802"/>
-                </a:solidFill>
-                <a:latin typeface="Arial" pitchFamily="34" charset="0"/>
-                <a:ea typeface="Arial" pitchFamily="34" charset="-122"/>
-                <a:cs typeface="Arial" pitchFamily="34" charset="-120"/>
-              </a:rPr>
-              <a:t>SUPPORTED → UNDECIDED</a:t>
-            </a:r>
-            <a:endParaRPr lang="en-US" sz="1150" dirty="0"/>
-          </a:p>
-        </p:txBody>
-      </p:sp>
-      <p:sp>
-        <p:nvSpPr>
-          <p:cNvPr id="13" name="added"/>
-          <p:cNvSpPr/>
-          <p:nvPr/>
-        </p:nvSpPr>
-        <p:spPr>
-          <a:xfrm>
-            <a:off x="548640" y="4617720"/>
-            <a:ext cx="11064240" cy="1143000"/>
-          </a:xfrm>
-          <a:prstGeom prst="rect">
-            <a:avLst/>
-          </a:prstGeom>
-          <a:solidFill>
-            <a:srgbClr val="F4F4F4"/>
-          </a:solidFill>
-          <a:ln w="9525">
-            <a:solidFill>
-              <a:srgbClr val="F4F4F4"/>
-            </a:solidFill>
-            <a:prstDash val="solid"/>
-          </a:ln>
-        </p:spPr>
-      </p:sp>
-      <p:sp>
-        <p:nvSpPr>
-          <p:cNvPr id="14" name="added-h"/>
-          <p:cNvSpPr txBox="1"/>
-          <p:nvPr/>
-        </p:nvSpPr>
-        <p:spPr>
-          <a:xfrm>
-            <a:off x="804672" y="4818888"/>
-            <a:ext cx="10552176" cy="292608"/>
-          </a:xfrm>
-          <a:prstGeom prst="rect">
-            <a:avLst/>
-          </a:prstGeom>
-          <a:noFill/>
-          <a:ln/>
-        </p:spPr>
-        <p:txBody>
-          <a:bodyPr wrap="square" lIns="0" tIns="0" rIns="0" bIns="0" rtlCol="0" anchor="ctr"/>
-          <a:lstStyle/>
-          <a:p>
-            <a:pPr indent="0" marL="0">
-              <a:buNone/>
-            </a:pPr>
-            <a:r>
-              <a:rPr lang="en-US" sz="1300" b="1" dirty="0">
-                <a:solidFill>
-                  <a:srgbClr val="1A1A1A"/>
-                </a:solidFill>
-              </a:rPr>
-              <a:t>Added relational fact — Q04, Chernobyl, temporal</a:t>
-            </a:r>
-            <a:endParaRPr lang="en-US" sz="1300" dirty="0"/>
-          </a:p>
-        </p:txBody>
-      </p:sp>
-      <p:sp>
-        <p:nvSpPr>
-          <p:cNvPr id="15" name="added-b"/>
-          <p:cNvSpPr txBox="1"/>
-          <p:nvPr/>
-        </p:nvSpPr>
-        <p:spPr>
-          <a:xfrm>
-            <a:off x="804672" y="5221224"/>
-            <a:ext cx="10552176" cy="374904"/>
-          </a:xfrm>
-          <a:prstGeom prst="rect">
-            <a:avLst/>
-          </a:prstGeom>
-          <a:noFill/>
-          <a:ln/>
-        </p:spPr>
-        <p:txBody>
-          <a:bodyPr wrap="square" lIns="0" tIns="0" rIns="0" bIns="0" rtlCol="0" anchor="t"/>
-          <a:lstStyle/>
-          <a:p>
-            <a:pPr indent="0" marL="0">
-              <a:lnSpc>
-                <a:spcPct val="125000"/>
-              </a:lnSpc>
-              <a:buNone/>
-            </a:pPr>
-            <a:r>
-              <a:rPr lang="en-US" sz="1200" dirty="0">
-                <a:solidFill>
-                  <a:srgbClr val="444444"/>
-                </a:solidFill>
-                <a:latin typeface="Arial" pitchFamily="34" charset="0"/>
-                <a:ea typeface="Arial" pitchFamily="34" charset="-122"/>
-                <a:cs typeface="Arial" pitchFamily="34" charset="-120"/>
-              </a:rPr>
-              <a:t>“The experiment just before the explosion caused the reactor to exceed its design limits, resulting in the explosion of hydrogen gas in the pressure vessel.”  The span that produced it was never covered by any extracted fact.</a:t>
-            </a:r>
-            <a:endParaRPr lang="en-US" sz="1200" dirty="0"/>
-          </a:p>
-        </p:txBody>
-      </p:sp>
-      <p:sp>
-        <p:nvSpPr>
-          <p:cNvPr id="16" name="note"/>
-          <p:cNvSpPr txBox="1"/>
-          <p:nvPr/>
-        </p:nvSpPr>
-        <p:spPr>
-          <a:xfrm>
-            <a:off x="548640" y="6291072"/>
-            <a:ext cx="10607040" cy="274320"/>
-          </a:xfrm>
-          <a:prstGeom prst="rect">
-            <a:avLst/>
-          </a:prstGeom>
-          <a:noFill/>
-          <a:ln/>
-        </p:spPr>
-        <p:txBody>
-          <a:bodyPr wrap="square" lIns="0" tIns="0" rIns="0" bIns="0" rtlCol="0" anchor="ctr"/>
-          <a:lstStyle/>
-          <a:p>
-            <a:pPr indent="0" marL="0">
-              <a:buNone/>
-            </a:pPr>
-            <a:r>
-              <a:rPr lang="en-US" sz="950" dirty="0">
-                <a:solidFill>
-                  <a:srgbClr val="767676"/>
-                </a:solidFill>
-                <a:latin typeface="Arial" pitchFamily="34" charset="0"/>
-                <a:ea typeface="Arial" pitchFamily="34" charset="-122"/>
-                <a:cs typeface="Arial" pitchFamily="34" charset="-120"/>
-              </a:rPr>
-              <a:t>6 examples auto-selected into outputs/examples/presentation_examples.json, ranked by label changes and error type.</a:t>
-            </a:r>
-            <a:endParaRPr lang="en-US" sz="950" dirty="0"/>
-          </a:p>
-        </p:txBody>
-      </p:sp>
-      <p:sp>
-        <p:nvSpPr>
-          <p:cNvPr id="25" name="Slide Number Placeholder 0"/>
-          <p:cNvSpPr>
-            <a:spLocks noGrp="1"/>
-          </p:cNvSpPr>
-          <p:nvPr>
-            <p:ph type="sldNum" sz="quarter" idx="4294967295"/>
-          </p:nvPr>
-        </p:nvSpPr>
-        <p:spPr>
-          <a:xfrm>
-            <a:off x="11338560" y="6327648"/>
-            <a:ext cx="365760" cy="256032"/>
-          </a:xfrm>
-          <a:prstGeom prst="rect">
-            <a:avLst/>
-          </a:prstGeom>
-          <a:extLst>
-            <a:ext uri="{C572A759-6A51-4108-AA02-DFA0A04FC94B}">
-              <ma14:wrappingTextBoxFlag xmlns:ma14="http://schemas.microsoft.com/office/mac/drawingml/2011/main" val="0"/>
-            </a:ext>
-          </a:extLst>
-        </p:spPr>
-        <p:txBody>
-          <a:bodyPr/>
-          <a:lstStyle>
-            <a:lvl1pPr>
-              <a:defRPr sz="900">
-                <a:solidFill>
-                  <a:srgbClr val="767676"/>
-                </a:solidFill>
-              </a:defRPr>
-            </a:lvl1pPr>
-          </a:lstStyle>
-          <a:p>
-            <a:pPr algn="r"/>
-            <a:fld id="{F7021451-1387-4CA6-816F-3879F97B5CBC}" type="slidenum">
-              <a:rPr b="0" lang="en-US"/>
-              <a:t>17</a:t>
-            </a:fld>
-            <a:endParaRPr lang="en-US"/>
-          </a:p>
-        </p:txBody>
-      </p:sp>
-    </p:spTree>
-  </p:cSld>
-  <p:clrMapOvr>
-    <a:masterClrMapping/>
-  </p:clrMapOvr>
-</p:sld>
-</file>
-
-<file path=ppt/slides/slide18.xml><?xml version="1.0" encoding="utf-8"?>
-<p:sld xmlns:a="http://schemas.openxmlformats.org/drawingml/2006/main" xmlns:r="http://schemas.openxmlformats.org/officeDocument/2006/relationships" xmlns:p="http://schemas.openxmlformats.org/presentationml/2006/main">
-  <p:cSld name="Slide 18">
-    <p:spTree>
-      <p:nvGrpSpPr>
-        <p:cNvPr id="1" name=""/>
-        <p:cNvGrpSpPr/>
-        <p:nvPr/>
-      </p:nvGrpSpPr>
-      <p:grpSpPr>
-        <a:xfrm>
-          <a:off x="0" y="0"/>
-          <a:ext cx="0" cy="0"/>
-          <a:chOff x="0" y="0"/>
-          <a:chExt cx="0" cy="0"/>
-        </a:xfrm>
-      </p:grpSpPr>
-      <p:sp>
-        <p:nvSpPr>
-          <p:cNvPr id="2" name="eyebrow"/>
-          <p:cNvSpPr txBox="1"/>
-          <p:nvPr/>
-        </p:nvSpPr>
-        <p:spPr>
-          <a:xfrm>
-            <a:off x="548640" y="347472"/>
-            <a:ext cx="11064240" cy="237744"/>
-          </a:xfrm>
-          <a:prstGeom prst="rect">
-            <a:avLst/>
-          </a:prstGeom>
-          <a:noFill/>
-          <a:ln/>
-        </p:spPr>
-        <p:txBody>
-          <a:bodyPr wrap="square" lIns="0" tIns="0" rIns="0" bIns="0" rtlCol="0" anchor="ctr"/>
-          <a:lstStyle/>
-          <a:p>
-            <a:pPr indent="0" marL="0">
-              <a:buNone/>
-            </a:pPr>
-            <a:r>
-              <a:rPr lang="en-US" sz="1000" b="1" spc="200" kern="0" dirty="0">
-                <a:solidFill>
-                  <a:srgbClr val="E90802"/>
-                </a:solidFill>
-                <a:latin typeface="Arial" pitchFamily="34" charset="0"/>
-                <a:ea typeface="Arial" pitchFamily="34" charset="-122"/>
-                <a:cs typeface="Arial" pitchFamily="34" charset="-120"/>
-              </a:rPr>
-              <a:t>APPENDIX — NOT PRESENTED</a:t>
-            </a:r>
-            <a:endParaRPr lang="en-US" sz="1000" dirty="0"/>
-          </a:p>
-        </p:txBody>
-      </p:sp>
-      <p:sp>
-        <p:nvSpPr>
-          <p:cNvPr id="3" name="title"/>
-          <p:cNvSpPr txBox="1"/>
-          <p:nvPr/>
-        </p:nvSpPr>
-        <p:spPr>
-          <a:xfrm>
-            <a:off x="548640" y="621792"/>
-            <a:ext cx="11064240" cy="548640"/>
-          </a:xfrm>
-          <a:prstGeom prst="rect">
-            <a:avLst/>
-          </a:prstGeom>
-          <a:noFill/>
-          <a:ln/>
-        </p:spPr>
-        <p:txBody>
-          <a:bodyPr wrap="square" lIns="0" tIns="0" rIns="0" bIns="0" rtlCol="0" anchor="ctr"/>
-          <a:lstStyle/>
-          <a:p>
-            <a:pPr indent="0" marL="0">
-              <a:buNone/>
-            </a:pPr>
-            <a:r>
-              <a:rPr lang="en-US" sz="2700" b="1" dirty="0">
-                <a:solidFill>
-                  <a:srgbClr val="1A1A1A"/>
-                </a:solidFill>
-              </a:rPr>
-              <a:t>Full ranked list of proposed improvements</a:t>
-            </a:r>
-            <a:endParaRPr lang="en-US" sz="2700" dirty="0"/>
-          </a:p>
-        </p:txBody>
-      </p:sp>
-      <p:sp>
-        <p:nvSpPr>
-          <p:cNvPr id="4" name="subtitle"/>
-          <p:cNvSpPr txBox="1"/>
-          <p:nvPr/>
-        </p:nvSpPr>
-        <p:spPr>
-          <a:xfrm>
-            <a:off x="548640" y="1188720"/>
-            <a:ext cx="11064240" cy="256032"/>
-          </a:xfrm>
-          <a:prstGeom prst="rect">
-            <a:avLst/>
-          </a:prstGeom>
-          <a:noFill/>
-          <a:ln/>
-        </p:spPr>
-        <p:txBody>
-          <a:bodyPr wrap="square" lIns="0" tIns="0" rIns="0" bIns="0" rtlCol="0" anchor="ctr"/>
-          <a:lstStyle/>
-          <a:p>
-            <a:pPr indent="0" marL="0">
-              <a:buNone/>
-            </a:pPr>
-            <a:r>
-              <a:rPr lang="en-US" sz="1350" dirty="0">
-                <a:solidFill>
-                  <a:srgbClr val="767676"/>
-                </a:solidFill>
-                <a:latin typeface="Arial" pitchFamily="34" charset="0"/>
-                <a:ea typeface="Arial" pitchFamily="34" charset="-122"/>
-                <a:cs typeface="Arial" pitchFamily="34" charset="-120"/>
-              </a:rPr>
-              <a:t>The first two items are measured; the rest are proposals</a:t>
-            </a:r>
-            <a:endParaRPr lang="en-US" sz="1350" dirty="0"/>
-          </a:p>
-        </p:txBody>
-      </p:sp>
-      <p:sp>
-        <p:nvSpPr>
-          <p:cNvPr id="5" name="head-rule"/>
-          <p:cNvSpPr/>
-          <p:nvPr/>
-        </p:nvSpPr>
-        <p:spPr>
-          <a:xfrm>
-            <a:off x="548640" y="1499616"/>
-            <a:ext cx="11064240" cy="10973"/>
-          </a:xfrm>
-          <a:prstGeom prst="rect">
-            <a:avLst/>
-          </a:prstGeom>
-          <a:solidFill>
-            <a:srgbClr val="DCDCDC"/>
-          </a:solidFill>
-          <a:ln w="3175">
-            <a:solidFill>
-              <a:srgbClr val="DCDCDC"/>
-            </a:solidFill>
-            <a:prstDash val="solid"/>
-          </a:ln>
-        </p:spPr>
-      </p:sp>
-      <p:sp>
-        <p:nvSpPr>
-          <p:cNvPr id="6" name="a-meas"/>
-          <p:cNvSpPr/>
-          <p:nvPr/>
-        </p:nvSpPr>
-        <p:spPr>
-          <a:xfrm>
-            <a:off x="548640" y="1600200"/>
-            <a:ext cx="5394960" cy="4160520"/>
-          </a:xfrm>
-          <a:prstGeom prst="rect">
-            <a:avLst/>
-          </a:prstGeom>
-          <a:solidFill>
-            <a:srgbClr val="FFFFFF"/>
-          </a:solidFill>
-          <a:ln w="9525">
-            <a:solidFill>
-              <a:srgbClr val="DCDCDC"/>
-            </a:solidFill>
-            <a:prstDash val="solid"/>
-          </a:ln>
-        </p:spPr>
-      </p:sp>
-      <p:sp>
-        <p:nvSpPr>
-          <p:cNvPr id="7" name="a-meas-edge"/>
-          <p:cNvSpPr/>
-          <p:nvPr/>
-        </p:nvSpPr>
-        <p:spPr>
-          <a:xfrm>
-            <a:off x="548640" y="1600200"/>
-            <a:ext cx="29261" cy="4160520"/>
-          </a:xfrm>
-          <a:prstGeom prst="rect">
-            <a:avLst/>
-          </a:prstGeom>
-          <a:solidFill>
-            <a:srgbClr val="E90802"/>
-          </a:solidFill>
-          <a:ln w="3175">
-            <a:solidFill>
-              <a:srgbClr val="E90802"/>
-            </a:solidFill>
-            <a:prstDash val="solid"/>
-          </a:ln>
-        </p:spPr>
-      </p:sp>
-      <p:sp>
-        <p:nvSpPr>
-          <p:cNvPr id="8" name="a-meas-h"/>
-          <p:cNvSpPr txBox="1"/>
-          <p:nvPr/>
-        </p:nvSpPr>
-        <p:spPr>
-          <a:xfrm>
-            <a:off x="804672" y="1801368"/>
-            <a:ext cx="4882896" cy="292608"/>
-          </a:xfrm>
-          <a:prstGeom prst="rect">
-            <a:avLst/>
-          </a:prstGeom>
-          <a:noFill/>
-          <a:ln/>
-        </p:spPr>
-        <p:txBody>
-          <a:bodyPr wrap="square" lIns="0" tIns="0" rIns="0" bIns="0" rtlCol="0" anchor="ctr"/>
-          <a:lstStyle/>
-          <a:p>
-            <a:pPr indent="0" marL="0">
-              <a:buNone/>
-            </a:pPr>
-            <a:r>
-              <a:rPr lang="en-US" sz="1450" b="1" dirty="0">
-                <a:solidFill>
-                  <a:srgbClr val="E90802"/>
-                </a:solidFill>
-              </a:rPr>
-              <a:t>Measurement quality</a:t>
-            </a:r>
-            <a:endParaRPr lang="en-US" sz="1450" dirty="0"/>
-          </a:p>
-        </p:txBody>
-      </p:sp>
-      <p:sp>
-        <p:nvSpPr>
-          <p:cNvPr id="9" name="a-meas-l"/>
-          <p:cNvSpPr txBox="1"/>
-          <p:nvPr/>
-        </p:nvSpPr>
-        <p:spPr>
-          <a:xfrm>
-            <a:off x="804672" y="2148840"/>
-            <a:ext cx="4882896" cy="3474720"/>
-          </a:xfrm>
-          <a:prstGeom prst="rect">
-            <a:avLst/>
-          </a:prstGeom>
-          <a:noFill/>
-          <a:ln/>
-        </p:spPr>
-        <p:txBody>
-          <a:bodyPr wrap="square" lIns="0" tIns="0" rIns="0" bIns="0" rtlCol="0" anchor="ctr"/>
-          <a:lstStyle/>
-          <a:p>
-            <a:pPr marL="342900" indent="-342900">
-              <a:spcAft>
-                <a:spcPts val="800"/>
-              </a:spcAft>
-              <a:buSzPct val="100000"/>
-              <a:buChar char="•"/>
-            </a:pPr>
-            <a:r>
-              <a:rPr lang="en-US" sz="1250" dirty="0">
-                <a:solidFill>
-                  <a:srgbClr val="444444"/>
-                </a:solidFill>
-                <a:latin typeface="Arial" pitchFamily="34" charset="0"/>
-                <a:ea typeface="Arial" pitchFamily="34" charset="-122"/>
-                <a:cs typeface="Arial" pitchFamily="34" charset="-120"/>
-              </a:rPr>
-              <a:t>Stronger local judge — tested, 7–8B on a T4</a:t>
-            </a:r>
-            <a:endParaRPr lang="en-US" sz="1250" dirty="0"/>
-          </a:p>
-          <a:p>
-            <a:pPr marL="342900" indent="-342900">
-              <a:spcAft>
-                <a:spcPts val="800"/>
-              </a:spcAft>
-              <a:buSzPct val="100000"/>
-              <a:buChar char="•"/>
-            </a:pPr>
-            <a:r>
-              <a:rPr lang="en-US" sz="1250" dirty="0">
-                <a:solidFill>
-                  <a:srgbClr val="444444"/>
-                </a:solidFill>
-                <a:latin typeface="Arial" pitchFamily="34" charset="0"/>
-                <a:ea typeface="Arial" pitchFamily="34" charset="-122"/>
-                <a:cs typeface="Arial" pitchFamily="34" charset="-120"/>
-              </a:rPr>
-              <a:t>Majority vote over union — tested, higher precision</a:t>
-            </a:r>
-            <a:endParaRPr lang="en-US" sz="1250" dirty="0"/>
-          </a:p>
-          <a:p>
-            <a:pPr marL="342900" indent="-342900">
-              <a:spcAft>
-                <a:spcPts val="800"/>
-              </a:spcAft>
-              <a:buSzPct val="100000"/>
-              <a:buChar char="•"/>
-            </a:pPr>
-            <a:r>
-              <a:rPr lang="en-US" sz="1250" dirty="0">
-                <a:solidFill>
-                  <a:srgbClr val="444444"/>
-                </a:solidFill>
-                <a:latin typeface="Arial" pitchFamily="34" charset="0"/>
-                <a:ea typeface="Arial" pitchFamily="34" charset="-122"/>
-                <a:cs typeface="Arial" pitchFamily="34" charset="-120"/>
-              </a:rPr>
-              <a:t>Third judge plus self-consistency</a:t>
-            </a:r>
-            <a:endParaRPr lang="en-US" sz="1250" dirty="0"/>
-          </a:p>
-          <a:p>
-            <a:pPr marL="342900" indent="-342900">
-              <a:spcAft>
-                <a:spcPts val="800"/>
-              </a:spcAft>
-              <a:buSzPct val="100000"/>
-              <a:buChar char="•"/>
-            </a:pPr>
-            <a:r>
-              <a:rPr lang="en-US" sz="1250" dirty="0">
-                <a:solidFill>
-                  <a:srgbClr val="444444"/>
-                </a:solidFill>
-                <a:latin typeface="Arial" pitchFamily="34" charset="0"/>
-                <a:ea typeface="Arial" pitchFamily="34" charset="-122"/>
-                <a:cs typeface="Arial" pitchFamily="34" charset="-120"/>
-              </a:rPr>
-              <a:t>Verification ensemble — LLM verdict plus an NLI model</a:t>
-            </a:r>
-            <a:endParaRPr lang="en-US" sz="1250" dirty="0"/>
-          </a:p>
-          <a:p>
-            <a:pPr marL="342900" indent="-342900">
-              <a:spcAft>
-                <a:spcPts val="800"/>
-              </a:spcAft>
-              <a:buSzPct val="100000"/>
-              <a:buChar char="•"/>
-            </a:pPr>
-            <a:r>
-              <a:rPr lang="en-US" sz="1250" dirty="0">
-                <a:solidFill>
-                  <a:srgbClr val="444444"/>
-                </a:solidFill>
-                <a:latin typeface="Arial" pitchFamily="34" charset="0"/>
-                <a:ea typeface="Arial" pitchFamily="34" charset="-122"/>
-                <a:cs typeface="Arial" pitchFamily="34" charset="-120"/>
-              </a:rPr>
-              <a:t>Evidence-aware verification — name the span, then judge</a:t>
-            </a:r>
-            <a:endParaRPr lang="en-US" sz="1250" dirty="0"/>
-          </a:p>
-          <a:p>
-            <a:pPr marL="342900" indent="-342900">
-              <a:spcAft>
-                <a:spcPts val="800"/>
-              </a:spcAft>
-              <a:buSzPct val="100000"/>
-              <a:buChar char="•"/>
-            </a:pPr>
-            <a:r>
-              <a:rPr lang="en-US" sz="1250" dirty="0">
-                <a:solidFill>
-                  <a:srgbClr val="444444"/>
-                </a:solidFill>
-                <a:latin typeface="Arial" pitchFamily="34" charset="0"/>
-                <a:ea typeface="Arial" pitchFamily="34" charset="-122"/>
-                <a:cs typeface="Arial" pitchFamily="34" charset="-120"/>
-              </a:rPr>
-              <a:t>One fixed entailment model for recall across all runs</a:t>
-            </a:r>
-            <a:endParaRPr lang="en-US" sz="1250" dirty="0"/>
-          </a:p>
-          <a:p>
-            <a:pPr marL="342900" indent="-342900">
-              <a:spcAft>
-                <a:spcPts val="800"/>
-              </a:spcAft>
-              <a:buSzPct val="100000"/>
-              <a:buChar char="•"/>
-            </a:pPr>
-            <a:r>
-              <a:rPr lang="en-US" sz="1250" dirty="0">
-                <a:solidFill>
-                  <a:srgbClr val="444444"/>
-                </a:solidFill>
-                <a:latin typeface="Arial" pitchFamily="34" charset="0"/>
-                <a:ea typeface="Arial" pitchFamily="34" charset="-122"/>
-                <a:cs typeface="Arial" pitchFamily="34" charset="-120"/>
-              </a:rPr>
-              <a:t>Better reference sets — several answers, human verification</a:t>
-            </a:r>
-            <a:endParaRPr lang="en-US" sz="1250" dirty="0"/>
-          </a:p>
-          <a:p>
-            <a:pPr marL="342900" indent="-342900">
-              <a:spcAft>
-                <a:spcPts val="800"/>
-              </a:spcAft>
-              <a:buSzPct val="100000"/>
-              <a:buChar char="•"/>
-            </a:pPr>
-            <a:r>
-              <a:rPr lang="en-US" sz="1250" dirty="0">
-                <a:solidFill>
-                  <a:srgbClr val="444444"/>
-                </a:solidFill>
-                <a:latin typeface="Arial" pitchFamily="34" charset="0"/>
-                <a:ea typeface="Arial" pitchFamily="34" charset="-122"/>
-                <a:cs typeface="Arial" pitchFamily="34" charset="-120"/>
-              </a:rPr>
-              <a:t>Calibration of the three label thresholds</a:t>
-            </a:r>
-            <a:endParaRPr lang="en-US" sz="1250" dirty="0"/>
-          </a:p>
-        </p:txBody>
-      </p:sp>
-      <p:sp>
-        <p:nvSpPr>
-          <p:cNvPr id="10" name="a-econ"/>
-          <p:cNvSpPr/>
-          <p:nvPr/>
-        </p:nvSpPr>
-        <p:spPr>
-          <a:xfrm>
-            <a:off x="6217920" y="1600200"/>
-            <a:ext cx="5394960" cy="4160520"/>
-          </a:xfrm>
-          <a:prstGeom prst="rect">
-            <a:avLst/>
-          </a:prstGeom>
-          <a:solidFill>
-            <a:srgbClr val="FFFFFF"/>
-          </a:solidFill>
-          <a:ln w="9525">
-            <a:solidFill>
-              <a:srgbClr val="DCDCDC"/>
-            </a:solidFill>
-            <a:prstDash val="solid"/>
-          </a:ln>
-        </p:spPr>
-      </p:sp>
-      <p:sp>
-        <p:nvSpPr>
-          <p:cNvPr id="11" name="a-econ-h"/>
-          <p:cNvSpPr txBox="1"/>
-          <p:nvPr/>
-        </p:nvSpPr>
-        <p:spPr>
-          <a:xfrm>
-            <a:off x="6473952" y="1801368"/>
-            <a:ext cx="4882896" cy="292608"/>
-          </a:xfrm>
-          <a:prstGeom prst="rect">
-            <a:avLst/>
-          </a:prstGeom>
-          <a:noFill/>
-          <a:ln/>
-        </p:spPr>
-        <p:txBody>
-          <a:bodyPr wrap="square" lIns="0" tIns="0" rIns="0" bIns="0" rtlCol="0" anchor="ctr"/>
-          <a:lstStyle/>
-          <a:p>
-            <a:pPr indent="0" marL="0">
-              <a:buNone/>
-            </a:pPr>
-            <a:r>
-              <a:rPr lang="en-US" sz="1450" b="1" dirty="0">
-                <a:solidFill>
-                  <a:srgbClr val="1A1A1A"/>
-                </a:solidFill>
-              </a:rPr>
-              <a:t>Retrieval, cost and coverage</a:t>
-            </a:r>
-            <a:endParaRPr lang="en-US" sz="1450" dirty="0"/>
-          </a:p>
-        </p:txBody>
-      </p:sp>
-      <p:sp>
-        <p:nvSpPr>
-          <p:cNvPr id="12" name="a-econ-l"/>
-          <p:cNvSpPr txBox="1"/>
-          <p:nvPr/>
-        </p:nvSpPr>
-        <p:spPr>
-          <a:xfrm>
-            <a:off x="6473952" y="2148840"/>
-            <a:ext cx="4882896" cy="3474720"/>
-          </a:xfrm>
-          <a:prstGeom prst="rect">
-            <a:avLst/>
-          </a:prstGeom>
-          <a:noFill/>
-          <a:ln/>
-        </p:spPr>
-        <p:txBody>
-          <a:bodyPr wrap="square" lIns="0" tIns="0" rIns="0" bIns="0" rtlCol="0" anchor="ctr"/>
-          <a:lstStyle/>
-          <a:p>
-            <a:pPr marL="342900" indent="-342900">
-              <a:spcAft>
-                <a:spcPts val="800"/>
-              </a:spcAft>
-              <a:buSzPct val="100000"/>
-              <a:buChar char="•"/>
-            </a:pPr>
-            <a:r>
-              <a:rPr lang="en-US" sz="1250" dirty="0">
-                <a:solidFill>
-                  <a:srgbClr val="444444"/>
-                </a:solidFill>
-                <a:latin typeface="Arial" pitchFamily="34" charset="0"/>
-                <a:ea typeface="Arial" pitchFamily="34" charset="-122"/>
-                <a:cs typeface="Arial" pitchFamily="34" charset="-120"/>
-              </a:rPr>
-              <a:t>Query expansion, dense embeddings, cross-encoder reranking</a:t>
-            </a:r>
-            <a:endParaRPr lang="en-US" sz="1250" dirty="0"/>
-          </a:p>
-          <a:p>
-            <a:pPr marL="342900" indent="-342900">
-              <a:spcAft>
-                <a:spcPts val="800"/>
-              </a:spcAft>
-              <a:buSzPct val="100000"/>
-              <a:buChar char="•"/>
-            </a:pPr>
-            <a:r>
-              <a:rPr lang="en-US" sz="1250" dirty="0">
-                <a:solidFill>
-                  <a:srgbClr val="444444"/>
-                </a:solidFill>
-                <a:latin typeface="Arial" pitchFamily="34" charset="0"/>
-                <a:ea typeface="Arial" pitchFamily="34" charset="-122"/>
-                <a:cs typeface="Arial" pitchFamily="34" charset="-120"/>
-              </a:rPr>
-              <a:t>Iterative refinement, maximum two passes</a:t>
-            </a:r>
-            <a:endParaRPr lang="en-US" sz="1250" dirty="0"/>
-          </a:p>
-          <a:p>
-            <a:pPr marL="342900" indent="-342900">
-              <a:spcAft>
-                <a:spcPts val="800"/>
-              </a:spcAft>
-              <a:buSzPct val="100000"/>
-              <a:buChar char="•"/>
-            </a:pPr>
-            <a:r>
-              <a:rPr lang="en-US" sz="1250" dirty="0">
-                <a:solidFill>
-                  <a:srgbClr val="444444"/>
-                </a:solidFill>
-                <a:latin typeface="Arial" pitchFamily="34" charset="0"/>
-                <a:ea typeface="Arial" pitchFamily="34" charset="-122"/>
-                <a:cs typeface="Arial" pitchFamily="34" charset="-120"/>
-              </a:rPr>
-              <a:t>Hybrid rule + LLM relation detection (implemented, off)</a:t>
-            </a:r>
-            <a:endParaRPr lang="en-US" sz="1250" dirty="0"/>
-          </a:p>
-          <a:p>
-            <a:pPr marL="342900" indent="-342900">
-              <a:spcAft>
-                <a:spcPts val="800"/>
-              </a:spcAft>
-              <a:buSzPct val="100000"/>
-              <a:buChar char="•"/>
-            </a:pPr>
-            <a:r>
-              <a:rPr lang="en-US" sz="1250" dirty="0">
-                <a:solidFill>
-                  <a:srgbClr val="444444"/>
-                </a:solidFill>
-                <a:latin typeface="Arial" pitchFamily="34" charset="0"/>
-                <a:ea typeface="Arial" pitchFamily="34" charset="-122"/>
-                <a:cs typeface="Arial" pitchFamily="34" charset="-120"/>
-              </a:rPr>
-              <a:t>Adaptive evidence count, driven by uncertainty</a:t>
-            </a:r>
-            <a:endParaRPr lang="en-US" sz="1250" dirty="0"/>
-          </a:p>
-          <a:p>
-            <a:pPr marL="342900" indent="-342900">
-              <a:spcAft>
-                <a:spcPts val="800"/>
-              </a:spcAft>
-              <a:buSzPct val="100000"/>
-              <a:buChar char="•"/>
-            </a:pPr>
-            <a:r>
-              <a:rPr lang="en-US" sz="1250" dirty="0">
-                <a:solidFill>
-                  <a:srgbClr val="444444"/>
-                </a:solidFill>
-                <a:latin typeface="Arial" pitchFamily="34" charset="0"/>
-                <a:ea typeface="Arial" pitchFamily="34" charset="-122"/>
-                <a:cs typeface="Arial" pitchFamily="34" charset="-120"/>
-              </a:rPr>
-              <a:t>Knowledge-source diversification, routed by claim type</a:t>
-            </a:r>
-            <a:endParaRPr lang="en-US" sz="1250" dirty="0"/>
-          </a:p>
-          <a:p>
-            <a:pPr marL="342900" indent="-342900">
-              <a:spcAft>
-                <a:spcPts val="800"/>
-              </a:spcAft>
-              <a:buSzPct val="100000"/>
-              <a:buChar char="•"/>
-            </a:pPr>
-            <a:r>
-              <a:rPr lang="en-US" sz="1250" dirty="0">
-                <a:solidFill>
-                  <a:srgbClr val="444444"/>
-                </a:solidFill>
-                <a:latin typeface="Arial" pitchFamily="34" charset="0"/>
-                <a:ea typeface="Arial" pitchFamily="34" charset="-122"/>
-                <a:cs typeface="Arial" pitchFamily="34" charset="-120"/>
-              </a:rPr>
-              <a:t>Claim difficulty routing — small model, then large</a:t>
-            </a:r>
-            <a:endParaRPr lang="en-US" sz="1250" dirty="0"/>
-          </a:p>
-          <a:p>
-            <a:pPr marL="342900" indent="-342900">
-              <a:spcAft>
-                <a:spcPts val="800"/>
-              </a:spcAft>
-              <a:buSzPct val="100000"/>
-              <a:buChar char="•"/>
-            </a:pPr>
-            <a:r>
-              <a:rPr lang="en-US" sz="1250" dirty="0">
-                <a:solidFill>
-                  <a:srgbClr val="444444"/>
-                </a:solidFill>
-                <a:latin typeface="Arial" pitchFamily="34" charset="0"/>
-                <a:ea typeface="Arial" pitchFamily="34" charset="-122"/>
-                <a:cs typeface="Arial" pitchFamily="34" charset="-120"/>
-              </a:rPr>
-              <a:t>Fine-tuned detector; distillation from a large open teacher</a:t>
-            </a:r>
-            <a:endParaRPr lang="en-US" sz="1250" dirty="0"/>
-          </a:p>
-          <a:p>
-            <a:pPr marL="342900" indent="-342900">
-              <a:spcAft>
-                <a:spcPts val="800"/>
-              </a:spcAft>
-              <a:buSzPct val="100000"/>
-              <a:buChar char="•"/>
-            </a:pPr>
-            <a:r>
-              <a:rPr lang="en-US" sz="1250" dirty="0">
-                <a:solidFill>
-                  <a:srgbClr val="444444"/>
-                </a:solidFill>
-                <a:latin typeface="Arial" pitchFamily="34" charset="0"/>
-                <a:ea typeface="Arial" pitchFamily="34" charset="-122"/>
-                <a:cs typeface="Arial" pitchFamily="34" charset="-120"/>
-              </a:rPr>
-              <a:t>The remaining baselines: FactScore, FactCheck-GPT, VERIFY</a:t>
-            </a:r>
-            <a:endParaRPr lang="en-US" sz="1250" dirty="0"/>
-          </a:p>
-        </p:txBody>
-      </p:sp>
-      <p:sp>
-        <p:nvSpPr>
-          <p:cNvPr id="13" name="note"/>
-          <p:cNvSpPr txBox="1"/>
-          <p:nvPr/>
-        </p:nvSpPr>
-        <p:spPr>
-          <a:xfrm>
-            <a:off x="548640" y="6291072"/>
-            <a:ext cx="10607040" cy="274320"/>
-          </a:xfrm>
-          <a:prstGeom prst="rect">
-            <a:avLst/>
-          </a:prstGeom>
-          <a:noFill/>
-          <a:ln/>
-        </p:spPr>
-        <p:txBody>
-          <a:bodyPr wrap="square" lIns="0" tIns="0" rIns="0" bIns="0" rtlCol="0" anchor="ctr"/>
-          <a:lstStyle/>
-          <a:p>
-            <a:pPr indent="0" marL="0">
-              <a:buNone/>
-            </a:pPr>
-            <a:r>
-              <a:rPr lang="en-US" sz="950" dirty="0">
-                <a:solidFill>
-                  <a:srgbClr val="767676"/>
-                </a:solidFill>
-                <a:latin typeface="Arial" pitchFamily="34" charset="0"/>
-                <a:ea typeface="Arial" pitchFamily="34" charset="-122"/>
-                <a:cs typeface="Arial" pitchFamily="34" charset="-120"/>
-              </a:rPr>
-              <a:t>Each proposal names the metric it is expected to move. None of them is claimed as a result.</a:t>
-            </a:r>
-            <a:endParaRPr lang="en-US" sz="950" dirty="0"/>
-          </a:p>
-        </p:txBody>
-      </p:sp>
-      <p:sp>
-        <p:nvSpPr>
-          <p:cNvPr id="25" name="Slide Number Placeholder 0"/>
-          <p:cNvSpPr>
-            <a:spLocks noGrp="1"/>
-          </p:cNvSpPr>
-          <p:nvPr>
-            <p:ph type="sldNum" sz="quarter" idx="4294967295"/>
-          </p:nvPr>
-        </p:nvSpPr>
-        <p:spPr>
-          <a:xfrm>
-            <a:off x="11338560" y="6327648"/>
-            <a:ext cx="365760" cy="256032"/>
-          </a:xfrm>
-          <a:prstGeom prst="rect">
-            <a:avLst/>
-          </a:prstGeom>
-          <a:extLst>
-            <a:ext uri="{C572A759-6A51-4108-AA02-DFA0A04FC94B}">
-              <ma14:wrappingTextBoxFlag xmlns:ma14="http://schemas.microsoft.com/office/mac/drawingml/2011/main" val="0"/>
-            </a:ext>
-          </a:extLst>
-        </p:spPr>
-        <p:txBody>
-          <a:bodyPr/>
-          <a:lstStyle>
-            <a:lvl1pPr>
-              <a:defRPr sz="900">
-                <a:solidFill>
-                  <a:srgbClr val="767676"/>
-                </a:solidFill>
-              </a:defRPr>
-            </a:lvl1pPr>
-          </a:lstStyle>
-          <a:p>
-            <a:pPr algn="r"/>
-            <a:fld id="{F7021451-1387-4CA6-816F-3879F97B5CBC}" type="slidenum">
-              <a:rPr b="0" lang="en-US"/>
-              <a:t>18</a:t>
-            </a:fld>
-            <a:endParaRPr lang="en-US"/>
-          </a:p>
-        </p:txBody>
-      </p:sp>
-    </p:spTree>
-  </p:cSld>
-  <p:clrMapOvr>
-    <a:masterClrMapping/>
-  </p:clrMapOvr>
-</p:sld>
-</file>
-
-<file path=ppt/slides/slide19.xml><?xml version="1.0" encoding="utf-8"?>
-<p:sld xmlns:a="http://schemas.openxmlformats.org/drawingml/2006/main" xmlns:r="http://schemas.openxmlformats.org/officeDocument/2006/relationships" xmlns:p="http://schemas.openxmlformats.org/presentationml/2006/main">
-  <p:cSld name="Slide 19">
-    <p:spTree>
-      <p:nvGrpSpPr>
-        <p:cNvPr id="1" name=""/>
-        <p:cNvGrpSpPr/>
-        <p:nvPr/>
-      </p:nvGrpSpPr>
-      <p:grpSpPr>
-        <a:xfrm>
-          <a:off x="0" y="0"/>
-          <a:ext cx="0" cy="0"/>
-          <a:chOff x="0" y="0"/>
-          <a:chExt cx="0" cy="0"/>
-        </a:xfrm>
-      </p:grpSpPr>
-      <p:sp>
-        <p:nvSpPr>
-          <p:cNvPr id="2" name="eyebrow"/>
-          <p:cNvSpPr txBox="1"/>
-          <p:nvPr/>
-        </p:nvSpPr>
-        <p:spPr>
-          <a:xfrm>
-            <a:off x="548640" y="347472"/>
-            <a:ext cx="11064240" cy="237744"/>
-          </a:xfrm>
-          <a:prstGeom prst="rect">
-            <a:avLst/>
-          </a:prstGeom>
-          <a:noFill/>
-          <a:ln/>
-        </p:spPr>
-        <p:txBody>
-          <a:bodyPr wrap="square" lIns="0" tIns="0" rIns="0" bIns="0" rtlCol="0" anchor="ctr"/>
-          <a:lstStyle/>
-          <a:p>
-            <a:pPr indent="0" marL="0">
-              <a:buNone/>
-            </a:pPr>
-            <a:r>
-              <a:rPr lang="en-US" sz="1000" b="1" spc="200" kern="0" dirty="0">
-                <a:solidFill>
-                  <a:srgbClr val="E90802"/>
-                </a:solidFill>
-                <a:latin typeface="Arial" pitchFamily="34" charset="0"/>
-                <a:ea typeface="Arial" pitchFamily="34" charset="-122"/>
-                <a:cs typeface="Arial" pitchFamily="34" charset="-120"/>
-              </a:rPr>
-              <a:t>APPENDIX — NOT PRESENTED</a:t>
-            </a:r>
-            <a:endParaRPr lang="en-US" sz="1000" dirty="0"/>
-          </a:p>
-        </p:txBody>
-      </p:sp>
-      <p:sp>
-        <p:nvSpPr>
-          <p:cNvPr id="3" name="title"/>
-          <p:cNvSpPr txBox="1"/>
-          <p:nvPr/>
-        </p:nvSpPr>
-        <p:spPr>
-          <a:xfrm>
-            <a:off x="548640" y="621792"/>
-            <a:ext cx="11064240" cy="548640"/>
-          </a:xfrm>
-          <a:prstGeom prst="rect">
-            <a:avLst/>
-          </a:prstGeom>
-          <a:noFill/>
-          <a:ln/>
-        </p:spPr>
-        <p:txBody>
-          <a:bodyPr wrap="square" lIns="0" tIns="0" rIns="0" bIns="0" rtlCol="0" anchor="ctr"/>
-          <a:lstStyle/>
-          <a:p>
-            <a:pPr indent="0" marL="0">
-              <a:buNone/>
-            </a:pPr>
-            <a:r>
-              <a:rPr lang="en-US" sz="2700" b="1" dirty="0">
-                <a:solidFill>
-                  <a:srgbClr val="1A1A1A"/>
-                </a:solidFill>
-              </a:rPr>
-              <a:t>Run B, and known hazards</a:t>
-            </a:r>
-            <a:endParaRPr lang="en-US" sz="2700" dirty="0"/>
-          </a:p>
-        </p:txBody>
-      </p:sp>
-      <p:sp>
-        <p:nvSpPr>
-          <p:cNvPr id="4" name="subtitle"/>
-          <p:cNvSpPr txBox="1"/>
-          <p:nvPr/>
-        </p:nvSpPr>
-        <p:spPr>
-          <a:xfrm>
-            <a:off x="548640" y="1188720"/>
-            <a:ext cx="11064240" cy="256032"/>
-          </a:xfrm>
-          <a:prstGeom prst="rect">
-            <a:avLst/>
-          </a:prstGeom>
-          <a:noFill/>
-          <a:ln/>
-        </p:spPr>
-        <p:txBody>
-          <a:bodyPr wrap="square" lIns="0" tIns="0" rIns="0" bIns="0" rtlCol="0" anchor="ctr"/>
-          <a:lstStyle/>
-          <a:p>
-            <a:pPr indent="0" marL="0">
-              <a:buNone/>
-            </a:pPr>
-            <a:r>
-              <a:rPr lang="en-US" sz="1350" dirty="0">
-                <a:solidFill>
-                  <a:srgbClr val="767676"/>
-                </a:solidFill>
-                <a:latin typeface="Arial" pitchFamily="34" charset="0"/>
-                <a:ea typeface="Arial" pitchFamily="34" charset="-122"/>
-                <a:cs typeface="Arial" pitchFamily="34" charset="-120"/>
-              </a:rPr>
-              <a:t>The uncontrolled run, and the engineering problems behind these numbers</a:t>
-            </a:r>
-            <a:endParaRPr lang="en-US" sz="1350" dirty="0"/>
-          </a:p>
-        </p:txBody>
-      </p:sp>
-      <p:sp>
-        <p:nvSpPr>
-          <p:cNvPr id="5" name="head-rule"/>
-          <p:cNvSpPr/>
-          <p:nvPr/>
-        </p:nvSpPr>
-        <p:spPr>
-          <a:xfrm>
-            <a:off x="548640" y="1499616"/>
-            <a:ext cx="11064240" cy="10973"/>
-          </a:xfrm>
-          <a:prstGeom prst="rect">
-            <a:avLst/>
-          </a:prstGeom>
-          <a:solidFill>
-            <a:srgbClr val="DCDCDC"/>
-          </a:solidFill>
-          <a:ln w="3175">
-            <a:solidFill>
-              <a:srgbClr val="DCDCDC"/>
-            </a:solidFill>
-            <a:prstDash val="solid"/>
-          </a:ln>
-        </p:spPr>
-      </p:sp>
-      <p:sp>
-        <p:nvSpPr>
-          <p:cNvPr id="6" name="expb"/>
-          <p:cNvSpPr/>
-          <p:nvPr/>
-        </p:nvSpPr>
-        <p:spPr>
-          <a:xfrm>
-            <a:off x="548640" y="1600200"/>
-            <a:ext cx="11064240" cy="1783080"/>
-          </a:xfrm>
-          <a:prstGeom prst="rect">
-            <a:avLst/>
-          </a:prstGeom>
-          <a:solidFill>
-            <a:srgbClr val="F4F4F4"/>
-          </a:solidFill>
-          <a:ln w="9525">
-            <a:solidFill>
-              <a:srgbClr val="F4F4F4"/>
-            </a:solidFill>
-            <a:prstDash val="solid"/>
-          </a:ln>
-        </p:spPr>
-      </p:sp>
-      <p:sp>
-        <p:nvSpPr>
-          <p:cNvPr id="7" name="expb-edge"/>
-          <p:cNvSpPr/>
-          <p:nvPr/>
-        </p:nvSpPr>
-        <p:spPr>
-          <a:xfrm>
-            <a:off x="548640" y="1600200"/>
-            <a:ext cx="29261" cy="1783080"/>
-          </a:xfrm>
-          <a:prstGeom prst="rect">
-            <a:avLst/>
-          </a:prstGeom>
-          <a:solidFill>
-            <a:srgbClr val="E90802"/>
-          </a:solidFill>
-          <a:ln w="3175">
-            <a:solidFill>
-              <a:srgbClr val="E90802"/>
-            </a:solidFill>
-            <a:prstDash val="solid"/>
-          </a:ln>
-        </p:spPr>
-      </p:sp>
-      <p:sp>
-        <p:nvSpPr>
-          <p:cNvPr id="8" name="expb-h"/>
-          <p:cNvSpPr txBox="1"/>
-          <p:nvPr/>
-        </p:nvSpPr>
-        <p:spPr>
-          <a:xfrm>
-            <a:off x="804672" y="1801368"/>
-            <a:ext cx="10552176" cy="292608"/>
-          </a:xfrm>
-          <a:prstGeom prst="rect">
-            <a:avLst/>
-          </a:prstGeom>
-          <a:noFill/>
-          <a:ln/>
-        </p:spPr>
-        <p:txBody>
-          <a:bodyPr wrap="square" lIns="0" tIns="0" rIns="0" bIns="0" rtlCol="0" anchor="ctr"/>
-          <a:lstStyle/>
-          <a:p>
-            <a:pPr indent="0" marL="0">
-              <a:buNone/>
-            </a:pPr>
-            <a:r>
-              <a:rPr lang="en-US" sz="1350" b="1" dirty="0">
-                <a:solidFill>
-                  <a:srgbClr val="E90802"/>
-                </a:solidFill>
-              </a:rPr>
-              <a:t>Run B — the whole pipeline at 7B, including the extractor</a:t>
-            </a:r>
-            <a:endParaRPr lang="en-US" sz="1350" dirty="0"/>
-          </a:p>
-        </p:txBody>
-      </p:sp>
-      <p:sp>
-        <p:nvSpPr>
-          <p:cNvPr id="9" name="expb-b"/>
-          <p:cNvSpPr txBox="1"/>
-          <p:nvPr/>
-        </p:nvSpPr>
-        <p:spPr>
-          <a:xfrm>
-            <a:off x="804672" y="2203704"/>
-            <a:ext cx="10552176" cy="1014984"/>
-          </a:xfrm>
-          <a:prstGeom prst="rect">
-            <a:avLst/>
-          </a:prstGeom>
-          <a:noFill/>
-          <a:ln/>
-        </p:spPr>
-        <p:txBody>
-          <a:bodyPr wrap="square" lIns="0" tIns="0" rIns="0" bIns="0" rtlCol="0" anchor="t"/>
-          <a:lstStyle/>
-          <a:p>
-            <a:pPr indent="0" marL="0">
-              <a:lnSpc>
-                <a:spcPct val="125000"/>
-              </a:lnSpc>
-              <a:buNone/>
-            </a:pPr>
-            <a:r>
-              <a:rPr lang="en-US" sz="1150" dirty="0">
-                <a:solidFill>
-                  <a:srgbClr val="444444"/>
-                </a:solidFill>
-                <a:latin typeface="Arial" pitchFamily="34" charset="0"/>
-                <a:ea typeface="Arial" pitchFamily="34" charset="-122"/>
-                <a:cs typeface="Arial" pitchFamily="34" charset="-120"/>
-              </a:rPr>
-              <a:t>Baseline: 15.92 facts per answer against 21.50, incomplete rate 0.319, precision 0.5050. Refinement then costs far less precision (−0.025, against −0.118 in run A).</a:t>
-            </a:r>
-            <a:endParaRPr lang="en-US" sz="1150" dirty="0"/>
-          </a:p>
-          <a:p>
-            <a:pPr indent="0" marL="0">
-              <a:lnSpc>
-                <a:spcPct val="125000"/>
-              </a:lnSpc>
-              <a:buNone/>
-            </a:pPr>
-            <a:r>
-              <a:rPr lang="en-US" sz="1150" dirty="0">
-                <a:solidFill>
-                  <a:srgbClr val="444444"/>
-                </a:solidFill>
-                <a:latin typeface="Arial" pitchFamily="34" charset="0"/>
-                <a:ea typeface="Arial" pitchFamily="34" charset="-122"/>
-                <a:cs typeface="Arial" pitchFamily="34" charset="-120"/>
-              </a:rPr>
-              <a:t>A stronger extractor writes fewer, coarser, more self-contained facts, so there is less to repair — the same trade the paper notes for VERIFY (18.5 facts per response against VeriFact's 32.3).</a:t>
-            </a:r>
-            <a:endParaRPr lang="en-US" sz="1150" dirty="0"/>
-          </a:p>
-          <a:p>
-            <a:pPr indent="0" marL="0">
-              <a:lnSpc>
-                <a:spcPct val="125000"/>
-              </a:lnSpc>
-              <a:buNone/>
-            </a:pPr>
-            <a:r>
-              <a:rPr lang="en-US" sz="1150" dirty="0">
-                <a:solidFill>
-                  <a:srgbClr val="444444"/>
-                </a:solidFill>
-                <a:latin typeface="Arial" pitchFamily="34" charset="0"/>
-                <a:ea typeface="Arial" pitchFamily="34" charset="-122"/>
-                <a:cs typeface="Arial" pitchFamily="34" charset="-120"/>
-              </a:rPr>
-              <a:t>B changed the extractor, the judge, the verifier and the recall entailment model at once, so its columns read only against its own baseline.</a:t>
-            </a:r>
-            <a:endParaRPr lang="en-US" sz="1150" dirty="0"/>
-          </a:p>
-        </p:txBody>
-      </p:sp>
-      <p:sp>
-        <p:nvSpPr>
-          <p:cNvPr id="10" name="haz0"/>
-          <p:cNvSpPr/>
-          <p:nvPr/>
-        </p:nvSpPr>
-        <p:spPr>
-          <a:xfrm>
-            <a:off x="548640" y="3657600"/>
-            <a:ext cx="3505200" cy="2103120"/>
-          </a:xfrm>
-          <a:prstGeom prst="rect">
-            <a:avLst/>
-          </a:prstGeom>
-          <a:solidFill>
-            <a:srgbClr val="FFFFFF"/>
-          </a:solidFill>
-          <a:ln w="9525">
-            <a:solidFill>
-              <a:srgbClr val="DCDCDC"/>
-            </a:solidFill>
-            <a:prstDash val="solid"/>
-          </a:ln>
-        </p:spPr>
-      </p:sp>
-      <p:sp>
-        <p:nvSpPr>
-          <p:cNvPr id="11" name="haz0-h"/>
-          <p:cNvSpPr txBox="1"/>
-          <p:nvPr/>
-        </p:nvSpPr>
-        <p:spPr>
-          <a:xfrm>
-            <a:off x="804672" y="3858768"/>
-            <a:ext cx="2993136" cy="292608"/>
-          </a:xfrm>
-          <a:prstGeom prst="rect">
-            <a:avLst/>
-          </a:prstGeom>
-          <a:noFill/>
-          <a:ln/>
-        </p:spPr>
-        <p:txBody>
-          <a:bodyPr wrap="square" lIns="0" tIns="0" rIns="0" bIns="0" rtlCol="0" anchor="ctr"/>
-          <a:lstStyle/>
-          <a:p>
-            <a:pPr indent="0" marL="0">
-              <a:buNone/>
-            </a:pPr>
-            <a:r>
-              <a:rPr lang="en-US" sz="1300" b="1" dirty="0">
-                <a:solidFill>
-                  <a:srgbClr val="1A1A1A"/>
-                </a:solidFill>
-              </a:rPr>
-              <a:t>GPU hazard</a:t>
-            </a:r>
-            <a:endParaRPr lang="en-US" sz="1300" dirty="0"/>
-          </a:p>
-        </p:txBody>
-      </p:sp>
-      <p:sp>
-        <p:nvSpPr>
-          <p:cNvPr id="12" name="haz0-b"/>
-          <p:cNvSpPr txBox="1"/>
-          <p:nvPr/>
-        </p:nvSpPr>
-        <p:spPr>
-          <a:xfrm>
-            <a:off x="804672" y="4261104"/>
-            <a:ext cx="2993136" cy="1335024"/>
-          </a:xfrm>
-          <a:prstGeom prst="rect">
-            <a:avLst/>
-          </a:prstGeom>
-          <a:noFill/>
-          <a:ln/>
-        </p:spPr>
-        <p:txBody>
-          <a:bodyPr wrap="square" lIns="0" tIns="0" rIns="0" bIns="0" rtlCol="0" anchor="t"/>
-          <a:lstStyle/>
-          <a:p>
-            <a:pPr indent="0" marL="0">
-              <a:lnSpc>
-                <a:spcPct val="125000"/>
-              </a:lnSpc>
-              <a:buNone/>
-            </a:pPr>
-            <a:r>
-              <a:rPr lang="en-US" sz="1100" dirty="0">
-                <a:solidFill>
-                  <a:srgbClr val="444444"/>
-                </a:solidFill>
-                <a:latin typeface="Arial" pitchFamily="34" charset="0"/>
-                <a:ea typeface="Arial" pitchFamily="34" charset="-122"/>
-                <a:cs typeface="Arial" pitchFamily="34" charset="-120"/>
-              </a:rPr>
-              <a:t>Two 3B Q4_K_M judges do not fit in 4 GB. The pipeline drives one judge at a time over the whole fact list, then releases its weights — otherwise the backend waits for the resident model's keep-alive and every call pays a ~20 s model load.</a:t>
-            </a:r>
-            <a:endParaRPr lang="en-US" sz="1100" dirty="0"/>
-          </a:p>
-        </p:txBody>
-      </p:sp>
-      <p:sp>
-        <p:nvSpPr>
-          <p:cNvPr id="13" name="haz1"/>
-          <p:cNvSpPr/>
-          <p:nvPr/>
-        </p:nvSpPr>
-        <p:spPr>
-          <a:xfrm>
-            <a:off x="4328160" y="3657600"/>
-            <a:ext cx="3505200" cy="2103120"/>
-          </a:xfrm>
-          <a:prstGeom prst="rect">
-            <a:avLst/>
-          </a:prstGeom>
-          <a:solidFill>
-            <a:srgbClr val="FFFFFF"/>
-          </a:solidFill>
-          <a:ln w="9525">
-            <a:solidFill>
-              <a:srgbClr val="DCDCDC"/>
-            </a:solidFill>
-            <a:prstDash val="solid"/>
-          </a:ln>
-        </p:spPr>
-      </p:sp>
-      <p:sp>
-        <p:nvSpPr>
-          <p:cNvPr id="14" name="haz1-h"/>
-          <p:cNvSpPr txBox="1"/>
-          <p:nvPr/>
-        </p:nvSpPr>
-        <p:spPr>
-          <a:xfrm>
-            <a:off x="4584192" y="3858768"/>
-            <a:ext cx="2993136" cy="292608"/>
-          </a:xfrm>
-          <a:prstGeom prst="rect">
-            <a:avLst/>
-          </a:prstGeom>
-          <a:noFill/>
-          <a:ln/>
-        </p:spPr>
-        <p:txBody>
-          <a:bodyPr wrap="square" lIns="0" tIns="0" rIns="0" bIns="0" rtlCol="0" anchor="ctr"/>
-          <a:lstStyle/>
-          <a:p>
-            <a:pPr indent="0" marL="0">
-              <a:buNone/>
-            </a:pPr>
-            <a:r>
-              <a:rPr lang="en-US" sz="1300" b="1" dirty="0">
-                <a:solidFill>
-                  <a:srgbClr val="1A1A1A"/>
-                </a:solidFill>
-              </a:rPr>
-              <a:t>Retrieval hazard</a:t>
-            </a:r>
-            <a:endParaRPr lang="en-US" sz="1300" dirty="0"/>
-          </a:p>
-        </p:txBody>
-      </p:sp>
-      <p:sp>
-        <p:nvSpPr>
-          <p:cNvPr id="15" name="haz1-b"/>
-          <p:cNvSpPr txBox="1"/>
-          <p:nvPr/>
-        </p:nvSpPr>
-        <p:spPr>
-          <a:xfrm>
-            <a:off x="4584192" y="4261104"/>
-            <a:ext cx="2993136" cy="1335024"/>
-          </a:xfrm>
-          <a:prstGeom prst="rect">
-            <a:avLst/>
-          </a:prstGeom>
-          <a:noFill/>
-          <a:ln/>
-        </p:spPr>
-        <p:txBody>
-          <a:bodyPr wrap="square" lIns="0" tIns="0" rIns="0" bIns="0" rtlCol="0" anchor="t"/>
-          <a:lstStyle/>
-          <a:p>
-            <a:pPr indent="0" marL="0">
-              <a:lnSpc>
-                <a:spcPct val="125000"/>
-              </a:lnSpc>
-              <a:buNone/>
-            </a:pPr>
-            <a:r>
-              <a:rPr lang="en-US" sz="1100" dirty="0">
-                <a:solidFill>
-                  <a:srgbClr val="444444"/>
-                </a:solidFill>
-                <a:latin typeface="Arial" pitchFamily="34" charset="0"/>
-                <a:ea typeface="Arial" pitchFamily="34" charset="-122"/>
-                <a:cs typeface="Arial" pitchFamily="34" charset="-120"/>
-              </a:rPr>
-              <a:t>Wikipedia rate-limits unauthenticated clients. Failed requests are not cached, so without retries a 429 silently becomes “no evidence” and two runs of the same pipeline disagree. Fixed with retries, backoff and Retry-After.</a:t>
-            </a:r>
-            <a:endParaRPr lang="en-US" sz="1100" dirty="0"/>
-          </a:p>
-        </p:txBody>
-      </p:sp>
-      <p:sp>
-        <p:nvSpPr>
-          <p:cNvPr id="16" name="haz2"/>
-          <p:cNvSpPr/>
-          <p:nvPr/>
-        </p:nvSpPr>
-        <p:spPr>
-          <a:xfrm>
-            <a:off x="8107680" y="3657600"/>
-            <a:ext cx="3505200" cy="2103120"/>
-          </a:xfrm>
-          <a:prstGeom prst="rect">
-            <a:avLst/>
-          </a:prstGeom>
-          <a:solidFill>
-            <a:srgbClr val="FFFFFF"/>
-          </a:solidFill>
-          <a:ln w="9525">
-            <a:solidFill>
-              <a:srgbClr val="DCDCDC"/>
-            </a:solidFill>
-            <a:prstDash val="solid"/>
-          </a:ln>
-        </p:spPr>
-      </p:sp>
-      <p:sp>
-        <p:nvSpPr>
-          <p:cNvPr id="17" name="haz2-h"/>
-          <p:cNvSpPr txBox="1"/>
-          <p:nvPr/>
-        </p:nvSpPr>
-        <p:spPr>
-          <a:xfrm>
-            <a:off x="8363712" y="3858768"/>
-            <a:ext cx="2993136" cy="292608"/>
-          </a:xfrm>
-          <a:prstGeom prst="rect">
-            <a:avLst/>
-          </a:prstGeom>
-          <a:noFill/>
-          <a:ln/>
-        </p:spPr>
-        <p:txBody>
-          <a:bodyPr wrap="square" lIns="0" tIns="0" rIns="0" bIns="0" rtlCol="0" anchor="ctr"/>
-          <a:lstStyle/>
-          <a:p>
-            <a:pPr indent="0" marL="0">
-              <a:buNone/>
-            </a:pPr>
-            <a:r>
-              <a:rPr lang="en-US" sz="1300" b="1" dirty="0">
-                <a:solidFill>
-                  <a:srgbClr val="1A1A1A"/>
-                </a:solidFill>
-              </a:rPr>
-              <a:t>Reproducibility</a:t>
-            </a:r>
-            <a:endParaRPr lang="en-US" sz="1300" dirty="0"/>
-          </a:p>
-        </p:txBody>
-      </p:sp>
-      <p:sp>
-        <p:nvSpPr>
-          <p:cNvPr id="18" name="haz2-b"/>
-          <p:cNvSpPr txBox="1"/>
-          <p:nvPr/>
-        </p:nvSpPr>
-        <p:spPr>
-          <a:xfrm>
-            <a:off x="8363712" y="4261104"/>
-            <a:ext cx="2993136" cy="1335024"/>
-          </a:xfrm>
-          <a:prstGeom prst="rect">
-            <a:avLst/>
-          </a:prstGeom>
-          <a:noFill/>
-          <a:ln/>
-        </p:spPr>
-        <p:txBody>
-          <a:bodyPr wrap="square" lIns="0" tIns="0" rIns="0" bIns="0" rtlCol="0" anchor="t"/>
-          <a:lstStyle/>
-          <a:p>
-            <a:pPr indent="0" marL="0">
-              <a:lnSpc>
-                <a:spcPct val="125000"/>
-              </a:lnSpc>
-              <a:buNone/>
-            </a:pPr>
-            <a:r>
-              <a:rPr lang="en-US" sz="1100" dirty="0">
-                <a:solidFill>
-                  <a:srgbClr val="444444"/>
-                </a:solidFill>
-                <a:latin typeface="Arial" pitchFamily="34" charset="0"/>
-                <a:ea typeface="Arial" pitchFamily="34" charset="-122"/>
-                <a:cs typeface="Arial" pitchFamily="34" charset="-120"/>
-              </a:rPr>
-              <a:t>Every LLM call is cached under hash(model + prompt + parameters), every page on disk. Temperature-0 decoding is not bit-reproducible until the cache is warm; all three runs replay exactly from the shipped caches.</a:t>
-            </a:r>
-            <a:endParaRPr lang="en-US" sz="1100" dirty="0"/>
-          </a:p>
-        </p:txBody>
-      </p:sp>
-      <p:sp>
-        <p:nvSpPr>
-          <p:cNvPr id="19" name="note"/>
-          <p:cNvSpPr txBox="1"/>
-          <p:nvPr/>
-        </p:nvSpPr>
-        <p:spPr>
-          <a:xfrm>
-            <a:off x="548640" y="6291072"/>
-            <a:ext cx="10607040" cy="274320"/>
-          </a:xfrm>
-          <a:prstGeom prst="rect">
-            <a:avLst/>
-          </a:prstGeom>
-          <a:noFill/>
-          <a:ln/>
-        </p:spPr>
-        <p:txBody>
-          <a:bodyPr wrap="square" lIns="0" tIns="0" rIns="0" bIns="0" rtlCol="0" anchor="ctr"/>
-          <a:lstStyle/>
-          <a:p>
-            <a:pPr indent="0" marL="0">
-              <a:buNone/>
-            </a:pPr>
-            <a:r>
-              <a:rPr lang="en-US" sz="950" dirty="0">
-                <a:solidFill>
-                  <a:srgbClr val="767676"/>
-                </a:solidFill>
-                <a:latin typeface="Arial" pitchFamily="34" charset="0"/>
-                <a:ea typeface="Arial" pitchFamily="34" charset="-122"/>
-                <a:cs typeface="Arial" pitchFamily="34" charset="-120"/>
-              </a:rPr>
-              <a:t>Full write-up in colab/RESULTS.md; all three runs reproduce from one command with no GPU.</a:t>
-            </a:r>
-            <a:endParaRPr lang="en-US" sz="950" dirty="0"/>
-          </a:p>
-        </p:txBody>
-      </p:sp>
-      <p:sp>
-        <p:nvSpPr>
-          <p:cNvPr id="25" name="Slide Number Placeholder 0"/>
-          <p:cNvSpPr>
-            <a:spLocks noGrp="1"/>
-          </p:cNvSpPr>
-          <p:nvPr>
-            <p:ph type="sldNum" sz="quarter" idx="4294967295"/>
-          </p:nvPr>
-        </p:nvSpPr>
-        <p:spPr>
-          <a:xfrm>
-            <a:off x="11338560" y="6327648"/>
-            <a:ext cx="365760" cy="256032"/>
-          </a:xfrm>
-          <a:prstGeom prst="rect">
-            <a:avLst/>
-          </a:prstGeom>
-          <a:extLst>
-            <a:ext uri="{C572A759-6A51-4108-AA02-DFA0A04FC94B}">
-              <ma14:wrappingTextBoxFlag xmlns:ma14="http://schemas.microsoft.com/office/mac/drawingml/2011/main" val="0"/>
-            </a:ext>
-          </a:extLst>
-        </p:spPr>
-        <p:txBody>
-          <a:bodyPr/>
-          <a:lstStyle>
-            <a:lvl1pPr>
-              <a:defRPr sz="900">
-                <a:solidFill>
-                  <a:srgbClr val="767676"/>
-                </a:solidFill>
-              </a:defRPr>
-            </a:lvl1pPr>
-          </a:lstStyle>
-          <a:p>
-            <a:pPr algn="r"/>
-            <a:fld id="{F7021451-1387-4CA6-816F-3879F97B5CBC}" type="slidenum">
-              <a:rPr b="0" lang="en-US"/>
-              <a:t>19</a:t>
             </a:fld>
             <a:endParaRPr lang="en-US"/>
           </a:p>

</xml_diff>

<commit_message>
docs: drop the backup slide, 15 slides
</commit_message>
<xml_diff>
--- a/presentation/VERIFACT-Lite-TTU.pptx
+++ b/presentation/VERIFACT-Lite-TTU.pptx
@@ -20,10 +20,9 @@
     <p:sldId id="268" r:id="rId14"/>
     <p:sldId id="269" r:id="rId15"/>
     <p:sldId id="270" r:id="rId16"/>
-    <p:sldId id="271" r:id="rId17"/>
   </p:sldIdLst>
   <p:notesMasterIdLst>
-    <p:notesMasterId r:id="rId18"/>
+    <p:notesMasterId r:id="rId17"/>
   </p:notesMasterIdLst>
   <p:sldSz cx="12192000" cy="6858000"/>
   <p:notesSz cx="6858000" cy="12192000"/>
@@ -122,7 +121,7 @@
   <p:extLst>
     <p:ext uri="{521415D9-36F7-43E2-AB2F-B90AF26B5E84}">
       <p14:sectionLst xmlns:p14="http://schemas.microsoft.com/office/powerpoint/2010/main">
-        <p14:section name="Talk" id="{812554c9-9b4e-7407-0140-df5e1e4590fc}">
+        <p14:section name="Talk" id="{3c82f99c-11c9-a1b4-4251-9486edae6c71}">
           <p14:sldIdLst>
             <p14:sldId id="256"/>
             <p14:sldId id="257"/>
@@ -139,11 +138,6 @@
             <p14:sldId id="268"/>
             <p14:sldId id="269"/>
             <p14:sldId id="270"/>
-          </p14:sldIdLst>
-        </p14:section>
-        <p14:section name="Backup" id="{638b93d3-0bd5-2e97-008c-7cf1980f3fd9}">
-          <p14:sldIdLst>
-            <p14:sldId id="271"/>
           </p14:sldIdLst>
         </p14:section>
       </p14:sectionLst>
@@ -1465,94 +1459,6 @@
 </p:notes>
 </file>
 
-<file path=ppt/notesSlides/notesSlide16.xml><?xml version="1.0" encoding="utf-8"?>
-<p:notes xmlns:a="http://schemas.openxmlformats.org/drawingml/2006/main" xmlns:r="http://schemas.openxmlformats.org/officeDocument/2006/relationships" xmlns:p="http://schemas.openxmlformats.org/presentationml/2006/main">
-  <p:cSld>
-    <p:spTree>
-      <p:nvGrpSpPr>
-        <p:cNvPr id="1" name=""/>
-        <p:cNvGrpSpPr/>
-        <p:nvPr/>
-      </p:nvGrpSpPr>
-      <p:grpSpPr>
-        <a:xfrm>
-          <a:off x="0" y="0"/>
-          <a:ext cx="0" cy="0"/>
-          <a:chOff x="0" y="0"/>
-          <a:chExt cx="0" cy="0"/>
-        </a:xfrm>
-      </p:grpSpPr>
-      <p:sp>
-        <p:nvSpPr>
-          <p:cNvPr id="2" name="Slide Image Placeholder 1"/>
-          <p:cNvSpPr>
-            <a:spLocks noGrp="1" noRot="1" noChangeAspect="1"/>
-          </p:cNvSpPr>
-          <p:nvPr>
-            <p:ph type="sldImg"/>
-          </p:nvPr>
-        </p:nvSpPr>
-        <p:spPr/>
-      </p:sp>
-      <p:sp>
-        <p:nvSpPr>
-          <p:cNvPr id="3" name="Notes Placeholder 2"/>
-          <p:cNvSpPr>
-            <a:spLocks noGrp="1"/>
-          </p:cNvSpPr>
-          <p:nvPr>
-            <p:ph type="body" idx="1"/>
-          </p:nvPr>
-        </p:nvSpPr>
-        <p:spPr/>
-        <p:txBody>
-          <a:bodyPr/>
-          <a:lstStyle/>
-          <a:p>
-            <a:r>
-              <a:rPr lang="en-US" dirty="0"/>
-              <a:t>Backup. Not part of the 15 minutes.</a:t>
-            </a:r>
-            <a:endParaRPr lang="en-US" dirty="0"/>
-          </a:p>
-        </p:txBody>
-      </p:sp>
-      <p:sp>
-        <p:nvSpPr>
-          <p:cNvPr id="4" name="Slide Number Placeholder 3"/>
-          <p:cNvSpPr>
-            <a:spLocks noGrp="1"/>
-          </p:cNvSpPr>
-          <p:nvPr>
-            <p:ph type="sldNum" sz="quarter" idx="10"/>
-          </p:nvPr>
-        </p:nvSpPr>
-        <p:spPr/>
-        <p:txBody>
-          <a:bodyPr/>
-          <a:lstStyle/>
-          <a:p>
-            <a:fld id="{F7021451-1387-4CA6-816F-3879F97B5CBC}" type="slidenum">
-              <a:rPr lang="en-US"/>
-              <a:t>16</a:t>
-            </a:fld>
-            <a:endParaRPr lang="en-US"/>
-          </a:p>
-        </p:txBody>
-      </p:sp>
-    </p:spTree>
-    <p:extLst>
-      <p:ext uri="{BB962C8B-B14F-4D97-AF65-F5344CB8AC3E}">
-        <p14:creationId xmlns:p14="http://schemas.microsoft.com/office/powerpoint/2010/main" val="1024086991"/>
-      </p:ext>
-    </p:extLst>
-  </p:cSld>
-  <p:clrMapOvr>
-    <a:masterClrMapping/>
-  </p:clrMapOvr>
-</p:notes>
-</file>
-
 <file path=ppt/notesSlides/notesSlide2.xml><?xml version="1.0" encoding="utf-8"?>
 <p:notes xmlns:a="http://schemas.openxmlformats.org/drawingml/2006/main" xmlns:r="http://schemas.openxmlformats.org/officeDocument/2006/relationships" xmlns:p="http://schemas.openxmlformats.org/presentationml/2006/main">
   <p:cSld>
@@ -17370,831 +17276,6 @@
             <a:fld id="{F7021451-1387-4CA6-816F-3879F97B5CBC}" type="slidenum">
               <a:rPr b="0" lang="en-US"/>
               <a:t>15</a:t>
-            </a:fld>
-            <a:endParaRPr lang="en-US"/>
-          </a:p>
-        </p:txBody>
-      </p:sp>
-    </p:spTree>
-  </p:cSld>
-  <p:clrMapOvr>
-    <a:masterClrMapping/>
-  </p:clrMapOvr>
-</p:sld>
-</file>
-
-<file path=ppt/slides/slide16.xml><?xml version="1.0" encoding="utf-8"?>
-<p:sld xmlns:a="http://schemas.openxmlformats.org/drawingml/2006/main" xmlns:r="http://schemas.openxmlformats.org/officeDocument/2006/relationships" xmlns:p="http://schemas.openxmlformats.org/presentationml/2006/main">
-  <p:cSld name="Slide 16">
-    <p:spTree>
-      <p:nvGrpSpPr>
-        <p:cNvPr id="1" name=""/>
-        <p:cNvGrpSpPr/>
-        <p:nvPr/>
-      </p:nvGrpSpPr>
-      <p:grpSpPr>
-        <a:xfrm>
-          <a:off x="0" y="0"/>
-          <a:ext cx="0" cy="0"/>
-          <a:chOff x="0" y="0"/>
-          <a:chExt cx="0" cy="0"/>
-        </a:xfrm>
-      </p:grpSpPr>
-      <p:sp>
-        <p:nvSpPr>
-          <p:cNvPr id="2" name="eyebrow"/>
-          <p:cNvSpPr txBox="1"/>
-          <p:nvPr/>
-        </p:nvSpPr>
-        <p:spPr>
-          <a:xfrm>
-            <a:off x="548640" y="347472"/>
-            <a:ext cx="11064240" cy="237744"/>
-          </a:xfrm>
-          <a:prstGeom prst="rect">
-            <a:avLst/>
-          </a:prstGeom>
-          <a:noFill/>
-          <a:ln/>
-        </p:spPr>
-        <p:txBody>
-          <a:bodyPr wrap="square" lIns="0" tIns="0" rIns="0" bIns="0" rtlCol="0" anchor="ctr"/>
-          <a:lstStyle/>
-          <a:p>
-            <a:pPr indent="0" marL="0">
-              <a:buNone/>
-            </a:pPr>
-            <a:r>
-              <a:rPr lang="en-US" sz="1000" b="1" spc="200" kern="0" dirty="0">
-                <a:solidFill>
-                  <a:srgbClr val="E90802"/>
-                </a:solidFill>
-                <a:latin typeface="Arial" pitchFamily="34" charset="0"/>
-                <a:ea typeface="Arial" pitchFamily="34" charset="-122"/>
-                <a:cs typeface="Arial" pitchFamily="34" charset="-120"/>
-              </a:rPr>
-              <a:t>BACKUP — NOT PRESENTED</a:t>
-            </a:r>
-            <a:endParaRPr lang="en-US" sz="1000" dirty="0"/>
-          </a:p>
-        </p:txBody>
-      </p:sp>
-      <p:sp>
-        <p:nvSpPr>
-          <p:cNvPr id="3" name="title"/>
-          <p:cNvSpPr txBox="1"/>
-          <p:nvPr/>
-        </p:nvSpPr>
-        <p:spPr>
-          <a:xfrm>
-            <a:off x="548640" y="621792"/>
-            <a:ext cx="11064240" cy="548640"/>
-          </a:xfrm>
-          <a:prstGeom prst="rect">
-            <a:avLst/>
-          </a:prstGeom>
-          <a:noFill/>
-          <a:ln/>
-        </p:spPr>
-        <p:txBody>
-          <a:bodyPr wrap="square" lIns="0" tIns="0" rIns="0" bIns="0" rtlCol="0" anchor="ctr"/>
-          <a:lstStyle/>
-          <a:p>
-            <a:pPr indent="0" marL="0">
-              <a:buNone/>
-            </a:pPr>
-            <a:r>
-              <a:rPr lang="en-US" sz="2700" b="1" dirty="0">
-                <a:solidFill>
-                  <a:srgbClr val="1A1A1A"/>
-                </a:solidFill>
-              </a:rPr>
-              <a:t>Detail behind the four most likely questions</a:t>
-            </a:r>
-            <a:endParaRPr lang="en-US" sz="2700" dirty="0"/>
-          </a:p>
-        </p:txBody>
-      </p:sp>
-      <p:sp>
-        <p:nvSpPr>
-          <p:cNvPr id="4" name="subtitle"/>
-          <p:cNvSpPr txBox="1"/>
-          <p:nvPr/>
-        </p:nvSpPr>
-        <p:spPr>
-          <a:xfrm>
-            <a:off x="548640" y="1188720"/>
-            <a:ext cx="11064240" cy="256032"/>
-          </a:xfrm>
-          <a:prstGeom prst="rect">
-            <a:avLst/>
-          </a:prstGeom>
-          <a:noFill/>
-          <a:ln/>
-        </p:spPr>
-        <p:txBody>
-          <a:bodyPr wrap="square" lIns="0" tIns="0" rIns="0" bIns="0" rtlCol="0" anchor="ctr"/>
-          <a:lstStyle/>
-          <a:p>
-            <a:pPr indent="0" marL="0">
-              <a:buNone/>
-            </a:pPr>
-            <a:r>
-              <a:rPr lang="en-US" sz="1350" dirty="0">
-                <a:solidFill>
-                  <a:srgbClr val="767676"/>
-                </a:solidFill>
-                <a:latin typeface="Arial" pitchFamily="34" charset="0"/>
-                <a:ea typeface="Arial" pitchFamily="34" charset="-122"/>
-                <a:cs typeface="Arial" pitchFamily="34" charset="-120"/>
-              </a:rPr>
-              <a:t>Word mapping, the uncontrolled run, what the refiner writes, and the engineering hazards</a:t>
-            </a:r>
-            <a:endParaRPr lang="en-US" sz="1350" dirty="0"/>
-          </a:p>
-        </p:txBody>
-      </p:sp>
-      <p:sp>
-        <p:nvSpPr>
-          <p:cNvPr id="5" name="head-rule"/>
-          <p:cNvSpPr/>
-          <p:nvPr/>
-        </p:nvSpPr>
-        <p:spPr>
-          <a:xfrm>
-            <a:off x="548640" y="1499616"/>
-            <a:ext cx="11064240" cy="10973"/>
-          </a:xfrm>
-          <a:prstGeom prst="rect">
-            <a:avLst/>
-          </a:prstGeom>
-          <a:solidFill>
-            <a:srgbClr val="DCDCDC"/>
-          </a:solidFill>
-          <a:ln w="3175">
-            <a:solidFill>
-              <a:srgbClr val="DCDCDC"/>
-            </a:solidFill>
-            <a:prstDash val="solid"/>
-          </a:ln>
-        </p:spPr>
-      </p:sp>
-      <p:sp>
-        <p:nvSpPr>
-          <p:cNvPr id="6" name="bk-wm"/>
-          <p:cNvSpPr/>
-          <p:nvPr/>
-        </p:nvSpPr>
-        <p:spPr>
-          <a:xfrm>
-            <a:off x="548640" y="1600200"/>
-            <a:ext cx="5394960" cy="2103120"/>
-          </a:xfrm>
-          <a:prstGeom prst="rect">
-            <a:avLst/>
-          </a:prstGeom>
-          <a:solidFill>
-            <a:srgbClr val="FFFFFF"/>
-          </a:solidFill>
-          <a:ln w="9525">
-            <a:solidFill>
-              <a:srgbClr val="DCDCDC"/>
-            </a:solidFill>
-            <a:prstDash val="solid"/>
-          </a:ln>
-        </p:spPr>
-      </p:sp>
-      <p:sp>
-        <p:nvSpPr>
-          <p:cNvPr id="7" name="bk-wm-h"/>
-          <p:cNvSpPr txBox="1"/>
-          <p:nvPr/>
-        </p:nvSpPr>
-        <p:spPr>
-          <a:xfrm>
-            <a:off x="804672" y="1801368"/>
-            <a:ext cx="4882896" cy="292608"/>
-          </a:xfrm>
-          <a:prstGeom prst="rect">
-            <a:avLst/>
-          </a:prstGeom>
-          <a:noFill/>
-          <a:ln/>
-        </p:spPr>
-        <p:txBody>
-          <a:bodyPr wrap="square" lIns="0" tIns="0" rIns="0" bIns="0" rtlCol="0" anchor="ctr"/>
-          <a:lstStyle/>
-          <a:p>
-            <a:pPr indent="0" marL="0">
-              <a:buNone/>
-            </a:pPr>
-            <a:r>
-              <a:rPr lang="en-US" sz="1350" b="1" dirty="0">
-                <a:solidFill>
-                  <a:srgbClr val="1A1A1A"/>
-                </a:solidFill>
-              </a:rPr>
-              <a:t>How missing relations are found — Algorithm 1</a:t>
-            </a:r>
-            <a:endParaRPr lang="en-US" sz="1350" dirty="0"/>
-          </a:p>
-        </p:txBody>
-      </p:sp>
-      <p:sp>
-        <p:nvSpPr>
-          <p:cNvPr id="8" name="bk-wm-b"/>
-          <p:cNvSpPr txBox="1"/>
-          <p:nvPr/>
-        </p:nvSpPr>
-        <p:spPr>
-          <a:xfrm>
-            <a:off x="804672" y="2203704"/>
-            <a:ext cx="4882896" cy="1335024"/>
-          </a:xfrm>
-          <a:prstGeom prst="rect">
-            <a:avLst/>
-          </a:prstGeom>
-          <a:noFill/>
-          <a:ln/>
-        </p:spPr>
-        <p:txBody>
-          <a:bodyPr wrap="square" lIns="0" tIns="0" rIns="0" bIns="0" rtlCol="0" anchor="t"/>
-          <a:lstStyle/>
-          <a:p>
-            <a:pPr indent="0" marL="0">
-              <a:lnSpc>
-                <a:spcPct val="125000"/>
-              </a:lnSpc>
-              <a:buNone/>
-            </a:pPr>
-            <a:r>
-              <a:rPr lang="en-US" sz="1050" dirty="0">
-                <a:solidFill>
-                  <a:srgbClr val="444444"/>
-                </a:solidFill>
-                <a:latin typeface="Arial" pitchFamily="34" charset="0"/>
-                <a:ea typeface="Arial" pitchFamily="34" charset="-122"/>
-                <a:cs typeface="Arial" pitchFamily="34" charset="-120"/>
-              </a:rPr>
-              <a:t>Take each fact's longest common substring with the response, mark those characters covered, collect the runs that stayed uncovered, and send them to the judges. Normalization is index-preserving, so offsets still point into the original answer.</a:t>
-            </a:r>
-            <a:endParaRPr lang="en-US" sz="1050" dirty="0"/>
-          </a:p>
-          <a:p>
-            <a:pPr indent="0" marL="0">
-              <a:lnSpc>
-                <a:spcPct val="125000"/>
-              </a:lnSpc>
-              <a:buNone/>
-            </a:pPr>
-            <a:r>
-              <a:rPr lang="en-US" sz="1050" dirty="0">
-                <a:solidFill>
-                  <a:srgbClr val="444444"/>
-                </a:solidFill>
-                <a:latin typeface="Arial" pitchFamily="34" charset="0"/>
-                <a:ea typeface="Arial" pitchFamily="34" charset="-122"/>
-                <a:cs typeface="Arial" pitchFamily="34" charset="-120"/>
-              </a:rPr>
-              <a:t>Coverage 0.55–0.59.  73 candidate spans.  A fact is added only when the span expresses a temporal or contingency relation AND no single existing fact already captures it.</a:t>
-            </a:r>
-            <a:endParaRPr lang="en-US" sz="1050" dirty="0"/>
-          </a:p>
-        </p:txBody>
-      </p:sp>
-      <p:sp>
-        <p:nvSpPr>
-          <p:cNvPr id="9" name="bk-b"/>
-          <p:cNvSpPr/>
-          <p:nvPr/>
-        </p:nvSpPr>
-        <p:spPr>
-          <a:xfrm>
-            <a:off x="6217920" y="1600200"/>
-            <a:ext cx="5394960" cy="2103120"/>
-          </a:xfrm>
-          <a:prstGeom prst="rect">
-            <a:avLst/>
-          </a:prstGeom>
-          <a:solidFill>
-            <a:srgbClr val="F4F4F4"/>
-          </a:solidFill>
-          <a:ln w="9525">
-            <a:solidFill>
-              <a:srgbClr val="F4F4F4"/>
-            </a:solidFill>
-            <a:prstDash val="solid"/>
-          </a:ln>
-        </p:spPr>
-      </p:sp>
-      <p:sp>
-        <p:nvSpPr>
-          <p:cNvPr id="10" name="bk-b-h"/>
-          <p:cNvSpPr txBox="1"/>
-          <p:nvPr/>
-        </p:nvSpPr>
-        <p:spPr>
-          <a:xfrm>
-            <a:off x="6473952" y="1801368"/>
-            <a:ext cx="4882896" cy="292608"/>
-          </a:xfrm>
-          <a:prstGeom prst="rect">
-            <a:avLst/>
-          </a:prstGeom>
-          <a:noFill/>
-          <a:ln/>
-        </p:spPr>
-        <p:txBody>
-          <a:bodyPr wrap="square" lIns="0" tIns="0" rIns="0" bIns="0" rtlCol="0" anchor="ctr"/>
-          <a:lstStyle/>
-          <a:p>
-            <a:pPr indent="0" marL="0">
-              <a:buNone/>
-            </a:pPr>
-            <a:r>
-              <a:rPr lang="en-US" sz="1350" b="1" dirty="0">
-                <a:solidFill>
-                  <a:srgbClr val="1A1A1A"/>
-                </a:solidFill>
-              </a:rPr>
-              <a:t>Run B — the whole pipeline at 7B, extractor included</a:t>
-            </a:r>
-            <a:endParaRPr lang="en-US" sz="1350" dirty="0"/>
-          </a:p>
-        </p:txBody>
-      </p:sp>
-      <p:sp>
-        <p:nvSpPr>
-          <p:cNvPr id="11" name="bk-b-b"/>
-          <p:cNvSpPr txBox="1"/>
-          <p:nvPr/>
-        </p:nvSpPr>
-        <p:spPr>
-          <a:xfrm>
-            <a:off x="6473952" y="2203704"/>
-            <a:ext cx="4882896" cy="1335024"/>
-          </a:xfrm>
-          <a:prstGeom prst="rect">
-            <a:avLst/>
-          </a:prstGeom>
-          <a:noFill/>
-          <a:ln/>
-        </p:spPr>
-        <p:txBody>
-          <a:bodyPr wrap="square" lIns="0" tIns="0" rIns="0" bIns="0" rtlCol="0" anchor="t"/>
-          <a:lstStyle/>
-          <a:p>
-            <a:pPr indent="0" marL="0">
-              <a:lnSpc>
-                <a:spcPct val="125000"/>
-              </a:lnSpc>
-              <a:buNone/>
-            </a:pPr>
-            <a:r>
-              <a:rPr lang="en-US" sz="1050" dirty="0">
-                <a:solidFill>
-                  <a:srgbClr val="444444"/>
-                </a:solidFill>
-                <a:latin typeface="Arial" pitchFamily="34" charset="0"/>
-                <a:ea typeface="Arial" pitchFamily="34" charset="-122"/>
-                <a:cs typeface="Arial" pitchFamily="34" charset="-120"/>
-              </a:rPr>
-              <a:t>Baseline 15.92 facts per answer against 21.50, incomplete rate 0.319, precision 0.5050. Refinement then costs −0.025 precision, against −0.118 in run A.</a:t>
-            </a:r>
-            <a:endParaRPr lang="en-US" sz="1050" dirty="0"/>
-          </a:p>
-          <a:p>
-            <a:pPr indent="0" marL="0">
-              <a:lnSpc>
-                <a:spcPct val="125000"/>
-              </a:lnSpc>
-              <a:buNone/>
-            </a:pPr>
-            <a:r>
-              <a:rPr lang="en-US" sz="1050" dirty="0">
-                <a:solidFill>
-                  <a:srgbClr val="444444"/>
-                </a:solidFill>
-                <a:latin typeface="Arial" pitchFamily="34" charset="0"/>
-                <a:ea typeface="Arial" pitchFamily="34" charset="-122"/>
-                <a:cs typeface="Arial" pitchFamily="34" charset="-120"/>
-              </a:rPr>
-              <a:t>A stronger extractor writes fewer, coarser, self-contained facts, so there is less to repair — the trade the paper notes for VERIFY (18.5 facts per response against VeriFact's 32.3).</a:t>
-            </a:r>
-            <a:endParaRPr lang="en-US" sz="1050" dirty="0"/>
-          </a:p>
-          <a:p>
-            <a:pPr indent="0" marL="0">
-              <a:lnSpc>
-                <a:spcPct val="125000"/>
-              </a:lnSpc>
-              <a:buNone/>
-            </a:pPr>
-            <a:r>
-              <a:rPr lang="en-US" sz="1050" dirty="0">
-                <a:solidFill>
-                  <a:srgbClr val="444444"/>
-                </a:solidFill>
-                <a:latin typeface="Arial" pitchFamily="34" charset="0"/>
-                <a:ea typeface="Arial" pitchFamily="34" charset="-122"/>
-                <a:cs typeface="Arial" pitchFamily="34" charset="-120"/>
-              </a:rPr>
-              <a:t>B changed four things at once, so it reads only against its own baseline.</a:t>
-            </a:r>
-            <a:endParaRPr lang="en-US" sz="1050" dirty="0"/>
-          </a:p>
-        </p:txBody>
-      </p:sp>
-      <p:sp>
-        <p:nvSpPr>
-          <p:cNvPr id="12" name="bk-q"/>
-          <p:cNvSpPr/>
-          <p:nvPr/>
-        </p:nvSpPr>
-        <p:spPr>
-          <a:xfrm>
-            <a:off x="548640" y="3886200"/>
-            <a:ext cx="5394960" cy="2103120"/>
-          </a:xfrm>
-          <a:prstGeom prst="rect">
-            <a:avLst/>
-          </a:prstGeom>
-          <a:solidFill>
-            <a:srgbClr val="F4F4F4"/>
-          </a:solidFill>
-          <a:ln w="9525">
-            <a:solidFill>
-              <a:srgbClr val="F4F4F4"/>
-            </a:solidFill>
-            <a:prstDash val="solid"/>
-          </a:ln>
-        </p:spPr>
-      </p:sp>
-      <p:sp>
-        <p:nvSpPr>
-          <p:cNvPr id="13" name="bk-q-edge"/>
-          <p:cNvSpPr/>
-          <p:nvPr/>
-        </p:nvSpPr>
-        <p:spPr>
-          <a:xfrm>
-            <a:off x="548640" y="3886200"/>
-            <a:ext cx="29261" cy="2103120"/>
-          </a:xfrm>
-          <a:prstGeom prst="rect">
-            <a:avLst/>
-          </a:prstGeom>
-          <a:solidFill>
-            <a:srgbClr val="E90802"/>
-          </a:solidFill>
-          <a:ln w="3175">
-            <a:solidFill>
-              <a:srgbClr val="E90802"/>
-            </a:solidFill>
-            <a:prstDash val="solid"/>
-          </a:ln>
-        </p:spPr>
-      </p:sp>
-      <p:sp>
-        <p:nvSpPr>
-          <p:cNvPr id="14" name="bk-q-h"/>
-          <p:cNvSpPr txBox="1"/>
-          <p:nvPr/>
-        </p:nvSpPr>
-        <p:spPr>
-          <a:xfrm>
-            <a:off x="804672" y="4087368"/>
-            <a:ext cx="4882896" cy="292608"/>
-          </a:xfrm>
-          <a:prstGeom prst="rect">
-            <a:avLst/>
-          </a:prstGeom>
-          <a:noFill/>
-          <a:ln/>
-        </p:spPr>
-        <p:txBody>
-          <a:bodyPr wrap="square" lIns="0" tIns="0" rIns="0" bIns="0" rtlCol="0" anchor="ctr"/>
-          <a:lstStyle/>
-          <a:p>
-            <a:pPr indent="0" marL="0">
-              <a:buNone/>
-            </a:pPr>
-            <a:r>
-              <a:rPr lang="en-US" sz="1350" b="1" dirty="0">
-                <a:solidFill>
-                  <a:srgbClr val="E90802"/>
-                </a:solidFill>
-              </a:rPr>
-              <a:t>What the 3B refiner actually writes</a:t>
-            </a:r>
-            <a:endParaRPr lang="en-US" sz="1350" dirty="0"/>
-          </a:p>
-        </p:txBody>
-      </p:sp>
-      <p:sp>
-        <p:nvSpPr>
-          <p:cNvPr id="15" name="bk-q-b"/>
-          <p:cNvSpPr txBox="1"/>
-          <p:nvPr/>
-        </p:nvSpPr>
-        <p:spPr>
-          <a:xfrm>
-            <a:off x="804672" y="4489704"/>
-            <a:ext cx="4882896" cy="1335024"/>
-          </a:xfrm>
-          <a:prstGeom prst="rect">
-            <a:avLst/>
-          </a:prstGeom>
-          <a:noFill/>
-          <a:ln/>
-        </p:spPr>
-        <p:txBody>
-          <a:bodyPr wrap="square" lIns="0" tIns="0" rIns="0" bIns="0" rtlCol="0" anchor="t"/>
-          <a:lstStyle/>
-          <a:p>
-            <a:pPr indent="0" marL="0">
-              <a:lnSpc>
-                <a:spcPct val="125000"/>
-              </a:lnSpc>
-              <a:buNone/>
-            </a:pPr>
-            <a:r>
-              <a:rPr lang="en-US" sz="1050" dirty="0">
-                <a:solidFill>
-                  <a:srgbClr val="444444"/>
-                </a:solidFill>
-                <a:latin typeface="Arial" pitchFamily="34" charset="0"/>
-                <a:ea typeface="Arial" pitchFamily="34" charset="-122"/>
-                <a:cs typeface="Arial" pitchFamily="34" charset="-120"/>
-              </a:rPr>
-              <a:t>Works — Q10:  “These substances are in the atmosphere.” becomes “… since the Montreal Protocol was signed.”   UNDECIDED → SUPPORTED.</a:t>
-            </a:r>
-            <a:endParaRPr lang="en-US" sz="1050" dirty="0"/>
-          </a:p>
-          <a:p>
-            <a:pPr indent="0" marL="0">
-              <a:lnSpc>
-                <a:spcPct val="125000"/>
-              </a:lnSpc>
-              <a:buNone/>
-            </a:pPr>
-            <a:r>
-              <a:rPr lang="en-US" sz="1050" dirty="0">
-                <a:solidFill>
-                  <a:srgbClr val="444444"/>
-                </a:solidFill>
-                <a:latin typeface="Arial" pitchFamily="34" charset="0"/>
-                <a:ea typeface="Arial" pitchFamily="34" charset="-122"/>
-                <a:cs typeface="Arial" pitchFamily="34" charset="-120"/>
-              </a:rPr>
-              <a:t>Fails — Q01:  “There was demand for gold as jewelry.” becomes “There was NO demand …”. The hypothetical from the question was pasted into a fact stating the opposite.</a:t>
-            </a:r>
-            <a:endParaRPr lang="en-US" sz="1050" dirty="0"/>
-          </a:p>
-          <a:p>
-            <a:pPr indent="0" marL="0">
-              <a:lnSpc>
-                <a:spcPct val="125000"/>
-              </a:lnSpc>
-              <a:buNone/>
-            </a:pPr>
-            <a:r>
-              <a:rPr lang="en-US" sz="1050" dirty="0">
-                <a:solidFill>
-                  <a:srgbClr val="444444"/>
-                </a:solidFill>
-                <a:latin typeface="Arial" pitchFamily="34" charset="0"/>
-                <a:ea typeface="Arial" pitchFamily="34" charset="-122"/>
-                <a:cs typeface="Arial" pitchFamily="34" charset="-120"/>
-              </a:rPr>
-              <a:t>Added relation — Q04:  “The experiment just before the explosion caused the reactor to exceed its design limits …”</a:t>
-            </a:r>
-            <a:endParaRPr lang="en-US" sz="1050" dirty="0"/>
-          </a:p>
-        </p:txBody>
-      </p:sp>
-      <p:sp>
-        <p:nvSpPr>
-          <p:cNvPr id="16" name="bk-haz"/>
-          <p:cNvSpPr/>
-          <p:nvPr/>
-        </p:nvSpPr>
-        <p:spPr>
-          <a:xfrm>
-            <a:off x="6217920" y="3886200"/>
-            <a:ext cx="5394960" cy="2103120"/>
-          </a:xfrm>
-          <a:prstGeom prst="rect">
-            <a:avLst/>
-          </a:prstGeom>
-          <a:solidFill>
-            <a:srgbClr val="FFFFFF"/>
-          </a:solidFill>
-          <a:ln w="9525">
-            <a:solidFill>
-              <a:srgbClr val="DCDCDC"/>
-            </a:solidFill>
-            <a:prstDash val="solid"/>
-          </a:ln>
-        </p:spPr>
-      </p:sp>
-      <p:sp>
-        <p:nvSpPr>
-          <p:cNvPr id="17" name="bk-haz-h"/>
-          <p:cNvSpPr txBox="1"/>
-          <p:nvPr/>
-        </p:nvSpPr>
-        <p:spPr>
-          <a:xfrm>
-            <a:off x="6473952" y="4087368"/>
-            <a:ext cx="4882896" cy="292608"/>
-          </a:xfrm>
-          <a:prstGeom prst="rect">
-            <a:avLst/>
-          </a:prstGeom>
-          <a:noFill/>
-          <a:ln/>
-        </p:spPr>
-        <p:txBody>
-          <a:bodyPr wrap="square" lIns="0" tIns="0" rIns="0" bIns="0" rtlCol="0" anchor="ctr"/>
-          <a:lstStyle/>
-          <a:p>
-            <a:pPr indent="0" marL="0">
-              <a:buNone/>
-            </a:pPr>
-            <a:r>
-              <a:rPr lang="en-US" sz="1350" b="1" dirty="0">
-                <a:solidFill>
-                  <a:srgbClr val="1A1A1A"/>
-                </a:solidFill>
-              </a:rPr>
-              <a:t>Engineering hazards behind these numbers</a:t>
-            </a:r>
-            <a:endParaRPr lang="en-US" sz="1350" dirty="0"/>
-          </a:p>
-        </p:txBody>
-      </p:sp>
-      <p:sp>
-        <p:nvSpPr>
-          <p:cNvPr id="18" name="bk-haz-b"/>
-          <p:cNvSpPr txBox="1"/>
-          <p:nvPr/>
-        </p:nvSpPr>
-        <p:spPr>
-          <a:xfrm>
-            <a:off x="6473952" y="4489704"/>
-            <a:ext cx="4882896" cy="1335024"/>
-          </a:xfrm>
-          <a:prstGeom prst="rect">
-            <a:avLst/>
-          </a:prstGeom>
-          <a:noFill/>
-          <a:ln/>
-        </p:spPr>
-        <p:txBody>
-          <a:bodyPr wrap="square" lIns="0" tIns="0" rIns="0" bIns="0" rtlCol="0" anchor="t"/>
-          <a:lstStyle/>
-          <a:p>
-            <a:pPr indent="0" marL="0">
-              <a:lnSpc>
-                <a:spcPct val="125000"/>
-              </a:lnSpc>
-              <a:buNone/>
-            </a:pPr>
-            <a:r>
-              <a:rPr lang="en-US" sz="1050" dirty="0">
-                <a:solidFill>
-                  <a:srgbClr val="444444"/>
-                </a:solidFill>
-                <a:latin typeface="Arial" pitchFamily="34" charset="0"/>
-                <a:ea typeface="Arial" pitchFamily="34" charset="-122"/>
-                <a:cs typeface="Arial" pitchFamily="34" charset="-120"/>
-              </a:rPr>
-              <a:t>GPU:  two 3B Q4_K_M judges do not fit in 4 GB, so the pipeline drives one judge over the whole fact list, then releases its weights — otherwise every call pays a ~20 s model load.</a:t>
-            </a:r>
-            <a:endParaRPr lang="en-US" sz="1050" dirty="0"/>
-          </a:p>
-          <a:p>
-            <a:pPr indent="0" marL="0">
-              <a:lnSpc>
-                <a:spcPct val="125000"/>
-              </a:lnSpc>
-              <a:buNone/>
-            </a:pPr>
-            <a:r>
-              <a:rPr lang="en-US" sz="1050" dirty="0">
-                <a:solidFill>
-                  <a:srgbClr val="444444"/>
-                </a:solidFill>
-                <a:latin typeface="Arial" pitchFamily="34" charset="0"/>
-                <a:ea typeface="Arial" pitchFamily="34" charset="-122"/>
-                <a:cs typeface="Arial" pitchFamily="34" charset="-120"/>
-              </a:rPr>
-              <a:t>Retrieval:  Wikipedia rate-limits unauthenticated clients and failures are not cached, so without retries a 429 silently becomes “no evidence”. Fixed with retries and backoff.</a:t>
-            </a:r>
-            <a:endParaRPr lang="en-US" sz="1050" dirty="0"/>
-          </a:p>
-          <a:p>
-            <a:pPr indent="0" marL="0">
-              <a:lnSpc>
-                <a:spcPct val="125000"/>
-              </a:lnSpc>
-              <a:buNone/>
-            </a:pPr>
-            <a:r>
-              <a:rPr lang="en-US" sz="1050" dirty="0">
-                <a:solidFill>
-                  <a:srgbClr val="444444"/>
-                </a:solidFill>
-                <a:latin typeface="Arial" pitchFamily="34" charset="0"/>
-                <a:ea typeface="Arial" pitchFamily="34" charset="-122"/>
-                <a:cs typeface="Arial" pitchFamily="34" charset="-120"/>
-              </a:rPr>
-              <a:t>Replay:  every LLM call is cached under hash(model + prompt + parameters).</a:t>
-            </a:r>
-            <a:endParaRPr lang="en-US" sz="1050" dirty="0"/>
-          </a:p>
-        </p:txBody>
-      </p:sp>
-      <p:sp>
-        <p:nvSpPr>
-          <p:cNvPr id="19" name="note"/>
-          <p:cNvSpPr txBox="1"/>
-          <p:nvPr/>
-        </p:nvSpPr>
-        <p:spPr>
-          <a:xfrm>
-            <a:off x="548640" y="6291072"/>
-            <a:ext cx="10607040" cy="274320"/>
-          </a:xfrm>
-          <a:prstGeom prst="rect">
-            <a:avLst/>
-          </a:prstGeom>
-          <a:noFill/>
-          <a:ln/>
-        </p:spPr>
-        <p:txBody>
-          <a:bodyPr wrap="square" lIns="0" tIns="0" rIns="0" bIns="0" rtlCol="0" anchor="ctr"/>
-          <a:lstStyle/>
-          <a:p>
-            <a:pPr indent="0" marL="0">
-              <a:buNone/>
-            </a:pPr>
-            <a:r>
-              <a:rPr lang="en-US" sz="950" dirty="0">
-                <a:solidFill>
-                  <a:srgbClr val="767676"/>
-                </a:solidFill>
-                <a:latin typeface="Arial" pitchFamily="34" charset="0"/>
-                <a:ea typeface="Arial" pitchFamily="34" charset="-122"/>
-                <a:cs typeface="Arial" pitchFamily="34" charset="-120"/>
-              </a:rPr>
-              <a:t>Full write-up in README.md and colab/RESULTS.md. All three runs reproduce from one command with no GPU.</a:t>
-            </a:r>
-            <a:endParaRPr lang="en-US" sz="950" dirty="0"/>
-          </a:p>
-        </p:txBody>
-      </p:sp>
-      <p:sp>
-        <p:nvSpPr>
-          <p:cNvPr id="25" name="Slide Number Placeholder 0"/>
-          <p:cNvSpPr>
-            <a:spLocks noGrp="1"/>
-          </p:cNvSpPr>
-          <p:nvPr>
-            <p:ph type="sldNum" sz="quarter" idx="4294967295"/>
-          </p:nvPr>
-        </p:nvSpPr>
-        <p:spPr>
-          <a:xfrm>
-            <a:off x="11338560" y="6327648"/>
-            <a:ext cx="365760" cy="256032"/>
-          </a:xfrm>
-          <a:prstGeom prst="rect">
-            <a:avLst/>
-          </a:prstGeom>
-          <a:extLst>
-            <a:ext uri="{C572A759-6A51-4108-AA02-DFA0A04FC94B}">
-              <ma14:wrappingTextBoxFlag xmlns:ma14="http://schemas.microsoft.com/office/mac/drawingml/2011/main" val="0"/>
-            </a:ext>
-          </a:extLst>
-        </p:spPr>
-        <p:txBody>
-          <a:bodyPr/>
-          <a:lstStyle>
-            <a:lvl1pPr>
-              <a:defRPr sz="900">
-                <a:solidFill>
-                  <a:srgbClr val="767676"/>
-                </a:solidFill>
-              </a:defRPr>
-            </a:lvl1pPr>
-          </a:lstStyle>
-          <a:p>
-            <a:pPr algn="r"/>
-            <a:fld id="{F7021451-1387-4CA6-816F-3879F97B5CBC}" type="slidenum">
-              <a:rPr b="0" lang="en-US"/>
-              <a:t>16</a:t>
             </a:fld>
             <a:endParaRPr lang="en-US"/>
           </a:p>

</xml_diff>

<commit_message>
docs: replace the limitation table with six proposed solutions
Slide 14 listed fixes, not proposals: stronger judges and majority vote
were already-run experiments, and the rest were standard engineering or
measurement hygiene. It now carries six proposals, each one named with
the measured failure it targets:

  - faithfulness-guarded refinement, for the inverted claim in Q01
  - refine then keep the better verdict, for undecided 146 -> 185
  - evidence-conditioned refinement, for unsupportable refined claims
  - disagreement-gated escalation, for the redundant second judge
  - judge-normalized reporting, for 0.105 vs 0.438 on identical facts
  - semantic word mapping, for the lexical coverage blind spot

The rubber-stamped-verifier story moves to the speaker notes, since the
footnotes on the closing slides have been removed by hand.

The .pptx was edited in place to preserve hand edits; build_deck.js
carries the same slide so a rebuild matches.
</commit_message>
<xml_diff>
--- a/presentation/VERIFACT-Lite-TTU.pptx
+++ b/presentation/VERIFACT-Lite-TTU.pptx
@@ -1117,8 +1117,7 @@
           <a:lstStyle/>
           <a:p>
             <a:r>
-              <a:rPr lang="en-US" dirty="0"/>
-              <a:t>[0:55] Open by owning the 0.92 mistake — it shows the harness was itself tested. Then the table: the top two rows started as proposals on the first version of this talk and are now experiments with results. The rest are still proposals, and are labelled as such.</a:t>
+              <a:t>[0:55] Six proposals, each named with the failure it targets. Spend the time on the two in scarlet. Faithfulness-guarded refinement fixes the meaning flip we found by reading our own output; judge-normalized reporting is the one that generalises past this paper, because it makes two judges' scores comparable at all. Mention in passing that we found the verifier rubber-stamping — precision 0.92 with zero contradictions across 258 facts — until we required a verbatim quote from the evidence.</a:t>
             </a:r>
           </a:p>
         </p:txBody>
@@ -2977,7 +2976,18 @@
                 <a:ea typeface="Arial" pitchFamily="34" charset="-122"/>
                 <a:cs typeface="Arial" pitchFamily="34" charset="-120"/>
               </a:rPr>
-              <a:t>Liu, Zhang, Munir, Gu &amp; Wang — EMNLP 2025  ·  Not a reproduction of the paper's reported results</a:t>
+              <a:t>Liu, Zhang, Munir, Gu &amp; Wang — EMNLP </a:t>
+            </a:r>
+            <a:r>
+              <a:rPr lang="en-US" sz="1050">
+                <a:solidFill>
+                  <a:srgbClr val="767676"/>
+                </a:solidFill>
+                <a:latin typeface="Arial" pitchFamily="34" charset="0"/>
+                <a:ea typeface="Arial" pitchFamily="34" charset="-122"/>
+                <a:cs typeface="Arial" pitchFamily="34" charset="-120"/>
+              </a:rPr>
+              <a:t>2025 </a:t>
             </a:r>
             <a:endParaRPr lang="en-US" sz="1050" dirty="0"/>
           </a:p>
@@ -12011,7 +12021,7 @@
           <p:nvPr>
             <p:extLst>
               <p:ext uri="{D42A27DB-BD31-4B8C-83A1-F6EECF244321}">
-                <p14:modId xmlns:p14="http://schemas.microsoft.com/office/powerpoint/2010/main" val="1579011935"/>
+                <p14:modId xmlns:p14="http://schemas.microsoft.com/office/powerpoint/2010/main" val="2754489017"/>
               </p:ext>
             </p:extLst>
           </p:nvPr>
@@ -12205,10 +12215,10 @@
                             <a:srgbClr val="1A1A1A"/>
                           </a:solidFill>
                           <a:latin typeface="Arial" pitchFamily="34" charset="0"/>
-                          <a:ea typeface="Arial" pitchFamily="34" charset="-122"/>
+                          <a:ea typeface="Arial" charset="0"/>
                           <a:cs typeface="Arial" pitchFamily="34" charset="-120"/>
                         </a:rPr>
-                        <a:t>VERIFACT-Lite</a:t>
+                        <a:t>Reimplementation</a:t>
                       </a:r>
                       <a:endParaRPr lang="en-US" sz="1150" dirty="0">
                         <a:latin typeface="Arial" charset="0"/>
@@ -15062,6 +15072,9 @@
           <a:lstStyle/>
           <a:p>
             <a:pPr marL="0" indent="0">
+              <a:lnSpc>
+                <a:spcPct val="100000"/>
+              </a:lnSpc>
               <a:buNone/>
             </a:pPr>
             <a:r>
@@ -15070,7 +15083,7 @@
                   <a:srgbClr val="1A1A1A"/>
                 </a:solidFill>
               </a:rPr>
-              <a:t>Every limitation points at a next step</a:t>
+              <a:t>Six proposals, each aimed at a failure we measured</a:t>
             </a:r>
             <a:endParaRPr lang="en-US" sz="2700" dirty="0"/>
           </a:p>
@@ -15098,6 +15111,9 @@
           <a:lstStyle/>
           <a:p>
             <a:pPr marL="0" indent="0">
+              <a:lnSpc>
+                <a:spcPct val="100000"/>
+              </a:lnSpc>
               <a:buNone/>
             </a:pPr>
             <a:r>
@@ -15109,7 +15125,7 @@
                 <a:ea typeface="Arial" pitchFamily="34" charset="-122"/>
                 <a:cs typeface="Arial" pitchFamily="34" charset="-120"/>
               </a:rPr>
-              <a:t>Two were tested; the rest are proposals, labelled as such</a:t>
+              <a:t>Two earlier proposals are already answered in the results; these six are not</a:t>
             </a:r>
             <a:endParaRPr lang="en-US" sz="1350" dirty="0"/>
           </a:p>
@@ -15147,1674 +15163,6 @@
           </a:p>
         </p:txBody>
       </p:sp>
-      <p:sp>
-        <p:nvSpPr>
-          <p:cNvPr id="6" name="rubber"/>
-          <p:cNvSpPr/>
-          <p:nvPr/>
-        </p:nvSpPr>
-        <p:spPr>
-          <a:xfrm>
-            <a:off x="548640" y="1600200"/>
-            <a:ext cx="11064240" cy="1188720"/>
-          </a:xfrm>
-          <a:prstGeom prst="rect">
-            <a:avLst/>
-          </a:prstGeom>
-          <a:solidFill>
-            <a:srgbClr val="F4F4F4"/>
-          </a:solidFill>
-          <a:ln w="9525">
-            <a:solidFill>
-              <a:srgbClr val="F4F4F4"/>
-            </a:solidFill>
-            <a:prstDash val="solid"/>
-          </a:ln>
-        </p:spPr>
-        <p:txBody>
-          <a:bodyPr/>
-          <a:lstStyle/>
-          <a:p>
-            <a:endParaRPr lang="en-IN"/>
-          </a:p>
-        </p:txBody>
-      </p:sp>
-      <p:sp>
-        <p:nvSpPr>
-          <p:cNvPr id="7" name="rubber-edge"/>
-          <p:cNvSpPr/>
-          <p:nvPr/>
-        </p:nvSpPr>
-        <p:spPr>
-          <a:xfrm>
-            <a:off x="548640" y="1600200"/>
-            <a:ext cx="29261" cy="1188720"/>
-          </a:xfrm>
-          <a:prstGeom prst="rect">
-            <a:avLst/>
-          </a:prstGeom>
-          <a:solidFill>
-            <a:srgbClr val="E90802"/>
-          </a:solidFill>
-          <a:ln w="3175">
-            <a:solidFill>
-              <a:srgbClr val="E90802"/>
-            </a:solidFill>
-            <a:prstDash val="solid"/>
-          </a:ln>
-        </p:spPr>
-        <p:txBody>
-          <a:bodyPr/>
-          <a:lstStyle/>
-          <a:p>
-            <a:endParaRPr lang="en-IN"/>
-          </a:p>
-        </p:txBody>
-      </p:sp>
-      <p:sp>
-        <p:nvSpPr>
-          <p:cNvPr id="8" name="rubber-h"/>
-          <p:cNvSpPr txBox="1"/>
-          <p:nvPr/>
-        </p:nvSpPr>
-        <p:spPr>
-          <a:xfrm>
-            <a:off x="804672" y="1801368"/>
-            <a:ext cx="10552176" cy="292608"/>
-          </a:xfrm>
-          <a:prstGeom prst="rect">
-            <a:avLst/>
-          </a:prstGeom>
-          <a:noFill/>
-          <a:ln/>
-        </p:spPr>
-        <p:txBody>
-          <a:bodyPr wrap="square" lIns="0" tIns="0" rIns="0" bIns="0" rtlCol="0" anchor="ctr"/>
-          <a:lstStyle/>
-          <a:p>
-            <a:pPr marL="0" indent="0">
-              <a:buNone/>
-            </a:pPr>
-            <a:r>
-              <a:rPr lang="en-US" sz="1350" b="1" dirty="0">
-                <a:solidFill>
-                  <a:srgbClr val="E90802"/>
-                </a:solidFill>
-              </a:rPr>
-              <a:t>Found by breaking our own result: a 3B verifier rubber-stamps unless forced to quote</a:t>
-            </a:r>
-            <a:endParaRPr lang="en-US" sz="1350" dirty="0"/>
-          </a:p>
-        </p:txBody>
-      </p:sp>
-      <p:sp>
-        <p:nvSpPr>
-          <p:cNvPr id="9" name="rubber-b"/>
-          <p:cNvSpPr txBox="1"/>
-          <p:nvPr/>
-        </p:nvSpPr>
-        <p:spPr>
-          <a:xfrm>
-            <a:off x="804672" y="2203704"/>
-            <a:ext cx="10552176" cy="420624"/>
-          </a:xfrm>
-          <a:prstGeom prst="rect">
-            <a:avLst/>
-          </a:prstGeom>
-          <a:noFill/>
-          <a:ln/>
-        </p:spPr>
-        <p:txBody>
-          <a:bodyPr wrap="square" lIns="0" tIns="0" rIns="0" bIns="0" rtlCol="0" anchor="t"/>
-          <a:lstStyle/>
-          <a:p>
-            <a:pPr marL="0" indent="0">
-              <a:lnSpc>
-                <a:spcPct val="125000"/>
-              </a:lnSpc>
-              <a:buNone/>
-            </a:pPr>
-            <a:r>
-              <a:rPr lang="en-US" sz="1200" dirty="0">
-                <a:solidFill>
-                  <a:srgbClr val="444444"/>
-                </a:solidFill>
-                <a:latin typeface="Arial" pitchFamily="34" charset="0"/>
-                <a:ea typeface="Arial" pitchFamily="34" charset="-122"/>
-                <a:cs typeface="Arial" pitchFamily="34" charset="-120"/>
-              </a:rPr>
-              <a:t>An earlier version reported precision 0.92 and zero contradictions across 258 facts, calling “Aluminium is the rarest metal in the Earth's crust” SUPPORTED with confidence 1.0. Requiring a verbatim quote from the evidence moved precision to 0.42 and made contradictions appear.</a:t>
-            </a:r>
-            <a:endParaRPr lang="en-US" sz="1200" dirty="0"/>
-          </a:p>
-        </p:txBody>
-      </p:sp>
-      <p:graphicFrame>
-        <p:nvGraphicFramePr>
-          <p:cNvPr id="15" name="fixes"/>
-          <p:cNvGraphicFramePr>
-            <a:graphicFrameLocks noGrp="1"/>
-          </p:cNvGraphicFramePr>
-          <p:nvPr>
-            <p:extLst>
-              <p:ext uri="{D42A27DB-BD31-4B8C-83A1-F6EECF244321}">
-                <p14:modId xmlns:p14="http://schemas.microsoft.com/office/powerpoint/2010/main" val="1579011935"/>
-              </p:ext>
-            </p:extLst>
-          </p:nvPr>
-        </p:nvGraphicFramePr>
-        <p:xfrm>
-          <a:off x="548640" y="3017520"/>
-          <a:ext cx="11064240" cy="2816352"/>
-        </p:xfrm>
-        <a:graphic>
-          <a:graphicData uri="http://schemas.openxmlformats.org/drawingml/2006/table">
-            <a:tbl>
-              <a:tblPr/>
-              <a:tblGrid>
-                <a:gridCol w="4206240">
-                  <a:extLst>
-                    <a:ext uri="{9D8B030D-6E8A-4147-A177-3AD203B41FA5}">
-                      <a16:colId xmlns:a16="http://schemas.microsoft.com/office/drawing/2014/main" val="20000"/>
-                    </a:ext>
-                  </a:extLst>
-                </a:gridCol>
-                <a:gridCol w="4114800">
-                  <a:extLst>
-                    <a:ext uri="{9D8B030D-6E8A-4147-A177-3AD203B41FA5}">
-                      <a16:colId xmlns:a16="http://schemas.microsoft.com/office/drawing/2014/main" val="20001"/>
-                    </a:ext>
-                  </a:extLst>
-                </a:gridCol>
-                <a:gridCol w="2743200">
-                  <a:extLst>
-                    <a:ext uri="{9D8B030D-6E8A-4147-A177-3AD203B41FA5}">
-                      <a16:colId xmlns:a16="http://schemas.microsoft.com/office/drawing/2014/main" val="20002"/>
-                    </a:ext>
-                  </a:extLst>
-                </a:gridCol>
-              </a:tblGrid>
-              <a:tr h="402336">
-                <a:tc>
-                  <a:txBody>
-                    <a:bodyPr/>
-                    <a:lstStyle/>
-                    <a:p>
-                      <a:pPr marL="0" indent="0" algn="l">
-                        <a:buNone/>
-                      </a:pPr>
-                      <a:r>
-                        <a:rPr lang="en-US" sz="1200" b="1" dirty="0">
-                          <a:solidFill>
-                            <a:srgbClr val="1A1A1A"/>
-                          </a:solidFill>
-                          <a:latin typeface="Arial" pitchFamily="34" charset="0"/>
-                          <a:ea typeface="Arial" pitchFamily="34" charset="-122"/>
-                          <a:cs typeface="Arial" pitchFamily="34" charset="-120"/>
-                        </a:rPr>
-                        <a:t>Limitation</a:t>
-                      </a:r>
-                      <a:endParaRPr lang="en-US" sz="1200" dirty="0">
-                        <a:latin typeface="Arial" charset="0"/>
-                        <a:ea typeface="Arial" charset="0"/>
-                        <a:cs typeface="Arial" charset="0"/>
-                      </a:endParaRPr>
-                    </a:p>
-                  </a:txBody>
-                  <a:tcPr marL="109728" marR="109728" marT="36576" marB="36576" anchor="ctr">
-                    <a:lnL w="6350" cap="flat" cmpd="sng" algn="ctr">
-                      <a:solidFill>
-                        <a:srgbClr val="DCDCDC"/>
-                      </a:solidFill>
-                      <a:prstDash val="solid"/>
-                      <a:round/>
-                      <a:headEnd type="none" w="med" len="med"/>
-                      <a:tailEnd type="none" w="med" len="med"/>
-                    </a:lnL>
-                    <a:lnR w="6350" cap="flat" cmpd="sng" algn="ctr">
-                      <a:solidFill>
-                        <a:srgbClr val="DCDCDC"/>
-                      </a:solidFill>
-                      <a:prstDash val="solid"/>
-                      <a:round/>
-                      <a:headEnd type="none" w="med" len="med"/>
-                      <a:tailEnd type="none" w="med" len="med"/>
-                    </a:lnR>
-                    <a:lnT w="6350" cap="flat" cmpd="sng" algn="ctr">
-                      <a:solidFill>
-                        <a:srgbClr val="DCDCDC"/>
-                      </a:solidFill>
-                      <a:prstDash val="solid"/>
-                      <a:round/>
-                      <a:headEnd type="none" w="med" len="med"/>
-                      <a:tailEnd type="none" w="med" len="med"/>
-                    </a:lnT>
-                    <a:lnB w="6350" cap="flat" cmpd="sng" algn="ctr">
-                      <a:solidFill>
-                        <a:srgbClr val="DCDCDC"/>
-                      </a:solidFill>
-                      <a:prstDash val="solid"/>
-                      <a:round/>
-                      <a:headEnd type="none" w="med" len="med"/>
-                      <a:tailEnd type="none" w="med" len="med"/>
-                    </a:lnB>
-                    <a:solidFill>
-                      <a:srgbClr val="F4F4F4"/>
-                    </a:solidFill>
-                  </a:tcPr>
-                </a:tc>
-                <a:tc>
-                  <a:txBody>
-                    <a:bodyPr/>
-                    <a:lstStyle/>
-                    <a:p>
-                      <a:pPr marL="0" indent="0" algn="l">
-                        <a:buNone/>
-                      </a:pPr>
-                      <a:r>
-                        <a:rPr lang="en-US" sz="1200" b="1" dirty="0">
-                          <a:solidFill>
-                            <a:srgbClr val="1A1A1A"/>
-                          </a:solidFill>
-                          <a:latin typeface="Arial" pitchFamily="34" charset="0"/>
-                          <a:ea typeface="Arial" pitchFamily="34" charset="-122"/>
-                          <a:cs typeface="Arial" pitchFamily="34" charset="-120"/>
-                        </a:rPr>
-                        <a:t>What would fix it</a:t>
-                      </a:r>
-                      <a:endParaRPr lang="en-US" sz="1200" dirty="0">
-                        <a:latin typeface="Arial" charset="0"/>
-                        <a:ea typeface="Arial" charset="0"/>
-                        <a:cs typeface="Arial" charset="0"/>
-                      </a:endParaRPr>
-                    </a:p>
-                  </a:txBody>
-                  <a:tcPr marL="109728" marR="109728" marT="36576" marB="36576" anchor="ctr">
-                    <a:lnL w="6350" cap="flat" cmpd="sng" algn="ctr">
-                      <a:solidFill>
-                        <a:srgbClr val="DCDCDC"/>
-                      </a:solidFill>
-                      <a:prstDash val="solid"/>
-                      <a:round/>
-                      <a:headEnd type="none" w="med" len="med"/>
-                      <a:tailEnd type="none" w="med" len="med"/>
-                    </a:lnL>
-                    <a:lnR w="6350" cap="flat" cmpd="sng" algn="ctr">
-                      <a:solidFill>
-                        <a:srgbClr val="DCDCDC"/>
-                      </a:solidFill>
-                      <a:prstDash val="solid"/>
-                      <a:round/>
-                      <a:headEnd type="none" w="med" len="med"/>
-                      <a:tailEnd type="none" w="med" len="med"/>
-                    </a:lnR>
-                    <a:lnT w="6350" cap="flat" cmpd="sng" algn="ctr">
-                      <a:solidFill>
-                        <a:srgbClr val="DCDCDC"/>
-                      </a:solidFill>
-                      <a:prstDash val="solid"/>
-                      <a:round/>
-                      <a:headEnd type="none" w="med" len="med"/>
-                      <a:tailEnd type="none" w="med" len="med"/>
-                    </a:lnT>
-                    <a:lnB w="6350" cap="flat" cmpd="sng" algn="ctr">
-                      <a:solidFill>
-                        <a:srgbClr val="DCDCDC"/>
-                      </a:solidFill>
-                      <a:prstDash val="solid"/>
-                      <a:round/>
-                      <a:headEnd type="none" w="med" len="med"/>
-                      <a:tailEnd type="none" w="med" len="med"/>
-                    </a:lnB>
-                    <a:solidFill>
-                      <a:srgbClr val="F4F4F4"/>
-                    </a:solidFill>
-                  </a:tcPr>
-                </a:tc>
-                <a:tc>
-                  <a:txBody>
-                    <a:bodyPr/>
-                    <a:lstStyle/>
-                    <a:p>
-                      <a:pPr marL="0" indent="0" algn="l">
-                        <a:buNone/>
-                      </a:pPr>
-                      <a:r>
-                        <a:rPr lang="en-US" sz="1200" b="1" dirty="0">
-                          <a:solidFill>
-                            <a:srgbClr val="1A1A1A"/>
-                          </a:solidFill>
-                          <a:latin typeface="Arial" pitchFamily="34" charset="0"/>
-                          <a:ea typeface="Arial" pitchFamily="34" charset="-122"/>
-                          <a:cs typeface="Arial" pitchFamily="34" charset="-120"/>
-                        </a:rPr>
-                        <a:t>Status</a:t>
-                      </a:r>
-                      <a:endParaRPr lang="en-US" sz="1200" dirty="0">
-                        <a:latin typeface="Arial" charset="0"/>
-                        <a:ea typeface="Arial" charset="0"/>
-                        <a:cs typeface="Arial" charset="0"/>
-                      </a:endParaRPr>
-                    </a:p>
-                  </a:txBody>
-                  <a:tcPr marL="109728" marR="109728" marT="36576" marB="36576" anchor="ctr">
-                    <a:lnL w="6350" cap="flat" cmpd="sng" algn="ctr">
-                      <a:solidFill>
-                        <a:srgbClr val="DCDCDC"/>
-                      </a:solidFill>
-                      <a:prstDash val="solid"/>
-                      <a:round/>
-                      <a:headEnd type="none" w="med" len="med"/>
-                      <a:tailEnd type="none" w="med" len="med"/>
-                    </a:lnL>
-                    <a:lnR w="6350" cap="flat" cmpd="sng" algn="ctr">
-                      <a:solidFill>
-                        <a:srgbClr val="DCDCDC"/>
-                      </a:solidFill>
-                      <a:prstDash val="solid"/>
-                      <a:round/>
-                      <a:headEnd type="none" w="med" len="med"/>
-                      <a:tailEnd type="none" w="med" len="med"/>
-                    </a:lnR>
-                    <a:lnT w="6350" cap="flat" cmpd="sng" algn="ctr">
-                      <a:solidFill>
-                        <a:srgbClr val="DCDCDC"/>
-                      </a:solidFill>
-                      <a:prstDash val="solid"/>
-                      <a:round/>
-                      <a:headEnd type="none" w="med" len="med"/>
-                      <a:tailEnd type="none" w="med" len="med"/>
-                    </a:lnT>
-                    <a:lnB w="6350" cap="flat" cmpd="sng" algn="ctr">
-                      <a:solidFill>
-                        <a:srgbClr val="DCDCDC"/>
-                      </a:solidFill>
-                      <a:prstDash val="solid"/>
-                      <a:round/>
-                      <a:headEnd type="none" w="med" len="med"/>
-                      <a:tailEnd type="none" w="med" len="med"/>
-                    </a:lnB>
-                    <a:solidFill>
-                      <a:srgbClr val="F4F4F4"/>
-                    </a:solidFill>
-                  </a:tcPr>
-                </a:tc>
-                <a:extLst>
-                  <a:ext uri="{0D108BD9-81ED-4DB2-BD59-A6C34878D82A}">
-                    <a16:rowId xmlns:a16="http://schemas.microsoft.com/office/drawing/2014/main" val="10000"/>
-                  </a:ext>
-                </a:extLst>
-              </a:tr>
-              <a:tr h="402336">
-                <a:tc>
-                  <a:txBody>
-                    <a:bodyPr/>
-                    <a:lstStyle/>
-                    <a:p>
-                      <a:pPr marL="0" indent="0" algn="l">
-                        <a:buNone/>
-                      </a:pPr>
-                      <a:r>
-                        <a:rPr lang="en-US" sz="1200" dirty="0">
-                          <a:solidFill>
-                            <a:srgbClr val="444444"/>
-                          </a:solidFill>
-                          <a:latin typeface="Arial" pitchFamily="34" charset="0"/>
-                          <a:ea typeface="Arial" pitchFamily="34" charset="-122"/>
-                          <a:cs typeface="Arial" pitchFamily="34" charset="-120"/>
-                        </a:rPr>
-                        <a:t>Judges are 3B; metrics track the judge</a:t>
-                      </a:r>
-                      <a:endParaRPr lang="en-US" sz="1200" dirty="0">
-                        <a:latin typeface="Arial" charset="0"/>
-                        <a:ea typeface="Arial" charset="0"/>
-                        <a:cs typeface="Arial" charset="0"/>
-                      </a:endParaRPr>
-                    </a:p>
-                  </a:txBody>
-                  <a:tcPr marL="109728" marR="109728" marT="36576" marB="36576" anchor="ctr">
-                    <a:lnL w="6350" cap="flat" cmpd="sng" algn="ctr">
-                      <a:solidFill>
-                        <a:srgbClr val="DCDCDC"/>
-                      </a:solidFill>
-                      <a:prstDash val="solid"/>
-                      <a:round/>
-                      <a:headEnd type="none" w="med" len="med"/>
-                      <a:tailEnd type="none" w="med" len="med"/>
-                    </a:lnL>
-                    <a:lnR w="6350" cap="flat" cmpd="sng" algn="ctr">
-                      <a:solidFill>
-                        <a:srgbClr val="DCDCDC"/>
-                      </a:solidFill>
-                      <a:prstDash val="solid"/>
-                      <a:round/>
-                      <a:headEnd type="none" w="med" len="med"/>
-                      <a:tailEnd type="none" w="med" len="med"/>
-                    </a:lnR>
-                    <a:lnT w="6350" cap="flat" cmpd="sng" algn="ctr">
-                      <a:solidFill>
-                        <a:srgbClr val="DCDCDC"/>
-                      </a:solidFill>
-                      <a:prstDash val="solid"/>
-                      <a:round/>
-                      <a:headEnd type="none" w="med" len="med"/>
-                      <a:tailEnd type="none" w="med" len="med"/>
-                    </a:lnT>
-                    <a:lnB w="6350" cap="flat" cmpd="sng" algn="ctr">
-                      <a:solidFill>
-                        <a:srgbClr val="DCDCDC"/>
-                      </a:solidFill>
-                      <a:prstDash val="solid"/>
-                      <a:round/>
-                      <a:headEnd type="none" w="med" len="med"/>
-                      <a:tailEnd type="none" w="med" len="med"/>
-                    </a:lnB>
-                    <a:solidFill>
-                      <a:srgbClr val="FFFFFF"/>
-                    </a:solidFill>
-                  </a:tcPr>
-                </a:tc>
-                <a:tc>
-                  <a:txBody>
-                    <a:bodyPr/>
-                    <a:lstStyle/>
-                    <a:p>
-                      <a:pPr marL="0" indent="0" algn="l">
-                        <a:buNone/>
-                      </a:pPr>
-                      <a:r>
-                        <a:rPr lang="en-US" sz="1200" dirty="0">
-                          <a:solidFill>
-                            <a:srgbClr val="444444"/>
-                          </a:solidFill>
-                          <a:latin typeface="Arial" pitchFamily="34" charset="0"/>
-                          <a:ea typeface="Arial" pitchFamily="34" charset="-122"/>
-                          <a:cs typeface="Arial" pitchFamily="34" charset="-120"/>
-                        </a:rPr>
-                        <a:t>Stronger local judge (7–14B)</a:t>
-                      </a:r>
-                      <a:endParaRPr lang="en-US" sz="1200" dirty="0">
-                        <a:latin typeface="Arial" charset="0"/>
-                        <a:ea typeface="Arial" charset="0"/>
-                        <a:cs typeface="Arial" charset="0"/>
-                      </a:endParaRPr>
-                    </a:p>
-                  </a:txBody>
-                  <a:tcPr marL="109728" marR="109728" marT="36576" marB="36576" anchor="ctr">
-                    <a:lnL w="6350" cap="flat" cmpd="sng" algn="ctr">
-                      <a:solidFill>
-                        <a:srgbClr val="DCDCDC"/>
-                      </a:solidFill>
-                      <a:prstDash val="solid"/>
-                      <a:round/>
-                      <a:headEnd type="none" w="med" len="med"/>
-                      <a:tailEnd type="none" w="med" len="med"/>
-                    </a:lnL>
-                    <a:lnR w="6350" cap="flat" cmpd="sng" algn="ctr">
-                      <a:solidFill>
-                        <a:srgbClr val="DCDCDC"/>
-                      </a:solidFill>
-                      <a:prstDash val="solid"/>
-                      <a:round/>
-                      <a:headEnd type="none" w="med" len="med"/>
-                      <a:tailEnd type="none" w="med" len="med"/>
-                    </a:lnR>
-                    <a:lnT w="6350" cap="flat" cmpd="sng" algn="ctr">
-                      <a:solidFill>
-                        <a:srgbClr val="DCDCDC"/>
-                      </a:solidFill>
-                      <a:prstDash val="solid"/>
-                      <a:round/>
-                      <a:headEnd type="none" w="med" len="med"/>
-                      <a:tailEnd type="none" w="med" len="med"/>
-                    </a:lnT>
-                    <a:lnB w="6350" cap="flat" cmpd="sng" algn="ctr">
-                      <a:solidFill>
-                        <a:srgbClr val="DCDCDC"/>
-                      </a:solidFill>
-                      <a:prstDash val="solid"/>
-                      <a:round/>
-                      <a:headEnd type="none" w="med" len="med"/>
-                      <a:tailEnd type="none" w="med" len="med"/>
-                    </a:lnB>
-                    <a:solidFill>
-                      <a:srgbClr val="FFFFFF"/>
-                    </a:solidFill>
-                  </a:tcPr>
-                </a:tc>
-                <a:tc>
-                  <a:txBody>
-                    <a:bodyPr/>
-                    <a:lstStyle/>
-                    <a:p>
-                      <a:pPr marL="0" indent="0" algn="l">
-                        <a:buNone/>
-                      </a:pPr>
-                      <a:r>
-                        <a:rPr lang="en-US" sz="1200" b="1" dirty="0">
-                          <a:solidFill>
-                            <a:srgbClr val="E90802"/>
-                          </a:solidFill>
-                          <a:latin typeface="Arial" pitchFamily="34" charset="0"/>
-                          <a:ea typeface="Arial" pitchFamily="34" charset="-122"/>
-                          <a:cs typeface="Arial" pitchFamily="34" charset="-120"/>
-                        </a:rPr>
-                        <a:t>tested — 4.2× more found</a:t>
-                      </a:r>
-                      <a:endParaRPr lang="en-US" sz="1200" dirty="0">
-                        <a:latin typeface="Arial" charset="0"/>
-                        <a:ea typeface="Arial" charset="0"/>
-                        <a:cs typeface="Arial" charset="0"/>
-                      </a:endParaRPr>
-                    </a:p>
-                  </a:txBody>
-                  <a:tcPr marL="109728" marR="109728" marT="36576" marB="36576" anchor="ctr">
-                    <a:lnL w="6350" cap="flat" cmpd="sng" algn="ctr">
-                      <a:solidFill>
-                        <a:srgbClr val="DCDCDC"/>
-                      </a:solidFill>
-                      <a:prstDash val="solid"/>
-                      <a:round/>
-                      <a:headEnd type="none" w="med" len="med"/>
-                      <a:tailEnd type="none" w="med" len="med"/>
-                    </a:lnL>
-                    <a:lnR w="6350" cap="flat" cmpd="sng" algn="ctr">
-                      <a:solidFill>
-                        <a:srgbClr val="DCDCDC"/>
-                      </a:solidFill>
-                      <a:prstDash val="solid"/>
-                      <a:round/>
-                      <a:headEnd type="none" w="med" len="med"/>
-                      <a:tailEnd type="none" w="med" len="med"/>
-                    </a:lnR>
-                    <a:lnT w="6350" cap="flat" cmpd="sng" algn="ctr">
-                      <a:solidFill>
-                        <a:srgbClr val="DCDCDC"/>
-                      </a:solidFill>
-                      <a:prstDash val="solid"/>
-                      <a:round/>
-                      <a:headEnd type="none" w="med" len="med"/>
-                      <a:tailEnd type="none" w="med" len="med"/>
-                    </a:lnT>
-                    <a:lnB w="6350" cap="flat" cmpd="sng" algn="ctr">
-                      <a:solidFill>
-                        <a:srgbClr val="DCDCDC"/>
-                      </a:solidFill>
-                      <a:prstDash val="solid"/>
-                      <a:round/>
-                      <a:headEnd type="none" w="med" len="med"/>
-                      <a:tailEnd type="none" w="med" len="med"/>
-                    </a:lnB>
-                    <a:solidFill>
-                      <a:srgbClr val="FFFFFF"/>
-                    </a:solidFill>
-                  </a:tcPr>
-                </a:tc>
-                <a:extLst>
-                  <a:ext uri="{0D108BD9-81ED-4DB2-BD59-A6C34878D82A}">
-                    <a16:rowId xmlns:a16="http://schemas.microsoft.com/office/drawing/2014/main" val="10001"/>
-                  </a:ext>
-                </a:extLst>
-              </a:tr>
-              <a:tr h="402336">
-                <a:tc>
-                  <a:txBody>
-                    <a:bodyPr/>
-                    <a:lstStyle/>
-                    <a:p>
-                      <a:pPr marL="0" indent="0" algn="l">
-                        <a:buNone/>
-                      </a:pPr>
-                      <a:r>
-                        <a:rPr lang="en-US" sz="1200" dirty="0">
-                          <a:solidFill>
-                            <a:srgbClr val="444444"/>
-                          </a:solidFill>
-                          <a:latin typeface="Arial" pitchFamily="34" charset="0"/>
-                          <a:ea typeface="Arial" pitchFamily="34" charset="-122"/>
-                          <a:cs typeface="Arial" pitchFamily="34" charset="-120"/>
-                        </a:rPr>
-                        <a:t>Union is dominated by the permissive judge</a:t>
-                      </a:r>
-                      <a:endParaRPr lang="en-US" sz="1200" dirty="0">
-                        <a:latin typeface="Arial" charset="0"/>
-                        <a:ea typeface="Arial" charset="0"/>
-                        <a:cs typeface="Arial" charset="0"/>
-                      </a:endParaRPr>
-                    </a:p>
-                  </a:txBody>
-                  <a:tcPr marL="109728" marR="109728" marT="36576" marB="36576" anchor="ctr">
-                    <a:lnL w="6350" cap="flat" cmpd="sng" algn="ctr">
-                      <a:solidFill>
-                        <a:srgbClr val="DCDCDC"/>
-                      </a:solidFill>
-                      <a:prstDash val="solid"/>
-                      <a:round/>
-                      <a:headEnd type="none" w="med" len="med"/>
-                      <a:tailEnd type="none" w="med" len="med"/>
-                    </a:lnL>
-                    <a:lnR w="6350" cap="flat" cmpd="sng" algn="ctr">
-                      <a:solidFill>
-                        <a:srgbClr val="DCDCDC"/>
-                      </a:solidFill>
-                      <a:prstDash val="solid"/>
-                      <a:round/>
-                      <a:headEnd type="none" w="med" len="med"/>
-                      <a:tailEnd type="none" w="med" len="med"/>
-                    </a:lnR>
-                    <a:lnT w="6350" cap="flat" cmpd="sng" algn="ctr">
-                      <a:solidFill>
-                        <a:srgbClr val="DCDCDC"/>
-                      </a:solidFill>
-                      <a:prstDash val="solid"/>
-                      <a:round/>
-                      <a:headEnd type="none" w="med" len="med"/>
-                      <a:tailEnd type="none" w="med" len="med"/>
-                    </a:lnT>
-                    <a:lnB w="6350" cap="flat" cmpd="sng" algn="ctr">
-                      <a:solidFill>
-                        <a:srgbClr val="DCDCDC"/>
-                      </a:solidFill>
-                      <a:prstDash val="solid"/>
-                      <a:round/>
-                      <a:headEnd type="none" w="med" len="med"/>
-                      <a:tailEnd type="none" w="med" len="med"/>
-                    </a:lnB>
-                    <a:solidFill>
-                      <a:srgbClr val="FFFFFF"/>
-                    </a:solidFill>
-                  </a:tcPr>
-                </a:tc>
-                <a:tc>
-                  <a:txBody>
-                    <a:bodyPr/>
-                    <a:lstStyle/>
-                    <a:p>
-                      <a:pPr marL="0" indent="0" algn="l">
-                        <a:buNone/>
-                      </a:pPr>
-                      <a:r>
-                        <a:rPr lang="en-US" sz="1200" dirty="0">
-                          <a:solidFill>
-                            <a:srgbClr val="444444"/>
-                          </a:solidFill>
-                          <a:latin typeface="Arial" pitchFamily="34" charset="0"/>
-                          <a:ea typeface="Arial" pitchFamily="34" charset="-122"/>
-                          <a:cs typeface="Arial" pitchFamily="34" charset="-120"/>
-                        </a:rPr>
-                        <a:t>Majority vote, or a third judge</a:t>
-                      </a:r>
-                      <a:endParaRPr lang="en-US" sz="1200" dirty="0">
-                        <a:latin typeface="Arial" charset="0"/>
-                        <a:ea typeface="Arial" charset="0"/>
-                        <a:cs typeface="Arial" charset="0"/>
-                      </a:endParaRPr>
-                    </a:p>
-                  </a:txBody>
-                  <a:tcPr marL="109728" marR="109728" marT="36576" marB="36576" anchor="ctr">
-                    <a:lnL w="6350" cap="flat" cmpd="sng" algn="ctr">
-                      <a:solidFill>
-                        <a:srgbClr val="DCDCDC"/>
-                      </a:solidFill>
-                      <a:prstDash val="solid"/>
-                      <a:round/>
-                      <a:headEnd type="none" w="med" len="med"/>
-                      <a:tailEnd type="none" w="med" len="med"/>
-                    </a:lnL>
-                    <a:lnR w="6350" cap="flat" cmpd="sng" algn="ctr">
-                      <a:solidFill>
-                        <a:srgbClr val="DCDCDC"/>
-                      </a:solidFill>
-                      <a:prstDash val="solid"/>
-                      <a:round/>
-                      <a:headEnd type="none" w="med" len="med"/>
-                      <a:tailEnd type="none" w="med" len="med"/>
-                    </a:lnR>
-                    <a:lnT w="6350" cap="flat" cmpd="sng" algn="ctr">
-                      <a:solidFill>
-                        <a:srgbClr val="DCDCDC"/>
-                      </a:solidFill>
-                      <a:prstDash val="solid"/>
-                      <a:round/>
-                      <a:headEnd type="none" w="med" len="med"/>
-                      <a:tailEnd type="none" w="med" len="med"/>
-                    </a:lnT>
-                    <a:lnB w="6350" cap="flat" cmpd="sng" algn="ctr">
-                      <a:solidFill>
-                        <a:srgbClr val="DCDCDC"/>
-                      </a:solidFill>
-                      <a:prstDash val="solid"/>
-                      <a:round/>
-                      <a:headEnd type="none" w="med" len="med"/>
-                      <a:tailEnd type="none" w="med" len="med"/>
-                    </a:lnB>
-                    <a:solidFill>
-                      <a:srgbClr val="FFFFFF"/>
-                    </a:solidFill>
-                  </a:tcPr>
-                </a:tc>
-                <a:tc>
-                  <a:txBody>
-                    <a:bodyPr/>
-                    <a:lstStyle/>
-                    <a:p>
-                      <a:pPr marL="0" indent="0" algn="l">
-                        <a:buNone/>
-                      </a:pPr>
-                      <a:r>
-                        <a:rPr lang="en-US" sz="1200" b="1" dirty="0">
-                          <a:solidFill>
-                            <a:srgbClr val="E90802"/>
-                          </a:solidFill>
-                          <a:latin typeface="Arial" pitchFamily="34" charset="0"/>
-                          <a:ea typeface="Arial" pitchFamily="34" charset="-122"/>
-                          <a:cs typeface="Arial" pitchFamily="34" charset="-120"/>
-                        </a:rPr>
-                        <a:t>tested — majority wins</a:t>
-                      </a:r>
-                      <a:endParaRPr lang="en-US" sz="1200" dirty="0">
-                        <a:latin typeface="Arial" charset="0"/>
-                        <a:ea typeface="Arial" charset="0"/>
-                        <a:cs typeface="Arial" charset="0"/>
-                      </a:endParaRPr>
-                    </a:p>
-                  </a:txBody>
-                  <a:tcPr marL="109728" marR="109728" marT="36576" marB="36576" anchor="ctr">
-                    <a:lnL w="6350" cap="flat" cmpd="sng" algn="ctr">
-                      <a:solidFill>
-                        <a:srgbClr val="DCDCDC"/>
-                      </a:solidFill>
-                      <a:prstDash val="solid"/>
-                      <a:round/>
-                      <a:headEnd type="none" w="med" len="med"/>
-                      <a:tailEnd type="none" w="med" len="med"/>
-                    </a:lnL>
-                    <a:lnR w="6350" cap="flat" cmpd="sng" algn="ctr">
-                      <a:solidFill>
-                        <a:srgbClr val="DCDCDC"/>
-                      </a:solidFill>
-                      <a:prstDash val="solid"/>
-                      <a:round/>
-                      <a:headEnd type="none" w="med" len="med"/>
-                      <a:tailEnd type="none" w="med" len="med"/>
-                    </a:lnR>
-                    <a:lnT w="6350" cap="flat" cmpd="sng" algn="ctr">
-                      <a:solidFill>
-                        <a:srgbClr val="DCDCDC"/>
-                      </a:solidFill>
-                      <a:prstDash val="solid"/>
-                      <a:round/>
-                      <a:headEnd type="none" w="med" len="med"/>
-                      <a:tailEnd type="none" w="med" len="med"/>
-                    </a:lnT>
-                    <a:lnB w="6350" cap="flat" cmpd="sng" algn="ctr">
-                      <a:solidFill>
-                        <a:srgbClr val="DCDCDC"/>
-                      </a:solidFill>
-                      <a:prstDash val="solid"/>
-                      <a:round/>
-                      <a:headEnd type="none" w="med" len="med"/>
-                      <a:tailEnd type="none" w="med" len="med"/>
-                    </a:lnB>
-                    <a:solidFill>
-                      <a:srgbClr val="FFFFFF"/>
-                    </a:solidFill>
-                  </a:tcPr>
-                </a:tc>
-                <a:extLst>
-                  <a:ext uri="{0D108BD9-81ED-4DB2-BD59-A6C34878D82A}">
-                    <a16:rowId xmlns:a16="http://schemas.microsoft.com/office/drawing/2014/main" val="10002"/>
-                  </a:ext>
-                </a:extLst>
-              </a:tr>
-              <a:tr h="402336">
-                <a:tc>
-                  <a:txBody>
-                    <a:bodyPr/>
-                    <a:lstStyle/>
-                    <a:p>
-                      <a:pPr marL="0" indent="0" algn="l">
-                        <a:buNone/>
-                      </a:pPr>
-                      <a:r>
-                        <a:rPr lang="en-US" sz="1200" dirty="0">
-                          <a:solidFill>
-                            <a:srgbClr val="444444"/>
-                          </a:solidFill>
-                          <a:latin typeface="Arial" pitchFamily="34" charset="0"/>
-                          <a:ea typeface="Arial" pitchFamily="34" charset="-122"/>
-                          <a:cs typeface="Arial" pitchFamily="34" charset="-120"/>
-                        </a:rPr>
-                        <a:t>Undecided dominates — 146 of 258 verdicts</a:t>
-                      </a:r>
-                      <a:endParaRPr lang="en-US" sz="1200" dirty="0">
-                        <a:latin typeface="Arial" charset="0"/>
-                        <a:ea typeface="Arial" charset="0"/>
-                        <a:cs typeface="Arial" charset="0"/>
-                      </a:endParaRPr>
-                    </a:p>
-                  </a:txBody>
-                  <a:tcPr marL="109728" marR="109728" marT="36576" marB="36576" anchor="ctr">
-                    <a:lnL w="6350" cap="flat" cmpd="sng" algn="ctr">
-                      <a:solidFill>
-                        <a:srgbClr val="DCDCDC"/>
-                      </a:solidFill>
-                      <a:prstDash val="solid"/>
-                      <a:round/>
-                      <a:headEnd type="none" w="med" len="med"/>
-                      <a:tailEnd type="none" w="med" len="med"/>
-                    </a:lnL>
-                    <a:lnR w="6350" cap="flat" cmpd="sng" algn="ctr">
-                      <a:solidFill>
-                        <a:srgbClr val="DCDCDC"/>
-                      </a:solidFill>
-                      <a:prstDash val="solid"/>
-                      <a:round/>
-                      <a:headEnd type="none" w="med" len="med"/>
-                      <a:tailEnd type="none" w="med" len="med"/>
-                    </a:lnR>
-                    <a:lnT w="6350" cap="flat" cmpd="sng" algn="ctr">
-                      <a:solidFill>
-                        <a:srgbClr val="DCDCDC"/>
-                      </a:solidFill>
-                      <a:prstDash val="solid"/>
-                      <a:round/>
-                      <a:headEnd type="none" w="med" len="med"/>
-                      <a:tailEnd type="none" w="med" len="med"/>
-                    </a:lnT>
-                    <a:lnB w="6350" cap="flat" cmpd="sng" algn="ctr">
-                      <a:solidFill>
-                        <a:srgbClr val="DCDCDC"/>
-                      </a:solidFill>
-                      <a:prstDash val="solid"/>
-                      <a:round/>
-                      <a:headEnd type="none" w="med" len="med"/>
-                      <a:tailEnd type="none" w="med" len="med"/>
-                    </a:lnB>
-                    <a:solidFill>
-                      <a:srgbClr val="FFFFFF"/>
-                    </a:solidFill>
-                  </a:tcPr>
-                </a:tc>
-                <a:tc>
-                  <a:txBody>
-                    <a:bodyPr/>
-                    <a:lstStyle/>
-                    <a:p>
-                      <a:pPr marL="0" indent="0" algn="l">
-                        <a:buNone/>
-                      </a:pPr>
-                      <a:r>
-                        <a:rPr lang="en-US" sz="1200" dirty="0">
-                          <a:solidFill>
-                            <a:srgbClr val="444444"/>
-                          </a:solidFill>
-                          <a:latin typeface="Arial" pitchFamily="34" charset="0"/>
-                          <a:ea typeface="Arial" pitchFamily="34" charset="-122"/>
-                          <a:cs typeface="Arial" pitchFamily="34" charset="-120"/>
-                        </a:rPr>
-                        <a:t>Dense retrieval, query expansion, reranking</a:t>
-                      </a:r>
-                      <a:endParaRPr lang="en-US" sz="1200" dirty="0">
-                        <a:latin typeface="Arial" charset="0"/>
-                        <a:ea typeface="Arial" charset="0"/>
-                        <a:cs typeface="Arial" charset="0"/>
-                      </a:endParaRPr>
-                    </a:p>
-                  </a:txBody>
-                  <a:tcPr marL="109728" marR="109728" marT="36576" marB="36576" anchor="ctr">
-                    <a:lnL w="6350" cap="flat" cmpd="sng" algn="ctr">
-                      <a:solidFill>
-                        <a:srgbClr val="DCDCDC"/>
-                      </a:solidFill>
-                      <a:prstDash val="solid"/>
-                      <a:round/>
-                      <a:headEnd type="none" w="med" len="med"/>
-                      <a:tailEnd type="none" w="med" len="med"/>
-                    </a:lnL>
-                    <a:lnR w="6350" cap="flat" cmpd="sng" algn="ctr">
-                      <a:solidFill>
-                        <a:srgbClr val="DCDCDC"/>
-                      </a:solidFill>
-                      <a:prstDash val="solid"/>
-                      <a:round/>
-                      <a:headEnd type="none" w="med" len="med"/>
-                      <a:tailEnd type="none" w="med" len="med"/>
-                    </a:lnR>
-                    <a:lnT w="6350" cap="flat" cmpd="sng" algn="ctr">
-                      <a:solidFill>
-                        <a:srgbClr val="DCDCDC"/>
-                      </a:solidFill>
-                      <a:prstDash val="solid"/>
-                      <a:round/>
-                      <a:headEnd type="none" w="med" len="med"/>
-                      <a:tailEnd type="none" w="med" len="med"/>
-                    </a:lnT>
-                    <a:lnB w="6350" cap="flat" cmpd="sng" algn="ctr">
-                      <a:solidFill>
-                        <a:srgbClr val="DCDCDC"/>
-                      </a:solidFill>
-                      <a:prstDash val="solid"/>
-                      <a:round/>
-                      <a:headEnd type="none" w="med" len="med"/>
-                      <a:tailEnd type="none" w="med" len="med"/>
-                    </a:lnB>
-                    <a:solidFill>
-                      <a:srgbClr val="FFFFFF"/>
-                    </a:solidFill>
-                  </a:tcPr>
-                </a:tc>
-                <a:tc>
-                  <a:txBody>
-                    <a:bodyPr/>
-                    <a:lstStyle/>
-                    <a:p>
-                      <a:pPr marL="0" indent="0" algn="l">
-                        <a:buNone/>
-                      </a:pPr>
-                      <a:r>
-                        <a:rPr lang="en-US" sz="1200" dirty="0">
-                          <a:solidFill>
-                            <a:srgbClr val="444444"/>
-                          </a:solidFill>
-                          <a:latin typeface="Arial" pitchFamily="34" charset="0"/>
-                          <a:ea typeface="Arial" pitchFamily="34" charset="-122"/>
-                          <a:cs typeface="Arial" pitchFamily="34" charset="-120"/>
-                        </a:rPr>
-                        <a:t>not yet run</a:t>
-                      </a:r>
-                      <a:endParaRPr lang="en-US" sz="1200" dirty="0">
-                        <a:latin typeface="Arial" charset="0"/>
-                        <a:ea typeface="Arial" charset="0"/>
-                        <a:cs typeface="Arial" charset="0"/>
-                      </a:endParaRPr>
-                    </a:p>
-                  </a:txBody>
-                  <a:tcPr marL="109728" marR="109728" marT="36576" marB="36576" anchor="ctr">
-                    <a:lnL w="6350" cap="flat" cmpd="sng" algn="ctr">
-                      <a:solidFill>
-                        <a:srgbClr val="DCDCDC"/>
-                      </a:solidFill>
-                      <a:prstDash val="solid"/>
-                      <a:round/>
-                      <a:headEnd type="none" w="med" len="med"/>
-                      <a:tailEnd type="none" w="med" len="med"/>
-                    </a:lnL>
-                    <a:lnR w="6350" cap="flat" cmpd="sng" algn="ctr">
-                      <a:solidFill>
-                        <a:srgbClr val="DCDCDC"/>
-                      </a:solidFill>
-                      <a:prstDash val="solid"/>
-                      <a:round/>
-                      <a:headEnd type="none" w="med" len="med"/>
-                      <a:tailEnd type="none" w="med" len="med"/>
-                    </a:lnR>
-                    <a:lnT w="6350" cap="flat" cmpd="sng" algn="ctr">
-                      <a:solidFill>
-                        <a:srgbClr val="DCDCDC"/>
-                      </a:solidFill>
-                      <a:prstDash val="solid"/>
-                      <a:round/>
-                      <a:headEnd type="none" w="med" len="med"/>
-                      <a:tailEnd type="none" w="med" len="med"/>
-                    </a:lnT>
-                    <a:lnB w="6350" cap="flat" cmpd="sng" algn="ctr">
-                      <a:solidFill>
-                        <a:srgbClr val="DCDCDC"/>
-                      </a:solidFill>
-                      <a:prstDash val="solid"/>
-                      <a:round/>
-                      <a:headEnd type="none" w="med" len="med"/>
-                      <a:tailEnd type="none" w="med" len="med"/>
-                    </a:lnB>
-                    <a:solidFill>
-                      <a:srgbClr val="FFFFFF"/>
-                    </a:solidFill>
-                  </a:tcPr>
-                </a:tc>
-                <a:extLst>
-                  <a:ext uri="{0D108BD9-81ED-4DB2-BD59-A6C34878D82A}">
-                    <a16:rowId xmlns:a16="http://schemas.microsoft.com/office/drawing/2014/main" val="10003"/>
-                  </a:ext>
-                </a:extLst>
-              </a:tr>
-              <a:tr h="402336">
-                <a:tc>
-                  <a:txBody>
-                    <a:bodyPr/>
-                    <a:lstStyle/>
-                    <a:p>
-                      <a:pPr marL="0" indent="0" algn="l">
-                        <a:buNone/>
-                      </a:pPr>
-                      <a:r>
-                        <a:rPr lang="en-US" sz="1200" dirty="0">
-                          <a:solidFill>
-                            <a:srgbClr val="444444"/>
-                          </a:solidFill>
-                          <a:latin typeface="Arial" pitchFamily="34" charset="0"/>
-                          <a:ea typeface="Arial" pitchFamily="34" charset="-122"/>
-                          <a:cs typeface="Arial" pitchFamily="34" charset="-120"/>
-                        </a:rPr>
-                        <a:t>Refined facts are sometimes still flagged</a:t>
-                      </a:r>
-                      <a:endParaRPr lang="en-US" sz="1200" dirty="0">
-                        <a:latin typeface="Arial" charset="0"/>
-                        <a:ea typeface="Arial" charset="0"/>
-                        <a:cs typeface="Arial" charset="0"/>
-                      </a:endParaRPr>
-                    </a:p>
-                  </a:txBody>
-                  <a:tcPr marL="109728" marR="109728" marT="36576" marB="36576" anchor="ctr">
-                    <a:lnL w="6350" cap="flat" cmpd="sng" algn="ctr">
-                      <a:solidFill>
-                        <a:srgbClr val="DCDCDC"/>
-                      </a:solidFill>
-                      <a:prstDash val="solid"/>
-                      <a:round/>
-                      <a:headEnd type="none" w="med" len="med"/>
-                      <a:tailEnd type="none" w="med" len="med"/>
-                    </a:lnL>
-                    <a:lnR w="6350" cap="flat" cmpd="sng" algn="ctr">
-                      <a:solidFill>
-                        <a:srgbClr val="DCDCDC"/>
-                      </a:solidFill>
-                      <a:prstDash val="solid"/>
-                      <a:round/>
-                      <a:headEnd type="none" w="med" len="med"/>
-                      <a:tailEnd type="none" w="med" len="med"/>
-                    </a:lnR>
-                    <a:lnT w="6350" cap="flat" cmpd="sng" algn="ctr">
-                      <a:solidFill>
-                        <a:srgbClr val="DCDCDC"/>
-                      </a:solidFill>
-                      <a:prstDash val="solid"/>
-                      <a:round/>
-                      <a:headEnd type="none" w="med" len="med"/>
-                      <a:tailEnd type="none" w="med" len="med"/>
-                    </a:lnT>
-                    <a:lnB w="6350" cap="flat" cmpd="sng" algn="ctr">
-                      <a:solidFill>
-                        <a:srgbClr val="DCDCDC"/>
-                      </a:solidFill>
-                      <a:prstDash val="solid"/>
-                      <a:round/>
-                      <a:headEnd type="none" w="med" len="med"/>
-                      <a:tailEnd type="none" w="med" len="med"/>
-                    </a:lnB>
-                    <a:solidFill>
-                      <a:srgbClr val="FFFFFF"/>
-                    </a:solidFill>
-                  </a:tcPr>
-                </a:tc>
-                <a:tc>
-                  <a:txBody>
-                    <a:bodyPr/>
-                    <a:lstStyle/>
-                    <a:p>
-                      <a:pPr marL="0" indent="0" algn="l">
-                        <a:buNone/>
-                      </a:pPr>
-                      <a:r>
-                        <a:rPr lang="en-US" sz="1200" dirty="0">
-                          <a:solidFill>
-                            <a:srgbClr val="444444"/>
-                          </a:solidFill>
-                          <a:latin typeface="Arial" pitchFamily="34" charset="0"/>
-                          <a:ea typeface="Arial" pitchFamily="34" charset="-122"/>
-                          <a:cs typeface="Arial" pitchFamily="34" charset="-120"/>
-                        </a:rPr>
-                        <a:t>Iterative refinement, maximum two passes</a:t>
-                      </a:r>
-                      <a:endParaRPr lang="en-US" sz="1200" dirty="0">
-                        <a:latin typeface="Arial" charset="0"/>
-                        <a:ea typeface="Arial" charset="0"/>
-                        <a:cs typeface="Arial" charset="0"/>
-                      </a:endParaRPr>
-                    </a:p>
-                  </a:txBody>
-                  <a:tcPr marL="109728" marR="109728" marT="36576" marB="36576" anchor="ctr">
-                    <a:lnL w="6350" cap="flat" cmpd="sng" algn="ctr">
-                      <a:solidFill>
-                        <a:srgbClr val="DCDCDC"/>
-                      </a:solidFill>
-                      <a:prstDash val="solid"/>
-                      <a:round/>
-                      <a:headEnd type="none" w="med" len="med"/>
-                      <a:tailEnd type="none" w="med" len="med"/>
-                    </a:lnL>
-                    <a:lnR w="6350" cap="flat" cmpd="sng" algn="ctr">
-                      <a:solidFill>
-                        <a:srgbClr val="DCDCDC"/>
-                      </a:solidFill>
-                      <a:prstDash val="solid"/>
-                      <a:round/>
-                      <a:headEnd type="none" w="med" len="med"/>
-                      <a:tailEnd type="none" w="med" len="med"/>
-                    </a:lnR>
-                    <a:lnT w="6350" cap="flat" cmpd="sng" algn="ctr">
-                      <a:solidFill>
-                        <a:srgbClr val="DCDCDC"/>
-                      </a:solidFill>
-                      <a:prstDash val="solid"/>
-                      <a:round/>
-                      <a:headEnd type="none" w="med" len="med"/>
-                      <a:tailEnd type="none" w="med" len="med"/>
-                    </a:lnT>
-                    <a:lnB w="6350" cap="flat" cmpd="sng" algn="ctr">
-                      <a:solidFill>
-                        <a:srgbClr val="DCDCDC"/>
-                      </a:solidFill>
-                      <a:prstDash val="solid"/>
-                      <a:round/>
-                      <a:headEnd type="none" w="med" len="med"/>
-                      <a:tailEnd type="none" w="med" len="med"/>
-                    </a:lnB>
-                    <a:solidFill>
-                      <a:srgbClr val="FFFFFF"/>
-                    </a:solidFill>
-                  </a:tcPr>
-                </a:tc>
-                <a:tc>
-                  <a:txBody>
-                    <a:bodyPr/>
-                    <a:lstStyle/>
-                    <a:p>
-                      <a:pPr marL="0" indent="0" algn="l">
-                        <a:buNone/>
-                      </a:pPr>
-                      <a:r>
-                        <a:rPr lang="en-US" sz="1200" dirty="0">
-                          <a:solidFill>
-                            <a:srgbClr val="444444"/>
-                          </a:solidFill>
-                          <a:latin typeface="Arial" pitchFamily="34" charset="0"/>
-                          <a:ea typeface="Arial" pitchFamily="34" charset="-122"/>
-                          <a:cs typeface="Arial" pitchFamily="34" charset="-120"/>
-                        </a:rPr>
-                        <a:t>not yet run</a:t>
-                      </a:r>
-                      <a:endParaRPr lang="en-US" sz="1200" dirty="0">
-                        <a:latin typeface="Arial" charset="0"/>
-                        <a:ea typeface="Arial" charset="0"/>
-                        <a:cs typeface="Arial" charset="0"/>
-                      </a:endParaRPr>
-                    </a:p>
-                  </a:txBody>
-                  <a:tcPr marL="109728" marR="109728" marT="36576" marB="36576" anchor="ctr">
-                    <a:lnL w="6350" cap="flat" cmpd="sng" algn="ctr">
-                      <a:solidFill>
-                        <a:srgbClr val="DCDCDC"/>
-                      </a:solidFill>
-                      <a:prstDash val="solid"/>
-                      <a:round/>
-                      <a:headEnd type="none" w="med" len="med"/>
-                      <a:tailEnd type="none" w="med" len="med"/>
-                    </a:lnL>
-                    <a:lnR w="6350" cap="flat" cmpd="sng" algn="ctr">
-                      <a:solidFill>
-                        <a:srgbClr val="DCDCDC"/>
-                      </a:solidFill>
-                      <a:prstDash val="solid"/>
-                      <a:round/>
-                      <a:headEnd type="none" w="med" len="med"/>
-                      <a:tailEnd type="none" w="med" len="med"/>
-                    </a:lnR>
-                    <a:lnT w="6350" cap="flat" cmpd="sng" algn="ctr">
-                      <a:solidFill>
-                        <a:srgbClr val="DCDCDC"/>
-                      </a:solidFill>
-                      <a:prstDash val="solid"/>
-                      <a:round/>
-                      <a:headEnd type="none" w="med" len="med"/>
-                      <a:tailEnd type="none" w="med" len="med"/>
-                    </a:lnT>
-                    <a:lnB w="6350" cap="flat" cmpd="sng" algn="ctr">
-                      <a:solidFill>
-                        <a:srgbClr val="DCDCDC"/>
-                      </a:solidFill>
-                      <a:prstDash val="solid"/>
-                      <a:round/>
-                      <a:headEnd type="none" w="med" len="med"/>
-                      <a:tailEnd type="none" w="med" len="med"/>
-                    </a:lnB>
-                    <a:solidFill>
-                      <a:srgbClr val="FFFFFF"/>
-                    </a:solidFill>
-                  </a:tcPr>
-                </a:tc>
-                <a:extLst>
-                  <a:ext uri="{0D108BD9-81ED-4DB2-BD59-A6C34878D82A}">
-                    <a16:rowId xmlns:a16="http://schemas.microsoft.com/office/drawing/2014/main" val="10004"/>
-                  </a:ext>
-                </a:extLst>
-              </a:tr>
-              <a:tr h="402336">
-                <a:tc>
-                  <a:txBody>
-                    <a:bodyPr/>
-                    <a:lstStyle/>
-                    <a:p>
-                      <a:pPr marL="0" indent="0" algn="l">
-                        <a:buNone/>
-                      </a:pPr>
-                      <a:r>
-                        <a:rPr lang="en-US" sz="1200" dirty="0">
-                          <a:solidFill>
-                            <a:srgbClr val="444444"/>
-                          </a:solidFill>
-                          <a:latin typeface="Arial" pitchFamily="34" charset="0"/>
-                          <a:ea typeface="Arial" pitchFamily="34" charset="-122"/>
-                          <a:cs typeface="Arial" pitchFamily="34" charset="-120"/>
-                        </a:rPr>
-                        <a:t>12 questions, 86 facts, no human annotation</a:t>
-                      </a:r>
-                      <a:endParaRPr lang="en-US" sz="1200" dirty="0">
-                        <a:latin typeface="Arial" charset="0"/>
-                        <a:ea typeface="Arial" charset="0"/>
-                        <a:cs typeface="Arial" charset="0"/>
-                      </a:endParaRPr>
-                    </a:p>
-                  </a:txBody>
-                  <a:tcPr marL="109728" marR="109728" marT="36576" marB="36576" anchor="ctr">
-                    <a:lnL w="6350" cap="flat" cmpd="sng" algn="ctr">
-                      <a:solidFill>
-                        <a:srgbClr val="DCDCDC"/>
-                      </a:solidFill>
-                      <a:prstDash val="solid"/>
-                      <a:round/>
-                      <a:headEnd type="none" w="med" len="med"/>
-                      <a:tailEnd type="none" w="med" len="med"/>
-                    </a:lnL>
-                    <a:lnR w="6350" cap="flat" cmpd="sng" algn="ctr">
-                      <a:solidFill>
-                        <a:srgbClr val="DCDCDC"/>
-                      </a:solidFill>
-                      <a:prstDash val="solid"/>
-                      <a:round/>
-                      <a:headEnd type="none" w="med" len="med"/>
-                      <a:tailEnd type="none" w="med" len="med"/>
-                    </a:lnR>
-                    <a:lnT w="6350" cap="flat" cmpd="sng" algn="ctr">
-                      <a:solidFill>
-                        <a:srgbClr val="DCDCDC"/>
-                      </a:solidFill>
-                      <a:prstDash val="solid"/>
-                      <a:round/>
-                      <a:headEnd type="none" w="med" len="med"/>
-                      <a:tailEnd type="none" w="med" len="med"/>
-                    </a:lnT>
-                    <a:lnB w="6350" cap="flat" cmpd="sng" algn="ctr">
-                      <a:solidFill>
-                        <a:srgbClr val="DCDCDC"/>
-                      </a:solidFill>
-                      <a:prstDash val="solid"/>
-                      <a:round/>
-                      <a:headEnd type="none" w="med" len="med"/>
-                      <a:tailEnd type="none" w="med" len="med"/>
-                    </a:lnB>
-                    <a:solidFill>
-                      <a:srgbClr val="FFFFFF"/>
-                    </a:solidFill>
-                  </a:tcPr>
-                </a:tc>
-                <a:tc>
-                  <a:txBody>
-                    <a:bodyPr/>
-                    <a:lstStyle/>
-                    <a:p>
-                      <a:pPr marL="0" indent="0" algn="l">
-                        <a:buNone/>
-                      </a:pPr>
-                      <a:r>
-                        <a:rPr lang="en-US" sz="1200" dirty="0">
-                          <a:solidFill>
-                            <a:srgbClr val="444444"/>
-                          </a:solidFill>
-                          <a:latin typeface="Arial" pitchFamily="34" charset="0"/>
-                          <a:ea typeface="Arial" pitchFamily="34" charset="-122"/>
-                          <a:cs typeface="Arial" pitchFamily="34" charset="-120"/>
-                        </a:rPr>
-                        <a:t>Larger benchmark, human-verified references</a:t>
-                      </a:r>
-                      <a:endParaRPr lang="en-US" sz="1200" dirty="0">
-                        <a:latin typeface="Arial" charset="0"/>
-                        <a:ea typeface="Arial" charset="0"/>
-                        <a:cs typeface="Arial" charset="0"/>
-                      </a:endParaRPr>
-                    </a:p>
-                  </a:txBody>
-                  <a:tcPr marL="109728" marR="109728" marT="36576" marB="36576" anchor="ctr">
-                    <a:lnL w="6350" cap="flat" cmpd="sng" algn="ctr">
-                      <a:solidFill>
-                        <a:srgbClr val="DCDCDC"/>
-                      </a:solidFill>
-                      <a:prstDash val="solid"/>
-                      <a:round/>
-                      <a:headEnd type="none" w="med" len="med"/>
-                      <a:tailEnd type="none" w="med" len="med"/>
-                    </a:lnL>
-                    <a:lnR w="6350" cap="flat" cmpd="sng" algn="ctr">
-                      <a:solidFill>
-                        <a:srgbClr val="DCDCDC"/>
-                      </a:solidFill>
-                      <a:prstDash val="solid"/>
-                      <a:round/>
-                      <a:headEnd type="none" w="med" len="med"/>
-                      <a:tailEnd type="none" w="med" len="med"/>
-                    </a:lnR>
-                    <a:lnT w="6350" cap="flat" cmpd="sng" algn="ctr">
-                      <a:solidFill>
-                        <a:srgbClr val="DCDCDC"/>
-                      </a:solidFill>
-                      <a:prstDash val="solid"/>
-                      <a:round/>
-                      <a:headEnd type="none" w="med" len="med"/>
-                      <a:tailEnd type="none" w="med" len="med"/>
-                    </a:lnT>
-                    <a:lnB w="6350" cap="flat" cmpd="sng" algn="ctr">
-                      <a:solidFill>
-                        <a:srgbClr val="DCDCDC"/>
-                      </a:solidFill>
-                      <a:prstDash val="solid"/>
-                      <a:round/>
-                      <a:headEnd type="none" w="med" len="med"/>
-                      <a:tailEnd type="none" w="med" len="med"/>
-                    </a:lnB>
-                    <a:solidFill>
-                      <a:srgbClr val="FFFFFF"/>
-                    </a:solidFill>
-                  </a:tcPr>
-                </a:tc>
-                <a:tc>
-                  <a:txBody>
-                    <a:bodyPr/>
-                    <a:lstStyle/>
-                    <a:p>
-                      <a:pPr marL="0" indent="0" algn="l">
-                        <a:buNone/>
-                      </a:pPr>
-                      <a:r>
-                        <a:rPr lang="en-US" sz="1200" dirty="0">
-                          <a:solidFill>
-                            <a:srgbClr val="444444"/>
-                          </a:solidFill>
-                          <a:latin typeface="Arial" pitchFamily="34" charset="0"/>
-                          <a:ea typeface="Arial" pitchFamily="34" charset="-122"/>
-                          <a:cs typeface="Arial" pitchFamily="34" charset="-120"/>
-                        </a:rPr>
-                        <a:t>not yet run</a:t>
-                      </a:r>
-                      <a:endParaRPr lang="en-US" sz="1200" dirty="0">
-                        <a:latin typeface="Arial" charset="0"/>
-                        <a:ea typeface="Arial" charset="0"/>
-                        <a:cs typeface="Arial" charset="0"/>
-                      </a:endParaRPr>
-                    </a:p>
-                  </a:txBody>
-                  <a:tcPr marL="109728" marR="109728" marT="36576" marB="36576" anchor="ctr">
-                    <a:lnL w="6350" cap="flat" cmpd="sng" algn="ctr">
-                      <a:solidFill>
-                        <a:srgbClr val="DCDCDC"/>
-                      </a:solidFill>
-                      <a:prstDash val="solid"/>
-                      <a:round/>
-                      <a:headEnd type="none" w="med" len="med"/>
-                      <a:tailEnd type="none" w="med" len="med"/>
-                    </a:lnL>
-                    <a:lnR w="6350" cap="flat" cmpd="sng" algn="ctr">
-                      <a:solidFill>
-                        <a:srgbClr val="DCDCDC"/>
-                      </a:solidFill>
-                      <a:prstDash val="solid"/>
-                      <a:round/>
-                      <a:headEnd type="none" w="med" len="med"/>
-                      <a:tailEnd type="none" w="med" len="med"/>
-                    </a:lnR>
-                    <a:lnT w="6350" cap="flat" cmpd="sng" algn="ctr">
-                      <a:solidFill>
-                        <a:srgbClr val="DCDCDC"/>
-                      </a:solidFill>
-                      <a:prstDash val="solid"/>
-                      <a:round/>
-                      <a:headEnd type="none" w="med" len="med"/>
-                      <a:tailEnd type="none" w="med" len="med"/>
-                    </a:lnT>
-                    <a:lnB w="6350" cap="flat" cmpd="sng" algn="ctr">
-                      <a:solidFill>
-                        <a:srgbClr val="DCDCDC"/>
-                      </a:solidFill>
-                      <a:prstDash val="solid"/>
-                      <a:round/>
-                      <a:headEnd type="none" w="med" len="med"/>
-                      <a:tailEnd type="none" w="med" len="med"/>
-                    </a:lnB>
-                    <a:solidFill>
-                      <a:srgbClr val="FFFFFF"/>
-                    </a:solidFill>
-                  </a:tcPr>
-                </a:tc>
-                <a:extLst>
-                  <a:ext uri="{0D108BD9-81ED-4DB2-BD59-A6C34878D82A}">
-                    <a16:rowId xmlns:a16="http://schemas.microsoft.com/office/drawing/2014/main" val="10005"/>
-                  </a:ext>
-                </a:extLst>
-              </a:tr>
-              <a:tr h="402336">
-                <a:tc>
-                  <a:txBody>
-                    <a:bodyPr/>
-                    <a:lstStyle/>
-                    <a:p>
-                      <a:pPr marL="0" indent="0" algn="l">
-                        <a:buNone/>
-                      </a:pPr>
-                      <a:r>
-                        <a:rPr lang="en-US" sz="1200" dirty="0">
-                          <a:solidFill>
-                            <a:srgbClr val="444444"/>
-                          </a:solidFill>
-                          <a:latin typeface="Arial" pitchFamily="34" charset="0"/>
-                          <a:ea typeface="Arial" pitchFamily="34" charset="-122"/>
-                          <a:cs typeface="Arial" pitchFamily="34" charset="-120"/>
-                        </a:rPr>
-                        <a:t>Recall is itself judge-dependent (0.41 vs 0.28)</a:t>
-                      </a:r>
-                      <a:endParaRPr lang="en-US" sz="1200" dirty="0">
-                        <a:latin typeface="Arial" charset="0"/>
-                        <a:ea typeface="Arial" charset="0"/>
-                        <a:cs typeface="Arial" charset="0"/>
-                      </a:endParaRPr>
-                    </a:p>
-                  </a:txBody>
-                  <a:tcPr marL="109728" marR="109728" marT="36576" marB="36576" anchor="ctr">
-                    <a:lnL w="6350" cap="flat" cmpd="sng" algn="ctr">
-                      <a:solidFill>
-                        <a:srgbClr val="DCDCDC"/>
-                      </a:solidFill>
-                      <a:prstDash val="solid"/>
-                      <a:round/>
-                      <a:headEnd type="none" w="med" len="med"/>
-                      <a:tailEnd type="none" w="med" len="med"/>
-                    </a:lnL>
-                    <a:lnR w="6350" cap="flat" cmpd="sng" algn="ctr">
-                      <a:solidFill>
-                        <a:srgbClr val="DCDCDC"/>
-                      </a:solidFill>
-                      <a:prstDash val="solid"/>
-                      <a:round/>
-                      <a:headEnd type="none" w="med" len="med"/>
-                      <a:tailEnd type="none" w="med" len="med"/>
-                    </a:lnR>
-                    <a:lnT w="6350" cap="flat" cmpd="sng" algn="ctr">
-                      <a:solidFill>
-                        <a:srgbClr val="DCDCDC"/>
-                      </a:solidFill>
-                      <a:prstDash val="solid"/>
-                      <a:round/>
-                      <a:headEnd type="none" w="med" len="med"/>
-                      <a:tailEnd type="none" w="med" len="med"/>
-                    </a:lnT>
-                    <a:lnB w="6350" cap="flat" cmpd="sng" algn="ctr">
-                      <a:solidFill>
-                        <a:srgbClr val="DCDCDC"/>
-                      </a:solidFill>
-                      <a:prstDash val="solid"/>
-                      <a:round/>
-                      <a:headEnd type="none" w="med" len="med"/>
-                      <a:tailEnd type="none" w="med" len="med"/>
-                    </a:lnB>
-                    <a:solidFill>
-                      <a:srgbClr val="FFFFFF"/>
-                    </a:solidFill>
-                  </a:tcPr>
-                </a:tc>
-                <a:tc>
-                  <a:txBody>
-                    <a:bodyPr/>
-                    <a:lstStyle/>
-                    <a:p>
-                      <a:pPr marL="0" indent="0" algn="l">
-                        <a:buNone/>
-                      </a:pPr>
-                      <a:r>
-                        <a:rPr lang="en-US" sz="1200" dirty="0">
-                          <a:solidFill>
-                            <a:srgbClr val="444444"/>
-                          </a:solidFill>
-                          <a:latin typeface="Arial" pitchFamily="34" charset="0"/>
-                          <a:ea typeface="Arial" pitchFamily="34" charset="-122"/>
-                          <a:cs typeface="Arial" pitchFamily="34" charset="-120"/>
-                        </a:rPr>
-                        <a:t>Fixed entailment model across all runs</a:t>
-                      </a:r>
-                      <a:endParaRPr lang="en-US" sz="1200" dirty="0">
-                        <a:latin typeface="Arial" charset="0"/>
-                        <a:ea typeface="Arial" charset="0"/>
-                        <a:cs typeface="Arial" charset="0"/>
-                      </a:endParaRPr>
-                    </a:p>
-                  </a:txBody>
-                  <a:tcPr marL="109728" marR="109728" marT="36576" marB="36576" anchor="ctr">
-                    <a:lnL w="6350" cap="flat" cmpd="sng" algn="ctr">
-                      <a:solidFill>
-                        <a:srgbClr val="DCDCDC"/>
-                      </a:solidFill>
-                      <a:prstDash val="solid"/>
-                      <a:round/>
-                      <a:headEnd type="none" w="med" len="med"/>
-                      <a:tailEnd type="none" w="med" len="med"/>
-                    </a:lnL>
-                    <a:lnR w="6350" cap="flat" cmpd="sng" algn="ctr">
-                      <a:solidFill>
-                        <a:srgbClr val="DCDCDC"/>
-                      </a:solidFill>
-                      <a:prstDash val="solid"/>
-                      <a:round/>
-                      <a:headEnd type="none" w="med" len="med"/>
-                      <a:tailEnd type="none" w="med" len="med"/>
-                    </a:lnR>
-                    <a:lnT w="6350" cap="flat" cmpd="sng" algn="ctr">
-                      <a:solidFill>
-                        <a:srgbClr val="DCDCDC"/>
-                      </a:solidFill>
-                      <a:prstDash val="solid"/>
-                      <a:round/>
-                      <a:headEnd type="none" w="med" len="med"/>
-                      <a:tailEnd type="none" w="med" len="med"/>
-                    </a:lnT>
-                    <a:lnB w="6350" cap="flat" cmpd="sng" algn="ctr">
-                      <a:solidFill>
-                        <a:srgbClr val="DCDCDC"/>
-                      </a:solidFill>
-                      <a:prstDash val="solid"/>
-                      <a:round/>
-                      <a:headEnd type="none" w="med" len="med"/>
-                      <a:tailEnd type="none" w="med" len="med"/>
-                    </a:lnB>
-                    <a:solidFill>
-                      <a:srgbClr val="FFFFFF"/>
-                    </a:solidFill>
-                  </a:tcPr>
-                </a:tc>
-                <a:tc>
-                  <a:txBody>
-                    <a:bodyPr/>
-                    <a:lstStyle/>
-                    <a:p>
-                      <a:pPr marL="0" indent="0" algn="l">
-                        <a:buNone/>
-                      </a:pPr>
-                      <a:r>
-                        <a:rPr lang="en-US" sz="1200" dirty="0">
-                          <a:solidFill>
-                            <a:srgbClr val="444444"/>
-                          </a:solidFill>
-                          <a:latin typeface="Arial" pitchFamily="34" charset="0"/>
-                          <a:ea typeface="Arial" pitchFamily="34" charset="-122"/>
-                          <a:cs typeface="Arial" pitchFamily="34" charset="-120"/>
-                        </a:rPr>
-                        <a:t>not yet run</a:t>
-                      </a:r>
-                      <a:endParaRPr lang="en-US" sz="1200" dirty="0">
-                        <a:latin typeface="Arial" charset="0"/>
-                        <a:ea typeface="Arial" charset="0"/>
-                        <a:cs typeface="Arial" charset="0"/>
-                      </a:endParaRPr>
-                    </a:p>
-                  </a:txBody>
-                  <a:tcPr marL="109728" marR="109728" marT="36576" marB="36576" anchor="ctr">
-                    <a:lnL w="6350" cap="flat" cmpd="sng" algn="ctr">
-                      <a:solidFill>
-                        <a:srgbClr val="DCDCDC"/>
-                      </a:solidFill>
-                      <a:prstDash val="solid"/>
-                      <a:round/>
-                      <a:headEnd type="none" w="med" len="med"/>
-                      <a:tailEnd type="none" w="med" len="med"/>
-                    </a:lnL>
-                    <a:lnR w="6350" cap="flat" cmpd="sng" algn="ctr">
-                      <a:solidFill>
-                        <a:srgbClr val="DCDCDC"/>
-                      </a:solidFill>
-                      <a:prstDash val="solid"/>
-                      <a:round/>
-                      <a:headEnd type="none" w="med" len="med"/>
-                      <a:tailEnd type="none" w="med" len="med"/>
-                    </a:lnR>
-                    <a:lnT w="6350" cap="flat" cmpd="sng" algn="ctr">
-                      <a:solidFill>
-                        <a:srgbClr val="DCDCDC"/>
-                      </a:solidFill>
-                      <a:prstDash val="solid"/>
-                      <a:round/>
-                      <a:headEnd type="none" w="med" len="med"/>
-                      <a:tailEnd type="none" w="med" len="med"/>
-                    </a:lnT>
-                    <a:lnB w="6350" cap="flat" cmpd="sng" algn="ctr">
-                      <a:solidFill>
-                        <a:srgbClr val="DCDCDC"/>
-                      </a:solidFill>
-                      <a:prstDash val="solid"/>
-                      <a:round/>
-                      <a:headEnd type="none" w="med" len="med"/>
-                      <a:tailEnd type="none" w="med" len="med"/>
-                    </a:lnB>
-                    <a:solidFill>
-                      <a:srgbClr val="FFFFFF"/>
-                    </a:solidFill>
-                  </a:tcPr>
-                </a:tc>
-                <a:extLst>
-                  <a:ext uri="{0D108BD9-81ED-4DB2-BD59-A6C34878D82A}">
-                    <a16:rowId xmlns:a16="http://schemas.microsoft.com/office/drawing/2014/main" val="10006"/>
-                  </a:ext>
-                </a:extLst>
-              </a:tr>
-            </a:tbl>
-          </a:graphicData>
-        </a:graphic>
-      </p:graphicFrame>
       <p:sp>
         <p:nvSpPr>
           <p:cNvPr id="25" name="Slide Number Placeholder 0"/>
@@ -16857,6 +15205,944 @@
               <a:t>14</a:t>
             </a:fld>
             <a:endParaRPr lang="en-US"/>
+          </a:p>
+        </p:txBody>
+      </p:sp>
+      <p:sp>
+        <p:nvSpPr>
+          <p:cNvPr id="26" name="p-card"/>
+          <p:cNvSpPr/>
+          <p:nvPr/>
+        </p:nvSpPr>
+        <p:spPr>
+          <a:xfrm>
+            <a:off x="548640" y="1600200"/>
+            <a:ext cx="3505200" cy="2103120"/>
+          </a:xfrm>
+          <a:prstGeom prst="rect">
+            <a:avLst/>
+          </a:prstGeom>
+          <a:solidFill>
+            <a:srgbClr val="FFFFFF"/>
+          </a:solidFill>
+          <a:ln w="9525">
+            <a:solidFill>
+              <a:srgbClr val="DCDCDC"/>
+            </a:solidFill>
+          </a:ln>
+          <a:effectLst/>
+        </p:spPr>
+        <p:style>
+          <a:lnRef idx="1">
+            <a:schemeClr val="accent1"/>
+          </a:lnRef>
+          <a:fillRef idx="3">
+            <a:schemeClr val="accent1"/>
+          </a:fillRef>
+          <a:effectRef idx="2">
+            <a:schemeClr val="accent1"/>
+          </a:effectRef>
+          <a:fontRef idx="minor">
+            <a:schemeClr val="lt1"/>
+          </a:fontRef>
+        </p:style>
+        <p:txBody>
+          <a:bodyPr rtlCol="0" anchor="ctr"/>
+          <a:lstStyle/>
+          <a:p/>
+        </p:txBody>
+      </p:sp>
+      <p:sp>
+        <p:nvSpPr>
+          <p:cNvPr id="27" name="p-edge"/>
+          <p:cNvSpPr/>
+          <p:nvPr/>
+        </p:nvSpPr>
+        <p:spPr>
+          <a:xfrm>
+            <a:off x="548640" y="1600200"/>
+            <a:ext cx="29260" cy="2103120"/>
+          </a:xfrm>
+          <a:prstGeom prst="rect">
+            <a:avLst/>
+          </a:prstGeom>
+          <a:solidFill>
+            <a:srgbClr val="E90802"/>
+          </a:solidFill>
+          <a:ln w="3175">
+            <a:solidFill>
+              <a:srgbClr val="E90802"/>
+            </a:solidFill>
+          </a:ln>
+          <a:effectLst/>
+        </p:spPr>
+        <p:style>
+          <a:lnRef idx="1">
+            <a:schemeClr val="accent1"/>
+          </a:lnRef>
+          <a:fillRef idx="3">
+            <a:schemeClr val="accent1"/>
+          </a:fillRef>
+          <a:effectRef idx="2">
+            <a:schemeClr val="accent1"/>
+          </a:effectRef>
+          <a:fontRef idx="minor">
+            <a:schemeClr val="lt1"/>
+          </a:fontRef>
+        </p:style>
+        <p:txBody>
+          <a:bodyPr rtlCol="0" anchor="ctr"/>
+          <a:lstStyle/>
+          <a:p>
+            <a:pPr algn="ctr"/>
+          </a:p>
+        </p:txBody>
+      </p:sp>
+      <p:sp>
+        <p:nvSpPr>
+          <p:cNvPr id="28" name="p-h"/>
+          <p:cNvSpPr txBox="1"/>
+          <p:nvPr/>
+        </p:nvSpPr>
+        <p:spPr>
+          <a:xfrm>
+            <a:off x="804672" y="1801368"/>
+            <a:ext cx="2993136" cy="457200"/>
+          </a:xfrm>
+          <a:prstGeom prst="rect">
+            <a:avLst/>
+          </a:prstGeom>
+          <a:noFill/>
+        </p:spPr>
+        <p:txBody>
+          <a:bodyPr wrap="square" lIns="0" rIns="0" tIns="0" bIns="0">
+            <a:spAutoFit/>
+          </a:bodyPr>
+          <a:lstStyle/>
+          <a:p>
+            <a:pPr>
+              <a:lnSpc>
+                <a:spcPct val="110000"/>
+              </a:lnSpc>
+            </a:pPr>
+            <a:r>
+              <a:rPr sz="1300" b="1">
+                <a:solidFill>
+                  <a:srgbClr val="E90802"/>
+                </a:solidFill>
+                <a:latin typeface="Arial"/>
+              </a:rPr>
+              <a:t>Faithfulness-guarded refinement</a:t>
+            </a:r>
+          </a:p>
+        </p:txBody>
+      </p:sp>
+      <p:sp>
+        <p:nvSpPr>
+          <p:cNvPr id="29" name="p-b"/>
+          <p:cNvSpPr txBox="1"/>
+          <p:nvPr/>
+        </p:nvSpPr>
+        <p:spPr>
+          <a:xfrm>
+            <a:off x="804672" y="2350008"/>
+            <a:ext cx="2993136" cy="1188719"/>
+          </a:xfrm>
+          <a:prstGeom prst="rect">
+            <a:avLst/>
+          </a:prstGeom>
+          <a:noFill/>
+        </p:spPr>
+        <p:txBody>
+          <a:bodyPr wrap="square" lIns="0" rIns="0" tIns="0" bIns="0" anchor="t">
+            <a:spAutoFit/>
+          </a:bodyPr>
+          <a:lstStyle/>
+          <a:p>
+            <a:pPr>
+              <a:lnSpc>
+                <a:spcPct val="125000"/>
+              </a:lnSpc>
+            </a:pPr>
+            <a:r>
+              <a:rPr sz="1100">
+                <a:solidFill>
+                  <a:srgbClr val="444444"/>
+                </a:solidFill>
+                <a:latin typeface="Arial"/>
+              </a:rPr>
+              <a:t>Accept a rewritten fact only when the original response entails it, checked by an NLI model.</a:t>
+            </a:r>
+          </a:p>
+          <a:p>
+            <a:pPr>
+              <a:lnSpc>
+                <a:spcPct val="125000"/>
+              </a:lnSpc>
+              <a:spcBef>
+                <a:spcPts val="600"/>
+              </a:spcBef>
+            </a:pPr>
+            <a:r>
+              <a:rPr sz="1050">
+                <a:solidFill>
+                  <a:srgbClr val="767676"/>
+                </a:solidFill>
+                <a:latin typeface="Arial"/>
+              </a:rPr>
+              <a:t>Targets the worst failure we saw: the refiner wrote “There was NO demand for gold as jewelry”, inverting the claim.</a:t>
+            </a:r>
+          </a:p>
+        </p:txBody>
+      </p:sp>
+      <p:sp>
+        <p:nvSpPr>
+          <p:cNvPr id="30" name="p-card"/>
+          <p:cNvSpPr/>
+          <p:nvPr/>
+        </p:nvSpPr>
+        <p:spPr>
+          <a:xfrm>
+            <a:off x="4328160" y="1600200"/>
+            <a:ext cx="3505200" cy="2103120"/>
+          </a:xfrm>
+          <a:prstGeom prst="rect">
+            <a:avLst/>
+          </a:prstGeom>
+          <a:solidFill>
+            <a:srgbClr val="FFFFFF"/>
+          </a:solidFill>
+          <a:ln w="9525">
+            <a:solidFill>
+              <a:srgbClr val="DCDCDC"/>
+            </a:solidFill>
+          </a:ln>
+          <a:effectLst/>
+        </p:spPr>
+        <p:style>
+          <a:lnRef idx="1">
+            <a:schemeClr val="accent1"/>
+          </a:lnRef>
+          <a:fillRef idx="3">
+            <a:schemeClr val="accent1"/>
+          </a:fillRef>
+          <a:effectRef idx="2">
+            <a:schemeClr val="accent1"/>
+          </a:effectRef>
+          <a:fontRef idx="minor">
+            <a:schemeClr val="lt1"/>
+          </a:fontRef>
+        </p:style>
+        <p:txBody>
+          <a:bodyPr rtlCol="0" anchor="ctr"/>
+          <a:lstStyle/>
+          <a:p/>
+        </p:txBody>
+      </p:sp>
+      <p:sp>
+        <p:nvSpPr>
+          <p:cNvPr id="31" name="p-h"/>
+          <p:cNvSpPr txBox="1"/>
+          <p:nvPr/>
+        </p:nvSpPr>
+        <p:spPr>
+          <a:xfrm>
+            <a:off x="4584192" y="1801368"/>
+            <a:ext cx="2993136" cy="457200"/>
+          </a:xfrm>
+          <a:prstGeom prst="rect">
+            <a:avLst/>
+          </a:prstGeom>
+          <a:noFill/>
+        </p:spPr>
+        <p:txBody>
+          <a:bodyPr wrap="square" lIns="0" rIns="0" tIns="0" bIns="0">
+            <a:spAutoFit/>
+          </a:bodyPr>
+          <a:lstStyle/>
+          <a:p>
+            <a:pPr>
+              <a:lnSpc>
+                <a:spcPct val="110000"/>
+              </a:lnSpc>
+            </a:pPr>
+            <a:r>
+              <a:rPr sz="1300" b="1">
+                <a:solidFill>
+                  <a:srgbClr val="1A1A1A"/>
+                </a:solidFill>
+                <a:latin typeface="Arial"/>
+              </a:rPr>
+              <a:t>Refine, then keep the better verdict</a:t>
+            </a:r>
+          </a:p>
+        </p:txBody>
+      </p:sp>
+      <p:sp>
+        <p:nvSpPr>
+          <p:cNvPr id="32" name="p-b"/>
+          <p:cNvSpPr txBox="1"/>
+          <p:nvPr/>
+        </p:nvSpPr>
+        <p:spPr>
+          <a:xfrm>
+            <a:off x="4584192" y="2350008"/>
+            <a:ext cx="2993136" cy="1188719"/>
+          </a:xfrm>
+          <a:prstGeom prst="rect">
+            <a:avLst/>
+          </a:prstGeom>
+          <a:noFill/>
+        </p:spPr>
+        <p:txBody>
+          <a:bodyPr wrap="square" lIns="0" rIns="0" tIns="0" bIns="0" anchor="t">
+            <a:spAutoFit/>
+          </a:bodyPr>
+          <a:lstStyle/>
+          <a:p>
+            <a:pPr>
+              <a:lnSpc>
+                <a:spcPct val="125000"/>
+              </a:lnSpc>
+            </a:pPr>
+            <a:r>
+              <a:rPr sz="1100">
+                <a:solidFill>
+                  <a:srgbClr val="444444"/>
+                </a:solidFill>
+                <a:latin typeface="Arial"/>
+              </a:rPr>
+              <a:t>Verify the original and the refined claim, and keep the refinement only when it does not turn a decided verdict into UNDECIDED.</a:t>
+            </a:r>
+          </a:p>
+          <a:p>
+            <a:pPr>
+              <a:lnSpc>
+                <a:spcPct val="125000"/>
+              </a:lnSpc>
+              <a:spcBef>
+                <a:spcPts val="600"/>
+              </a:spcBef>
+            </a:pPr>
+            <a:r>
+              <a:rPr sz="1050">
+                <a:solidFill>
+                  <a:srgbClr val="767676"/>
+                </a:solidFill>
+                <a:latin typeface="Arial"/>
+              </a:rPr>
+              <a:t>Targets the central cost we measured: undecided 146 → 185, precision −0.077.</a:t>
+            </a:r>
+          </a:p>
+        </p:txBody>
+      </p:sp>
+      <p:sp>
+        <p:nvSpPr>
+          <p:cNvPr id="33" name="p-card"/>
+          <p:cNvSpPr/>
+          <p:nvPr/>
+        </p:nvSpPr>
+        <p:spPr>
+          <a:xfrm>
+            <a:off x="8107680" y="1600200"/>
+            <a:ext cx="3505200" cy="2103120"/>
+          </a:xfrm>
+          <a:prstGeom prst="rect">
+            <a:avLst/>
+          </a:prstGeom>
+          <a:solidFill>
+            <a:srgbClr val="FFFFFF"/>
+          </a:solidFill>
+          <a:ln w="9525">
+            <a:solidFill>
+              <a:srgbClr val="DCDCDC"/>
+            </a:solidFill>
+          </a:ln>
+          <a:effectLst/>
+        </p:spPr>
+        <p:style>
+          <a:lnRef idx="1">
+            <a:schemeClr val="accent1"/>
+          </a:lnRef>
+          <a:fillRef idx="3">
+            <a:schemeClr val="accent1"/>
+          </a:fillRef>
+          <a:effectRef idx="2">
+            <a:schemeClr val="accent1"/>
+          </a:effectRef>
+          <a:fontRef idx="minor">
+            <a:schemeClr val="lt1"/>
+          </a:fontRef>
+        </p:style>
+        <p:txBody>
+          <a:bodyPr rtlCol="0" anchor="ctr"/>
+          <a:lstStyle/>
+          <a:p/>
+        </p:txBody>
+      </p:sp>
+      <p:sp>
+        <p:nvSpPr>
+          <p:cNvPr id="34" name="p-h"/>
+          <p:cNvSpPr txBox="1"/>
+          <p:nvPr/>
+        </p:nvSpPr>
+        <p:spPr>
+          <a:xfrm>
+            <a:off x="8363712" y="1801368"/>
+            <a:ext cx="2993136" cy="457200"/>
+          </a:xfrm>
+          <a:prstGeom prst="rect">
+            <a:avLst/>
+          </a:prstGeom>
+          <a:noFill/>
+        </p:spPr>
+        <p:txBody>
+          <a:bodyPr wrap="square" lIns="0" rIns="0" tIns="0" bIns="0">
+            <a:spAutoFit/>
+          </a:bodyPr>
+          <a:lstStyle/>
+          <a:p>
+            <a:pPr>
+              <a:lnSpc>
+                <a:spcPct val="110000"/>
+              </a:lnSpc>
+            </a:pPr>
+            <a:r>
+              <a:rPr sz="1300" b="1">
+                <a:solidFill>
+                  <a:srgbClr val="1A1A1A"/>
+                </a:solidFill>
+                <a:latin typeface="Arial"/>
+              </a:rPr>
+              <a:t>Evidence-conditioned refinement</a:t>
+            </a:r>
+          </a:p>
+        </p:txBody>
+      </p:sp>
+      <p:sp>
+        <p:nvSpPr>
+          <p:cNvPr id="35" name="p-b"/>
+          <p:cNvSpPr txBox="1"/>
+          <p:nvPr/>
+        </p:nvSpPr>
+        <p:spPr>
+          <a:xfrm>
+            <a:off x="8363712" y="2350008"/>
+            <a:ext cx="2993136" cy="1188719"/>
+          </a:xfrm>
+          <a:prstGeom prst="rect">
+            <a:avLst/>
+          </a:prstGeom>
+          <a:noFill/>
+        </p:spPr>
+        <p:txBody>
+          <a:bodyPr wrap="square" lIns="0" rIns="0" tIns="0" bIns="0" anchor="t">
+            <a:spAutoFit/>
+          </a:bodyPr>
+          <a:lstStyle/>
+          <a:p>
+            <a:pPr>
+              <a:lnSpc>
+                <a:spcPct val="125000"/>
+              </a:lnSpc>
+            </a:pPr>
+            <a:r>
+              <a:rPr sz="1100">
+                <a:solidFill>
+                  <a:srgbClr val="444444"/>
+                </a:solidFill>
+                <a:latin typeface="Arial"/>
+              </a:rPr>
+              <a:t>Retrieve first, then rewrite the claim against the evidence that exists, so refinement produces checkable claims.</a:t>
+            </a:r>
+          </a:p>
+          <a:p>
+            <a:pPr>
+              <a:lnSpc>
+                <a:spcPct val="125000"/>
+              </a:lnSpc>
+              <a:spcBef>
+                <a:spcPts val="600"/>
+              </a:spcBef>
+            </a:pPr>
+            <a:r>
+              <a:rPr sz="1050">
+                <a:solidFill>
+                  <a:srgbClr val="767676"/>
+                </a:solidFill>
+                <a:latin typeface="Arial"/>
+              </a:rPr>
+              <a:t>Reverses the paper's order. Targets refined claims that no single Wikipedia sentence can support.</a:t>
+            </a:r>
+          </a:p>
+        </p:txBody>
+      </p:sp>
+      <p:sp>
+        <p:nvSpPr>
+          <p:cNvPr id="36" name="p-card"/>
+          <p:cNvSpPr/>
+          <p:nvPr/>
+        </p:nvSpPr>
+        <p:spPr>
+          <a:xfrm>
+            <a:off x="548640" y="3886200"/>
+            <a:ext cx="3505200" cy="2103120"/>
+          </a:xfrm>
+          <a:prstGeom prst="rect">
+            <a:avLst/>
+          </a:prstGeom>
+          <a:solidFill>
+            <a:srgbClr val="F4F4F4"/>
+          </a:solidFill>
+          <a:ln w="9525">
+            <a:solidFill>
+              <a:srgbClr val="F4F4F4"/>
+            </a:solidFill>
+          </a:ln>
+          <a:effectLst/>
+        </p:spPr>
+        <p:style>
+          <a:lnRef idx="1">
+            <a:schemeClr val="accent1"/>
+          </a:lnRef>
+          <a:fillRef idx="3">
+            <a:schemeClr val="accent1"/>
+          </a:fillRef>
+          <a:effectRef idx="2">
+            <a:schemeClr val="accent1"/>
+          </a:effectRef>
+          <a:fontRef idx="minor">
+            <a:schemeClr val="lt1"/>
+          </a:fontRef>
+        </p:style>
+        <p:txBody>
+          <a:bodyPr rtlCol="0" anchor="ctr"/>
+          <a:lstStyle/>
+          <a:p/>
+        </p:txBody>
+      </p:sp>
+      <p:sp>
+        <p:nvSpPr>
+          <p:cNvPr id="37" name="p-h"/>
+          <p:cNvSpPr txBox="1"/>
+          <p:nvPr/>
+        </p:nvSpPr>
+        <p:spPr>
+          <a:xfrm>
+            <a:off x="804672" y="4087368"/>
+            <a:ext cx="2993136" cy="457200"/>
+          </a:xfrm>
+          <a:prstGeom prst="rect">
+            <a:avLst/>
+          </a:prstGeom>
+          <a:noFill/>
+        </p:spPr>
+        <p:txBody>
+          <a:bodyPr wrap="square" lIns="0" rIns="0" tIns="0" bIns="0">
+            <a:spAutoFit/>
+          </a:bodyPr>
+          <a:lstStyle/>
+          <a:p>
+            <a:pPr>
+              <a:lnSpc>
+                <a:spcPct val="110000"/>
+              </a:lnSpc>
+            </a:pPr>
+            <a:r>
+              <a:rPr sz="1300" b="1">
+                <a:solidFill>
+                  <a:srgbClr val="1A1A1A"/>
+                </a:solidFill>
+                <a:latin typeface="Arial"/>
+              </a:rPr>
+              <a:t>Disagreement-gated escalation</a:t>
+            </a:r>
+          </a:p>
+        </p:txBody>
+      </p:sp>
+      <p:sp>
+        <p:nvSpPr>
+          <p:cNvPr id="38" name="p-b"/>
+          <p:cNvSpPr txBox="1"/>
+          <p:nvPr/>
+        </p:nvSpPr>
+        <p:spPr>
+          <a:xfrm>
+            <a:off x="804672" y="4636008"/>
+            <a:ext cx="2993136" cy="1188719"/>
+          </a:xfrm>
+          <a:prstGeom prst="rect">
+            <a:avLst/>
+          </a:prstGeom>
+          <a:noFill/>
+        </p:spPr>
+        <p:txBody>
+          <a:bodyPr wrap="square" lIns="0" rIns="0" tIns="0" bIns="0" anchor="t">
+            <a:spAutoFit/>
+          </a:bodyPr>
+          <a:lstStyle/>
+          <a:p>
+            <a:pPr>
+              <a:lnSpc>
+                <a:spcPct val="125000"/>
+              </a:lnSpc>
+            </a:pPr>
+            <a:r>
+              <a:rPr sz="1100">
+                <a:solidFill>
+                  <a:srgbClr val="444444"/>
+                </a:solidFill>
+                <a:latin typeface="Arial"/>
+              </a:rPr>
+              <a:t>Run the small judges first and send only the facts they disagree on to a larger model.</a:t>
+            </a:r>
+          </a:p>
+          <a:p>
+            <a:pPr>
+              <a:lnSpc>
+                <a:spcPct val="125000"/>
+              </a:lnSpc>
+              <a:spcBef>
+                <a:spcPts val="600"/>
+              </a:spcBef>
+            </a:pPr>
+            <a:r>
+              <a:rPr sz="1050">
+                <a:solidFill>
+                  <a:srgbClr val="767676"/>
+                </a:solidFill>
+                <a:latin typeface="Arial"/>
+              </a:rPr>
+              <a:t>Our data says the ensemble equalled Llama on relations at every size, so most second opinions are free to skip.</a:t>
+            </a:r>
+          </a:p>
+        </p:txBody>
+      </p:sp>
+      <p:sp>
+        <p:nvSpPr>
+          <p:cNvPr id="39" name="p-card"/>
+          <p:cNvSpPr/>
+          <p:nvPr/>
+        </p:nvSpPr>
+        <p:spPr>
+          <a:xfrm>
+            <a:off x="4328160" y="3886200"/>
+            <a:ext cx="3505200" cy="2103120"/>
+          </a:xfrm>
+          <a:prstGeom prst="rect">
+            <a:avLst/>
+          </a:prstGeom>
+          <a:solidFill>
+            <a:srgbClr val="F4F4F4"/>
+          </a:solidFill>
+          <a:ln w="9525">
+            <a:solidFill>
+              <a:srgbClr val="F4F4F4"/>
+            </a:solidFill>
+          </a:ln>
+          <a:effectLst/>
+        </p:spPr>
+        <p:style>
+          <a:lnRef idx="1">
+            <a:schemeClr val="accent1"/>
+          </a:lnRef>
+          <a:fillRef idx="3">
+            <a:schemeClr val="accent1"/>
+          </a:fillRef>
+          <a:effectRef idx="2">
+            <a:schemeClr val="accent1"/>
+          </a:effectRef>
+          <a:fontRef idx="minor">
+            <a:schemeClr val="lt1"/>
+          </a:fontRef>
+        </p:style>
+        <p:txBody>
+          <a:bodyPr rtlCol="0" anchor="ctr"/>
+          <a:lstStyle/>
+          <a:p/>
+        </p:txBody>
+      </p:sp>
+      <p:sp>
+        <p:nvSpPr>
+          <p:cNvPr id="40" name="p-edge"/>
+          <p:cNvSpPr/>
+          <p:nvPr/>
+        </p:nvSpPr>
+        <p:spPr>
+          <a:xfrm>
+            <a:off x="4328160" y="3886200"/>
+            <a:ext cx="29260" cy="2103120"/>
+          </a:xfrm>
+          <a:prstGeom prst="rect">
+            <a:avLst/>
+          </a:prstGeom>
+          <a:solidFill>
+            <a:srgbClr val="E90802"/>
+          </a:solidFill>
+          <a:ln w="3175">
+            <a:solidFill>
+              <a:srgbClr val="E90802"/>
+            </a:solidFill>
+          </a:ln>
+          <a:effectLst/>
+        </p:spPr>
+        <p:style>
+          <a:lnRef idx="1">
+            <a:schemeClr val="accent1"/>
+          </a:lnRef>
+          <a:fillRef idx="3">
+            <a:schemeClr val="accent1"/>
+          </a:fillRef>
+          <a:effectRef idx="2">
+            <a:schemeClr val="accent1"/>
+          </a:effectRef>
+          <a:fontRef idx="minor">
+            <a:schemeClr val="lt1"/>
+          </a:fontRef>
+        </p:style>
+        <p:txBody>
+          <a:bodyPr rtlCol="0" anchor="ctr"/>
+          <a:lstStyle/>
+          <a:p>
+            <a:pPr algn="ctr"/>
+          </a:p>
+        </p:txBody>
+      </p:sp>
+      <p:sp>
+        <p:nvSpPr>
+          <p:cNvPr id="41" name="p-h"/>
+          <p:cNvSpPr txBox="1"/>
+          <p:nvPr/>
+        </p:nvSpPr>
+        <p:spPr>
+          <a:xfrm>
+            <a:off x="4584192" y="4087368"/>
+            <a:ext cx="2993136" cy="457200"/>
+          </a:xfrm>
+          <a:prstGeom prst="rect">
+            <a:avLst/>
+          </a:prstGeom>
+          <a:noFill/>
+        </p:spPr>
+        <p:txBody>
+          <a:bodyPr wrap="square" lIns="0" rIns="0" tIns="0" bIns="0">
+            <a:spAutoFit/>
+          </a:bodyPr>
+          <a:lstStyle/>
+          <a:p>
+            <a:pPr>
+              <a:lnSpc>
+                <a:spcPct val="110000"/>
+              </a:lnSpc>
+            </a:pPr>
+            <a:r>
+              <a:rPr sz="1300" b="1">
+                <a:solidFill>
+                  <a:srgbClr val="E90802"/>
+                </a:solidFill>
+                <a:latin typeface="Arial"/>
+              </a:rPr>
+              <a:t>Judge-normalized reporting</a:t>
+            </a:r>
+          </a:p>
+        </p:txBody>
+      </p:sp>
+      <p:sp>
+        <p:nvSpPr>
+          <p:cNvPr id="42" name="p-b"/>
+          <p:cNvSpPr txBox="1"/>
+          <p:nvPr/>
+        </p:nvSpPr>
+        <p:spPr>
+          <a:xfrm>
+            <a:off x="4584192" y="4636008"/>
+            <a:ext cx="2993136" cy="1188719"/>
+          </a:xfrm>
+          <a:prstGeom prst="rect">
+            <a:avLst/>
+          </a:prstGeom>
+          <a:noFill/>
+        </p:spPr>
+        <p:txBody>
+          <a:bodyPr wrap="square" lIns="0" rIns="0" tIns="0" bIns="0" anchor="t">
+            <a:spAutoFit/>
+          </a:bodyPr>
+          <a:lstStyle/>
+          <a:p>
+            <a:pPr>
+              <a:lnSpc>
+                <a:spcPct val="125000"/>
+              </a:lnSpc>
+            </a:pPr>
+            <a:r>
+              <a:rPr sz="1100">
+                <a:solidFill>
+                  <a:srgbClr val="444444"/>
+                </a:solidFill>
+                <a:latin typeface="Arial"/>
+              </a:rPr>
+              <a:t>Calibrate every judge on one fixed annotated probe set and report the incomplete rate relative to that anchor.</a:t>
+            </a:r>
+          </a:p>
+          <a:p>
+            <a:pPr>
+              <a:lnSpc>
+                <a:spcPct val="125000"/>
+              </a:lnSpc>
+              <a:spcBef>
+                <a:spcPts val="600"/>
+              </a:spcBef>
+            </a:pPr>
+            <a:r>
+              <a:rPr sz="1050">
+                <a:solidFill>
+                  <a:srgbClr val="767676"/>
+                </a:solidFill>
+                <a:latin typeface="Arial"/>
+              </a:rPr>
+              <a:t>Makes 0.105 and 0.438 comparable instead of incommensurable. The proposal that generalises past this paper.</a:t>
+            </a:r>
+          </a:p>
+        </p:txBody>
+      </p:sp>
+      <p:sp>
+        <p:nvSpPr>
+          <p:cNvPr id="43" name="p-card"/>
+          <p:cNvSpPr/>
+          <p:nvPr/>
+        </p:nvSpPr>
+        <p:spPr>
+          <a:xfrm>
+            <a:off x="8107680" y="3886200"/>
+            <a:ext cx="3505200" cy="2103120"/>
+          </a:xfrm>
+          <a:prstGeom prst="rect">
+            <a:avLst/>
+          </a:prstGeom>
+          <a:solidFill>
+            <a:srgbClr val="F4F4F4"/>
+          </a:solidFill>
+          <a:ln w="9525">
+            <a:solidFill>
+              <a:srgbClr val="F4F4F4"/>
+            </a:solidFill>
+          </a:ln>
+          <a:effectLst/>
+        </p:spPr>
+        <p:style>
+          <a:lnRef idx="1">
+            <a:schemeClr val="accent1"/>
+          </a:lnRef>
+          <a:fillRef idx="3">
+            <a:schemeClr val="accent1"/>
+          </a:fillRef>
+          <a:effectRef idx="2">
+            <a:schemeClr val="accent1"/>
+          </a:effectRef>
+          <a:fontRef idx="minor">
+            <a:schemeClr val="lt1"/>
+          </a:fontRef>
+        </p:style>
+        <p:txBody>
+          <a:bodyPr rtlCol="0" anchor="ctr"/>
+          <a:lstStyle/>
+          <a:p/>
+        </p:txBody>
+      </p:sp>
+      <p:sp>
+        <p:nvSpPr>
+          <p:cNvPr id="44" name="p-h"/>
+          <p:cNvSpPr txBox="1"/>
+          <p:nvPr/>
+        </p:nvSpPr>
+        <p:spPr>
+          <a:xfrm>
+            <a:off x="8363712" y="4087368"/>
+            <a:ext cx="2993136" cy="457200"/>
+          </a:xfrm>
+          <a:prstGeom prst="rect">
+            <a:avLst/>
+          </a:prstGeom>
+          <a:noFill/>
+        </p:spPr>
+        <p:txBody>
+          <a:bodyPr wrap="square" lIns="0" rIns="0" tIns="0" bIns="0">
+            <a:spAutoFit/>
+          </a:bodyPr>
+          <a:lstStyle/>
+          <a:p>
+            <a:pPr>
+              <a:lnSpc>
+                <a:spcPct val="110000"/>
+              </a:lnSpc>
+            </a:pPr>
+            <a:r>
+              <a:rPr sz="1300" b="1">
+                <a:solidFill>
+                  <a:srgbClr val="1A1A1A"/>
+                </a:solidFill>
+                <a:latin typeface="Arial"/>
+              </a:rPr>
+              <a:t>Semantic word mapping</a:t>
+            </a:r>
+          </a:p>
+        </p:txBody>
+      </p:sp>
+      <p:sp>
+        <p:nvSpPr>
+          <p:cNvPr id="45" name="p-b"/>
+          <p:cNvSpPr txBox="1"/>
+          <p:nvPr/>
+        </p:nvSpPr>
+        <p:spPr>
+          <a:xfrm>
+            <a:off x="8363712" y="4636008"/>
+            <a:ext cx="2993136" cy="1188719"/>
+          </a:xfrm>
+          <a:prstGeom prst="rect">
+            <a:avLst/>
+          </a:prstGeom>
+          <a:noFill/>
+        </p:spPr>
+        <p:txBody>
+          <a:bodyPr wrap="square" lIns="0" rIns="0" tIns="0" bIns="0" anchor="t">
+            <a:spAutoFit/>
+          </a:bodyPr>
+          <a:lstStyle/>
+          <a:p>
+            <a:pPr>
+              <a:lnSpc>
+                <a:spcPct val="125000"/>
+              </a:lnSpc>
+            </a:pPr>
+            <a:r>
+              <a:rPr sz="1100">
+                <a:solidFill>
+                  <a:srgbClr val="444444"/>
+                </a:solidFill>
+                <a:latin typeface="Arial"/>
+              </a:rPr>
+              <a:t>Replace the longest-common-substring coverage test with embedding coverage over the response.</a:t>
+            </a:r>
+          </a:p>
+          <a:p>
+            <a:pPr>
+              <a:lnSpc>
+                <a:spcPct val="125000"/>
+              </a:lnSpc>
+              <a:spcBef>
+                <a:spcPts val="600"/>
+              </a:spcBef>
+            </a:pPr>
+            <a:r>
+              <a:rPr sz="1050">
+                <a:solidFill>
+                  <a:srgbClr val="767676"/>
+                </a:solidFill>
+                <a:latin typeface="Arial"/>
+              </a:rPr>
+              <a:t>Targets a lexical blind spot: a paraphrased relation currently counts as uncovered and is re-added as a fact.</a:t>
+            </a:r>
           </a:p>
         </p:txBody>
       </p:sp>
@@ -21278,7 +20564,7 @@
           <p:nvPr>
             <p:extLst>
               <p:ext uri="{D42A27DB-BD31-4B8C-83A1-F6EECF244321}">
-                <p14:modId xmlns:p14="http://schemas.microsoft.com/office/powerpoint/2010/main" val="3244196388"/>
+                <p14:modId xmlns:p14="http://schemas.microsoft.com/office/powerpoint/2010/main" val="3753226532"/>
               </p:ext>
             </p:extLst>
           </p:nvPr>
@@ -21468,7 +20754,7 @@
                           <a:ea typeface="Arial" pitchFamily="34" charset="-122"/>
                           <a:cs typeface="Arial" pitchFamily="34" charset="-120"/>
                         </a:rPr>
-                        <a:t>VERIFACT-Lite</a:t>
+                        <a:t>Reimplementation </a:t>
                       </a:r>
                       <a:endParaRPr lang="en-US" sz="1250" dirty="0">
                         <a:latin typeface="Arial" charset="0"/>
@@ -24156,7 +23442,7 @@
                   <a:srgbClr val="E90802"/>
                 </a:solidFill>
               </a:rPr>
-              <a:t>VERIFACT-Lite — with refinement</a:t>
+              <a:t>Reimplemented Model — with refinement</a:t>
             </a:r>
             <a:endParaRPr lang="en-US" sz="1450" dirty="0"/>
           </a:p>
@@ -24751,7 +24037,29 @@
                 <a:ea typeface="Arial" pitchFamily="34" charset="-122"/>
                 <a:cs typeface="Arial" pitchFamily="34" charset="-120"/>
               </a:rPr>
-              <a:t>Baseline against VERIFACT-Lite, laptop run, Qwen2.5-3B judges</a:t>
+              <a:t>Baseline against </a:t>
+            </a:r>
+            <a:r>
+              <a:rPr lang="en-US" sz="1350" dirty="0" err="1">
+                <a:solidFill>
+                  <a:srgbClr val="767676"/>
+                </a:solidFill>
+                <a:latin typeface="Arial" pitchFamily="34" charset="0"/>
+                <a:ea typeface="Arial" pitchFamily="34" charset="-122"/>
+                <a:cs typeface="Arial" pitchFamily="34" charset="-120"/>
+              </a:rPr>
+              <a:t>Reimplemetation</a:t>
+            </a:r>
+            <a:r>
+              <a:rPr lang="en-US" sz="1350" dirty="0">
+                <a:solidFill>
+                  <a:srgbClr val="767676"/>
+                </a:solidFill>
+                <a:latin typeface="Arial" pitchFamily="34" charset="0"/>
+                <a:ea typeface="Arial" pitchFamily="34" charset="-122"/>
+                <a:cs typeface="Arial" pitchFamily="34" charset="-120"/>
+              </a:rPr>
+              <a:t>, laptop run, Qwen2.5-3B judges</a:t>
             </a:r>
             <a:endParaRPr lang="en-US" sz="1350" dirty="0"/>
           </a:p>

</xml_diff>